<commit_message>
Starting point for Dojo 1
</commit_message>
<xml_diff>
--- a/ki-thementag-dojos.pptx
+++ b/ki-thementag-dojos.pptx
@@ -5,13 +5,14 @@
     <p:sldMasterId id="2147483661" r:id="rId6"/>
   </p:sldMasterIdLst>
   <p:notesMasterIdLst>
-    <p:notesMasterId r:id="rId8"/>
+    <p:notesMasterId r:id="rId9"/>
   </p:notesMasterIdLst>
   <p:handoutMasterIdLst>
-    <p:handoutMasterId r:id="rId9"/>
+    <p:handoutMasterId r:id="rId10"/>
   </p:handoutMasterIdLst>
   <p:sldIdLst>
     <p:sldId id="1329" r:id="rId7"/>
+    <p:sldId id="1331" r:id="rId8"/>
   </p:sldIdLst>
   <p:sldSz cx="12192000" cy="6858000"/>
   <p:notesSz cx="6858000" cy="9144000"/>
@@ -12875,214 +12876,235 @@
           </a:p>
         </p:txBody>
       </p:sp>
-      <p:sp>
-        <p:nvSpPr>
-          <p:cNvPr id="14" name="Inhaltsplatzhalter 4">
-            <a:extLst>
-              <a:ext uri="{FF2B5EF4-FFF2-40B4-BE49-F238E27FC236}">
-                <a16:creationId xmlns:a16="http://schemas.microsoft.com/office/drawing/2014/main" id="{E7A0ACCC-7805-73F9-B351-8863AA5B80DB}"/>
-              </a:ext>
-            </a:extLst>
-          </p:cNvPr>
-          <p:cNvSpPr txBox="1">
-            <a:spLocks/>
-          </p:cNvSpPr>
+      <p:grpSp>
+        <p:nvGrpSpPr>
+          <p:cNvPr id="9" name="Gruppieren 8">
+            <a:extLst>
+              <a:ext uri="{FF2B5EF4-FFF2-40B4-BE49-F238E27FC236}">
+                <a16:creationId xmlns:a16="http://schemas.microsoft.com/office/drawing/2014/main" id="{B3088B3B-64E7-C6F7-B55A-998DE2895A58}"/>
+              </a:ext>
+            </a:extLst>
+          </p:cNvPr>
+          <p:cNvGrpSpPr/>
           <p:nvPr/>
-        </p:nvSpPr>
-        <p:spPr>
-          <a:xfrm>
-            <a:off x="563628" y="5017454"/>
-            <a:ext cx="5616624" cy="1363873"/>
-          </a:xfrm>
-          <a:prstGeom prst="rect">
-            <a:avLst/>
-          </a:prstGeom>
-        </p:spPr>
-        <p:txBody>
-          <a:bodyPr vert="horz" lIns="91440" tIns="45720" rIns="91440" bIns="45720" rtlCol="0">
-            <a:normAutofit/>
-          </a:bodyPr>
-          <a:lstStyle>
-            <a:lvl1pPr marL="342900" indent="-342900" defTabSz="457200">
-              <a:spcBef>
-                <a:spcPts val="600"/>
-              </a:spcBef>
-              <a:buClr>
-                <a:schemeClr val="accent1"/>
-              </a:buClr>
-              <a:buFont typeface="Wingdings" panose="05000000000000000000" pitchFamily="2" charset="2"/>
-              <a:buChar char="§"/>
-              <a:defRPr>
-                <a:latin typeface="Open Sans Light" panose="020B0306030504020204" pitchFamily="34" charset="0"/>
-                <a:ea typeface="Open Sans Light" panose="020B0306030504020204" pitchFamily="34" charset="0"/>
-                <a:cs typeface="Open Sans Light" panose="020B0306030504020204" pitchFamily="34" charset="0"/>
-              </a:defRPr>
-            </a:lvl1pPr>
-            <a:lvl2pPr marL="742950" indent="-285750" defTabSz="457200">
-              <a:spcBef>
-                <a:spcPts val="600"/>
-              </a:spcBef>
-              <a:buClr>
-                <a:schemeClr val="accent1"/>
-              </a:buClr>
-              <a:buFont typeface="Wingdings" panose="05000000000000000000" pitchFamily="2" charset="2"/>
-              <a:buChar char="§"/>
-              <a:defRPr sz="2000">
-                <a:latin typeface="Open Sans Light" panose="020B0306030504020204" pitchFamily="34" charset="0"/>
-                <a:ea typeface="Open Sans Light" panose="020B0306030504020204" pitchFamily="34" charset="0"/>
-                <a:cs typeface="Open Sans Light" panose="020B0306030504020204" pitchFamily="34" charset="0"/>
-              </a:defRPr>
-            </a:lvl2pPr>
-            <a:lvl3pPr marL="1143000" indent="-228600" defTabSz="457200">
-              <a:spcBef>
-                <a:spcPts val="600"/>
-              </a:spcBef>
-              <a:buClr>
-                <a:schemeClr val="accent1"/>
-              </a:buClr>
-              <a:buFont typeface="Wingdings" panose="05000000000000000000" pitchFamily="2" charset="2"/>
-              <a:buChar char="§"/>
-              <a:defRPr sz="1600">
-                <a:latin typeface="Open Sans Light" panose="020B0306030504020204" pitchFamily="34" charset="0"/>
-                <a:ea typeface="Open Sans Light" panose="020B0306030504020204" pitchFamily="34" charset="0"/>
-                <a:cs typeface="Open Sans Light" panose="020B0306030504020204" pitchFamily="34" charset="0"/>
-              </a:defRPr>
-            </a:lvl3pPr>
-            <a:lvl4pPr marL="1600200" indent="-228600" defTabSz="457200">
-              <a:spcBef>
-                <a:spcPts val="600"/>
-              </a:spcBef>
-              <a:buClr>
-                <a:schemeClr val="accent1"/>
-              </a:buClr>
-              <a:buFont typeface="Symbol" panose="05050102010706020507" pitchFamily="18" charset="2"/>
-              <a:buChar char="-"/>
-              <a:defRPr sz="1600">
-                <a:latin typeface="Open Sans Light" panose="020B0306030504020204" pitchFamily="34" charset="0"/>
-                <a:ea typeface="Open Sans Light" panose="020B0306030504020204" pitchFamily="34" charset="0"/>
-                <a:cs typeface="Open Sans Light" panose="020B0306030504020204" pitchFamily="34" charset="0"/>
-              </a:defRPr>
-            </a:lvl4pPr>
-            <a:lvl5pPr marL="2057400" indent="-228600" defTabSz="457200">
-              <a:spcBef>
-                <a:spcPts val="600"/>
-              </a:spcBef>
-              <a:buClr>
-                <a:schemeClr val="accent1"/>
-              </a:buClr>
-              <a:buFont typeface="Symbol" panose="05050102010706020507" pitchFamily="18" charset="2"/>
-              <a:buChar char="-"/>
-              <a:defRPr sz="1200">
-                <a:latin typeface="Open Sans Light" panose="020B0306030504020204" pitchFamily="34" charset="0"/>
-                <a:ea typeface="Open Sans Light" panose="020B0306030504020204" pitchFamily="34" charset="0"/>
-                <a:cs typeface="Open Sans Light" panose="020B0306030504020204" pitchFamily="34" charset="0"/>
-              </a:defRPr>
-            </a:lvl5pPr>
-            <a:lvl6pPr marL="2514600" indent="-228600" defTabSz="457200">
-              <a:spcBef>
-                <a:spcPct val="20000"/>
-              </a:spcBef>
-              <a:buFont typeface="Arial"/>
-              <a:buChar char="•"/>
-              <a:defRPr sz="2000"/>
-            </a:lvl6pPr>
-            <a:lvl7pPr marL="2971800" indent="-228600" defTabSz="457200">
-              <a:spcBef>
-                <a:spcPct val="20000"/>
-              </a:spcBef>
-              <a:buFont typeface="Arial"/>
-              <a:buChar char="•"/>
-              <a:defRPr sz="2000"/>
-            </a:lvl7pPr>
-            <a:lvl8pPr marL="3429000" indent="-228600" defTabSz="457200">
-              <a:spcBef>
-                <a:spcPct val="20000"/>
-              </a:spcBef>
-              <a:buFont typeface="Arial"/>
-              <a:buChar char="•"/>
-              <a:defRPr sz="2000"/>
-            </a:lvl8pPr>
-            <a:lvl9pPr marL="3886200" indent="-228600" defTabSz="457200">
-              <a:spcBef>
-                <a:spcPct val="20000"/>
-              </a:spcBef>
-              <a:buFont typeface="Arial"/>
-              <a:buChar char="•"/>
-              <a:defRPr sz="2000"/>
-            </a:lvl9pPr>
-          </a:lstStyle>
-          <a:p>
-            <a:r>
-              <a:rPr lang="de-DE" dirty="0" err="1"/>
-              <a:t>Refactoring</a:t>
-            </a:r>
-            <a:endParaRPr lang="de-DE" dirty="0"/>
-          </a:p>
-          <a:p>
-            <a:r>
-              <a:rPr lang="de-DE" dirty="0"/>
-              <a:t>Aufräumen des </a:t>
-            </a:r>
-            <a:r>
-              <a:rPr lang="de-DE" dirty="0" err="1"/>
-              <a:t>Spagetticodes</a:t>
-            </a:r>
-            <a:r>
-              <a:rPr lang="de-DE" dirty="0"/>
-              <a:t> mit </a:t>
-            </a:r>
-            <a:r>
-              <a:rPr lang="de-DE" dirty="0" err="1"/>
-              <a:t>Junie</a:t>
-            </a:r>
-            <a:r>
-              <a:rPr lang="de-DE" dirty="0"/>
-              <a:t> Chat</a:t>
-            </a:r>
-          </a:p>
-          <a:p>
-            <a:r>
-              <a:rPr lang="de-DE" dirty="0"/>
-              <a:t>Ggf. parallel mit H.I.</a:t>
-            </a:r>
-          </a:p>
-        </p:txBody>
-      </p:sp>
-      <p:sp>
-        <p:nvSpPr>
-          <p:cNvPr id="17" name="Textfeld 16">
-            <a:extLst>
-              <a:ext uri="{FF2B5EF4-FFF2-40B4-BE49-F238E27FC236}">
-                <a16:creationId xmlns:a16="http://schemas.microsoft.com/office/drawing/2014/main" id="{4CC1568A-F8C6-CD98-2159-5A7A4A0D0068}"/>
-              </a:ext>
-            </a:extLst>
-          </p:cNvPr>
-          <p:cNvSpPr txBox="1"/>
-          <p:nvPr/>
-        </p:nvSpPr>
-        <p:spPr>
+        </p:nvGrpSpPr>
+        <p:grpSpPr>
           <a:xfrm>
             <a:off x="473468" y="4606347"/>
-            <a:ext cx="1499128" cy="461665"/>
-          </a:xfrm>
-          <a:prstGeom prst="rect">
-            <a:avLst/>
-          </a:prstGeom>
-          <a:noFill/>
-        </p:spPr>
-        <p:txBody>
-          <a:bodyPr wrap="none" rtlCol="0">
-            <a:spAutoFit/>
-          </a:bodyPr>
-          <a:lstStyle/>
-          <a:p>
-            <a:r>
-              <a:rPr lang="de-DE" sz="2400" b="1" dirty="0"/>
-              <a:t>2. Stunde</a:t>
-            </a:r>
-          </a:p>
-        </p:txBody>
-      </p:sp>
+            <a:ext cx="5706784" cy="1774980"/>
+            <a:chOff x="473468" y="4606347"/>
+            <a:chExt cx="5706784" cy="1774980"/>
+          </a:xfrm>
+        </p:grpSpPr>
+        <p:sp>
+          <p:nvSpPr>
+            <p:cNvPr id="14" name="Inhaltsplatzhalter 4">
+              <a:extLst>
+                <a:ext uri="{FF2B5EF4-FFF2-40B4-BE49-F238E27FC236}">
+                  <a16:creationId xmlns:a16="http://schemas.microsoft.com/office/drawing/2014/main" id="{E7A0ACCC-7805-73F9-B351-8863AA5B80DB}"/>
+                </a:ext>
+              </a:extLst>
+            </p:cNvPr>
+            <p:cNvSpPr txBox="1">
+              <a:spLocks/>
+            </p:cNvSpPr>
+            <p:nvPr/>
+          </p:nvSpPr>
+          <p:spPr>
+            <a:xfrm>
+              <a:off x="563628" y="5017454"/>
+              <a:ext cx="5616624" cy="1363873"/>
+            </a:xfrm>
+            <a:prstGeom prst="rect">
+              <a:avLst/>
+            </a:prstGeom>
+          </p:spPr>
+          <p:txBody>
+            <a:bodyPr vert="horz" lIns="91440" tIns="45720" rIns="91440" bIns="45720" rtlCol="0">
+              <a:normAutofit/>
+            </a:bodyPr>
+            <a:lstStyle>
+              <a:lvl1pPr marL="342900" indent="-342900" defTabSz="457200">
+                <a:spcBef>
+                  <a:spcPts val="600"/>
+                </a:spcBef>
+                <a:buClr>
+                  <a:schemeClr val="accent1"/>
+                </a:buClr>
+                <a:buFont typeface="Wingdings" panose="05000000000000000000" pitchFamily="2" charset="2"/>
+                <a:buChar char="§"/>
+                <a:defRPr>
+                  <a:latin typeface="Open Sans Light" panose="020B0306030504020204" pitchFamily="34" charset="0"/>
+                  <a:ea typeface="Open Sans Light" panose="020B0306030504020204" pitchFamily="34" charset="0"/>
+                  <a:cs typeface="Open Sans Light" panose="020B0306030504020204" pitchFamily="34" charset="0"/>
+                </a:defRPr>
+              </a:lvl1pPr>
+              <a:lvl2pPr marL="742950" indent="-285750" defTabSz="457200">
+                <a:spcBef>
+                  <a:spcPts val="600"/>
+                </a:spcBef>
+                <a:buClr>
+                  <a:schemeClr val="accent1"/>
+                </a:buClr>
+                <a:buFont typeface="Wingdings" panose="05000000000000000000" pitchFamily="2" charset="2"/>
+                <a:buChar char="§"/>
+                <a:defRPr sz="2000">
+                  <a:latin typeface="Open Sans Light" panose="020B0306030504020204" pitchFamily="34" charset="0"/>
+                  <a:ea typeface="Open Sans Light" panose="020B0306030504020204" pitchFamily="34" charset="0"/>
+                  <a:cs typeface="Open Sans Light" panose="020B0306030504020204" pitchFamily="34" charset="0"/>
+                </a:defRPr>
+              </a:lvl2pPr>
+              <a:lvl3pPr marL="1143000" indent="-228600" defTabSz="457200">
+                <a:spcBef>
+                  <a:spcPts val="600"/>
+                </a:spcBef>
+                <a:buClr>
+                  <a:schemeClr val="accent1"/>
+                </a:buClr>
+                <a:buFont typeface="Wingdings" panose="05000000000000000000" pitchFamily="2" charset="2"/>
+                <a:buChar char="§"/>
+                <a:defRPr sz="1600">
+                  <a:latin typeface="Open Sans Light" panose="020B0306030504020204" pitchFamily="34" charset="0"/>
+                  <a:ea typeface="Open Sans Light" panose="020B0306030504020204" pitchFamily="34" charset="0"/>
+                  <a:cs typeface="Open Sans Light" panose="020B0306030504020204" pitchFamily="34" charset="0"/>
+                </a:defRPr>
+              </a:lvl3pPr>
+              <a:lvl4pPr marL="1600200" indent="-228600" defTabSz="457200">
+                <a:spcBef>
+                  <a:spcPts val="600"/>
+                </a:spcBef>
+                <a:buClr>
+                  <a:schemeClr val="accent1"/>
+                </a:buClr>
+                <a:buFont typeface="Symbol" panose="05050102010706020507" pitchFamily="18" charset="2"/>
+                <a:buChar char="-"/>
+                <a:defRPr sz="1600">
+                  <a:latin typeface="Open Sans Light" panose="020B0306030504020204" pitchFamily="34" charset="0"/>
+                  <a:ea typeface="Open Sans Light" panose="020B0306030504020204" pitchFamily="34" charset="0"/>
+                  <a:cs typeface="Open Sans Light" panose="020B0306030504020204" pitchFamily="34" charset="0"/>
+                </a:defRPr>
+              </a:lvl4pPr>
+              <a:lvl5pPr marL="2057400" indent="-228600" defTabSz="457200">
+                <a:spcBef>
+                  <a:spcPts val="600"/>
+                </a:spcBef>
+                <a:buClr>
+                  <a:schemeClr val="accent1"/>
+                </a:buClr>
+                <a:buFont typeface="Symbol" panose="05050102010706020507" pitchFamily="18" charset="2"/>
+                <a:buChar char="-"/>
+                <a:defRPr sz="1200">
+                  <a:latin typeface="Open Sans Light" panose="020B0306030504020204" pitchFamily="34" charset="0"/>
+                  <a:ea typeface="Open Sans Light" panose="020B0306030504020204" pitchFamily="34" charset="0"/>
+                  <a:cs typeface="Open Sans Light" panose="020B0306030504020204" pitchFamily="34" charset="0"/>
+                </a:defRPr>
+              </a:lvl5pPr>
+              <a:lvl6pPr marL="2514600" indent="-228600" defTabSz="457200">
+                <a:spcBef>
+                  <a:spcPct val="20000"/>
+                </a:spcBef>
+                <a:buFont typeface="Arial"/>
+                <a:buChar char="•"/>
+                <a:defRPr sz="2000"/>
+              </a:lvl6pPr>
+              <a:lvl7pPr marL="2971800" indent="-228600" defTabSz="457200">
+                <a:spcBef>
+                  <a:spcPct val="20000"/>
+                </a:spcBef>
+                <a:buFont typeface="Arial"/>
+                <a:buChar char="•"/>
+                <a:defRPr sz="2000"/>
+              </a:lvl7pPr>
+              <a:lvl8pPr marL="3429000" indent="-228600" defTabSz="457200">
+                <a:spcBef>
+                  <a:spcPct val="20000"/>
+                </a:spcBef>
+                <a:buFont typeface="Arial"/>
+                <a:buChar char="•"/>
+                <a:defRPr sz="2000"/>
+              </a:lvl8pPr>
+              <a:lvl9pPr marL="3886200" indent="-228600" defTabSz="457200">
+                <a:spcBef>
+                  <a:spcPct val="20000"/>
+                </a:spcBef>
+                <a:buFont typeface="Arial"/>
+                <a:buChar char="•"/>
+                <a:defRPr sz="2000"/>
+              </a:lvl9pPr>
+            </a:lstStyle>
+            <a:p>
+              <a:r>
+                <a:rPr lang="de-DE" dirty="0" err="1"/>
+                <a:t>Refactoring</a:t>
+              </a:r>
+              <a:endParaRPr lang="de-DE" dirty="0"/>
+            </a:p>
+            <a:p>
+              <a:r>
+                <a:rPr lang="de-DE" dirty="0"/>
+                <a:t>Aufräumen des </a:t>
+              </a:r>
+              <a:r>
+                <a:rPr lang="de-DE" dirty="0" err="1"/>
+                <a:t>Spagetticodes</a:t>
+              </a:r>
+              <a:r>
+                <a:rPr lang="de-DE" dirty="0"/>
+                <a:t> mit </a:t>
+              </a:r>
+              <a:r>
+                <a:rPr lang="de-DE" dirty="0" err="1"/>
+                <a:t>Junie</a:t>
+              </a:r>
+              <a:r>
+                <a:rPr lang="de-DE" dirty="0"/>
+                <a:t> Chat</a:t>
+              </a:r>
+            </a:p>
+            <a:p>
+              <a:r>
+                <a:rPr lang="de-DE" dirty="0"/>
+                <a:t>Ggf. parallel mit H.I.</a:t>
+              </a:r>
+            </a:p>
+          </p:txBody>
+        </p:sp>
+        <p:sp>
+          <p:nvSpPr>
+            <p:cNvPr id="17" name="Textfeld 16">
+              <a:extLst>
+                <a:ext uri="{FF2B5EF4-FFF2-40B4-BE49-F238E27FC236}">
+                  <a16:creationId xmlns:a16="http://schemas.microsoft.com/office/drawing/2014/main" id="{4CC1568A-F8C6-CD98-2159-5A7A4A0D0068}"/>
+                </a:ext>
+              </a:extLst>
+            </p:cNvPr>
+            <p:cNvSpPr txBox="1"/>
+            <p:nvPr/>
+          </p:nvSpPr>
+          <p:spPr>
+            <a:xfrm>
+              <a:off x="473468" y="4606347"/>
+              <a:ext cx="1499128" cy="461665"/>
+            </a:xfrm>
+            <a:prstGeom prst="rect">
+              <a:avLst/>
+            </a:prstGeom>
+            <a:noFill/>
+          </p:spPr>
+          <p:txBody>
+            <a:bodyPr wrap="none" rtlCol="0">
+              <a:spAutoFit/>
+            </a:bodyPr>
+            <a:lstStyle/>
+            <a:p>
+              <a:r>
+                <a:rPr lang="de-DE" sz="2400" b="1" dirty="0"/>
+                <a:t>2. Stunde</a:t>
+              </a:r>
+            </a:p>
+          </p:txBody>
+        </p:sp>
+      </p:grpSp>
       <p:sp>
         <p:nvSpPr>
           <p:cNvPr id="27" name="Inhaltsplatzhalter 4">
@@ -13483,6 +13505,2520 @@
   <p:clrMapOvr>
     <a:masterClrMapping/>
   </p:clrMapOvr>
+  <p:timing>
+    <p:tnLst>
+      <p:par>
+        <p:cTn id="1" dur="indefinite" restart="never" nodeType="tmRoot">
+          <p:childTnLst>
+            <p:seq concurrent="1" nextAc="seek">
+              <p:cTn id="2" dur="indefinite" nodeType="mainSeq">
+                <p:childTnLst>
+                  <p:par>
+                    <p:cTn id="3" fill="hold">
+                      <p:stCondLst>
+                        <p:cond delay="indefinite"/>
+                      </p:stCondLst>
+                      <p:childTnLst>
+                        <p:par>
+                          <p:cTn id="4" fill="hold">
+                            <p:stCondLst>
+                              <p:cond delay="0"/>
+                            </p:stCondLst>
+                            <p:childTnLst>
+                              <p:par>
+                                <p:cTn id="5" presetID="1" presetClass="entr" presetSubtype="0" fill="hold" grpId="0" nodeType="clickEffect">
+                                  <p:stCondLst>
+                                    <p:cond delay="0"/>
+                                  </p:stCondLst>
+                                  <p:childTnLst>
+                                    <p:set>
+                                      <p:cBhvr>
+                                        <p:cTn id="6" dur="1" fill="hold">
+                                          <p:stCondLst>
+                                            <p:cond delay="0"/>
+                                          </p:stCondLst>
+                                        </p:cTn>
+                                        <p:tgtEl>
+                                          <p:spTgt spid="35"/>
+                                        </p:tgtEl>
+                                        <p:attrNameLst>
+                                          <p:attrName>style.visibility</p:attrName>
+                                        </p:attrNameLst>
+                                      </p:cBhvr>
+                                      <p:to>
+                                        <p:strVal val="visible"/>
+                                      </p:to>
+                                    </p:set>
+                                  </p:childTnLst>
+                                </p:cTn>
+                              </p:par>
+                              <p:par>
+                                <p:cTn id="7" presetID="1" presetClass="entr" presetSubtype="0" fill="hold" grpId="0" nodeType="withEffect">
+                                  <p:stCondLst>
+                                    <p:cond delay="0"/>
+                                  </p:stCondLst>
+                                  <p:childTnLst>
+                                    <p:set>
+                                      <p:cBhvr>
+                                        <p:cTn id="8" dur="1" fill="hold">
+                                          <p:stCondLst>
+                                            <p:cond delay="0"/>
+                                          </p:stCondLst>
+                                        </p:cTn>
+                                        <p:tgtEl>
+                                          <p:spTgt spid="8"/>
+                                        </p:tgtEl>
+                                        <p:attrNameLst>
+                                          <p:attrName>style.visibility</p:attrName>
+                                        </p:attrNameLst>
+                                      </p:cBhvr>
+                                      <p:to>
+                                        <p:strVal val="visible"/>
+                                      </p:to>
+                                    </p:set>
+                                  </p:childTnLst>
+                                </p:cTn>
+                              </p:par>
+                              <p:par>
+                                <p:cTn id="9" presetID="1" presetClass="entr" presetSubtype="0" fill="hold" grpId="0" nodeType="withEffect">
+                                  <p:stCondLst>
+                                    <p:cond delay="0"/>
+                                  </p:stCondLst>
+                                  <p:childTnLst>
+                                    <p:set>
+                                      <p:cBhvr>
+                                        <p:cTn id="10" dur="1" fill="hold">
+                                          <p:stCondLst>
+                                            <p:cond delay="0"/>
+                                          </p:stCondLst>
+                                        </p:cTn>
+                                        <p:tgtEl>
+                                          <p:spTgt spid="11"/>
+                                        </p:tgtEl>
+                                        <p:attrNameLst>
+                                          <p:attrName>style.visibility</p:attrName>
+                                        </p:attrNameLst>
+                                      </p:cBhvr>
+                                      <p:to>
+                                        <p:strVal val="visible"/>
+                                      </p:to>
+                                    </p:set>
+                                  </p:childTnLst>
+                                </p:cTn>
+                              </p:par>
+                              <p:par>
+                                <p:cTn id="11" presetID="1" presetClass="entr" presetSubtype="0" fill="hold" grpId="0" nodeType="withEffect">
+                                  <p:stCondLst>
+                                    <p:cond delay="0"/>
+                                  </p:stCondLst>
+                                  <p:childTnLst>
+                                    <p:set>
+                                      <p:cBhvr>
+                                        <p:cTn id="12" dur="1" fill="hold">
+                                          <p:stCondLst>
+                                            <p:cond delay="0"/>
+                                          </p:stCondLst>
+                                        </p:cTn>
+                                        <p:tgtEl>
+                                          <p:spTgt spid="5">
+                                            <p:txEl>
+                                              <p:pRg st="0" end="0"/>
+                                            </p:txEl>
+                                          </p:spTgt>
+                                        </p:tgtEl>
+                                        <p:attrNameLst>
+                                          <p:attrName>style.visibility</p:attrName>
+                                        </p:attrNameLst>
+                                      </p:cBhvr>
+                                      <p:to>
+                                        <p:strVal val="visible"/>
+                                      </p:to>
+                                    </p:set>
+                                  </p:childTnLst>
+                                </p:cTn>
+                              </p:par>
+                              <p:par>
+                                <p:cTn id="13" presetID="1" presetClass="entr" presetSubtype="0" fill="hold" grpId="0" nodeType="withEffect">
+                                  <p:stCondLst>
+                                    <p:cond delay="0"/>
+                                  </p:stCondLst>
+                                  <p:childTnLst>
+                                    <p:set>
+                                      <p:cBhvr>
+                                        <p:cTn id="14" dur="1" fill="hold">
+                                          <p:stCondLst>
+                                            <p:cond delay="0"/>
+                                          </p:stCondLst>
+                                        </p:cTn>
+                                        <p:tgtEl>
+                                          <p:spTgt spid="5">
+                                            <p:txEl>
+                                              <p:pRg st="1" end="1"/>
+                                            </p:txEl>
+                                          </p:spTgt>
+                                        </p:tgtEl>
+                                        <p:attrNameLst>
+                                          <p:attrName>style.visibility</p:attrName>
+                                        </p:attrNameLst>
+                                      </p:cBhvr>
+                                      <p:to>
+                                        <p:strVal val="visible"/>
+                                      </p:to>
+                                    </p:set>
+                                  </p:childTnLst>
+                                </p:cTn>
+                              </p:par>
+                              <p:par>
+                                <p:cTn id="15" presetID="1" presetClass="entr" presetSubtype="0" fill="hold" grpId="0" nodeType="withEffect">
+                                  <p:stCondLst>
+                                    <p:cond delay="0"/>
+                                  </p:stCondLst>
+                                  <p:childTnLst>
+                                    <p:set>
+                                      <p:cBhvr>
+                                        <p:cTn id="16" dur="1" fill="hold">
+                                          <p:stCondLst>
+                                            <p:cond delay="0"/>
+                                          </p:stCondLst>
+                                        </p:cTn>
+                                        <p:tgtEl>
+                                          <p:spTgt spid="5">
+                                            <p:txEl>
+                                              <p:pRg st="2" end="2"/>
+                                            </p:txEl>
+                                          </p:spTgt>
+                                        </p:tgtEl>
+                                        <p:attrNameLst>
+                                          <p:attrName>style.visibility</p:attrName>
+                                        </p:attrNameLst>
+                                      </p:cBhvr>
+                                      <p:to>
+                                        <p:strVal val="visible"/>
+                                      </p:to>
+                                    </p:set>
+                                  </p:childTnLst>
+                                </p:cTn>
+                              </p:par>
+                              <p:par>
+                                <p:cTn id="17" presetID="1" presetClass="entr" presetSubtype="0" fill="hold" grpId="0" nodeType="withEffect">
+                                  <p:stCondLst>
+                                    <p:cond delay="0"/>
+                                  </p:stCondLst>
+                                  <p:childTnLst>
+                                    <p:set>
+                                      <p:cBhvr>
+                                        <p:cTn id="18" dur="1" fill="hold">
+                                          <p:stCondLst>
+                                            <p:cond delay="0"/>
+                                          </p:stCondLst>
+                                        </p:cTn>
+                                        <p:tgtEl>
+                                          <p:spTgt spid="5">
+                                            <p:txEl>
+                                              <p:pRg st="3" end="3"/>
+                                            </p:txEl>
+                                          </p:spTgt>
+                                        </p:tgtEl>
+                                        <p:attrNameLst>
+                                          <p:attrName>style.visibility</p:attrName>
+                                        </p:attrNameLst>
+                                      </p:cBhvr>
+                                      <p:to>
+                                        <p:strVal val="visible"/>
+                                      </p:to>
+                                    </p:set>
+                                  </p:childTnLst>
+                                </p:cTn>
+                              </p:par>
+                              <p:par>
+                                <p:cTn id="19" presetID="1" presetClass="entr" presetSubtype="0" fill="hold" grpId="0" nodeType="withEffect">
+                                  <p:stCondLst>
+                                    <p:cond delay="0"/>
+                                  </p:stCondLst>
+                                  <p:childTnLst>
+                                    <p:set>
+                                      <p:cBhvr>
+                                        <p:cTn id="20" dur="1" fill="hold">
+                                          <p:stCondLst>
+                                            <p:cond delay="0"/>
+                                          </p:stCondLst>
+                                        </p:cTn>
+                                        <p:tgtEl>
+                                          <p:spTgt spid="5">
+                                            <p:txEl>
+                                              <p:pRg st="4" end="4"/>
+                                            </p:txEl>
+                                          </p:spTgt>
+                                        </p:tgtEl>
+                                        <p:attrNameLst>
+                                          <p:attrName>style.visibility</p:attrName>
+                                        </p:attrNameLst>
+                                      </p:cBhvr>
+                                      <p:to>
+                                        <p:strVal val="visible"/>
+                                      </p:to>
+                                    </p:set>
+                                  </p:childTnLst>
+                                </p:cTn>
+                              </p:par>
+                            </p:childTnLst>
+                          </p:cTn>
+                        </p:par>
+                      </p:childTnLst>
+                    </p:cTn>
+                  </p:par>
+                  <p:par>
+                    <p:cTn id="21" fill="hold">
+                      <p:stCondLst>
+                        <p:cond delay="indefinite"/>
+                      </p:stCondLst>
+                      <p:childTnLst>
+                        <p:par>
+                          <p:cTn id="22" fill="hold">
+                            <p:stCondLst>
+                              <p:cond delay="0"/>
+                            </p:stCondLst>
+                            <p:childTnLst>
+                              <p:par>
+                                <p:cTn id="23" presetID="1" presetClass="entr" presetSubtype="0" fill="hold" nodeType="clickEffect">
+                                  <p:stCondLst>
+                                    <p:cond delay="0"/>
+                                  </p:stCondLst>
+                                  <p:childTnLst>
+                                    <p:set>
+                                      <p:cBhvr>
+                                        <p:cTn id="24" dur="1" fill="hold">
+                                          <p:stCondLst>
+                                            <p:cond delay="0"/>
+                                          </p:stCondLst>
+                                        </p:cTn>
+                                        <p:tgtEl>
+                                          <p:spTgt spid="9"/>
+                                        </p:tgtEl>
+                                        <p:attrNameLst>
+                                          <p:attrName>style.visibility</p:attrName>
+                                        </p:attrNameLst>
+                                      </p:cBhvr>
+                                      <p:to>
+                                        <p:strVal val="visible"/>
+                                      </p:to>
+                                    </p:set>
+                                  </p:childTnLst>
+                                </p:cTn>
+                              </p:par>
+                            </p:childTnLst>
+                          </p:cTn>
+                        </p:par>
+                      </p:childTnLst>
+                    </p:cTn>
+                  </p:par>
+                  <p:par>
+                    <p:cTn id="25" fill="hold">
+                      <p:stCondLst>
+                        <p:cond delay="indefinite"/>
+                      </p:stCondLst>
+                      <p:childTnLst>
+                        <p:par>
+                          <p:cTn id="26" fill="hold">
+                            <p:stCondLst>
+                              <p:cond delay="0"/>
+                            </p:stCondLst>
+                            <p:childTnLst>
+                              <p:par>
+                                <p:cTn id="27" presetID="1" presetClass="entr" presetSubtype="0" fill="hold" grpId="0" nodeType="clickEffect">
+                                  <p:stCondLst>
+                                    <p:cond delay="0"/>
+                                  </p:stCondLst>
+                                  <p:childTnLst>
+                                    <p:set>
+                                      <p:cBhvr>
+                                        <p:cTn id="28" dur="1" fill="hold">
+                                          <p:stCondLst>
+                                            <p:cond delay="0"/>
+                                          </p:stCondLst>
+                                        </p:cTn>
+                                        <p:tgtEl>
+                                          <p:spTgt spid="34"/>
+                                        </p:tgtEl>
+                                        <p:attrNameLst>
+                                          <p:attrName>style.visibility</p:attrName>
+                                        </p:attrNameLst>
+                                      </p:cBhvr>
+                                      <p:to>
+                                        <p:strVal val="visible"/>
+                                      </p:to>
+                                    </p:set>
+                                  </p:childTnLst>
+                                </p:cTn>
+                              </p:par>
+                              <p:par>
+                                <p:cTn id="29" presetID="1" presetClass="entr" presetSubtype="0" fill="hold" grpId="0" nodeType="withEffect">
+                                  <p:stCondLst>
+                                    <p:cond delay="0"/>
+                                  </p:stCondLst>
+                                  <p:childTnLst>
+                                    <p:set>
+                                      <p:cBhvr>
+                                        <p:cTn id="30" dur="1" fill="hold">
+                                          <p:stCondLst>
+                                            <p:cond delay="0"/>
+                                          </p:stCondLst>
+                                        </p:cTn>
+                                        <p:tgtEl>
+                                          <p:spTgt spid="27"/>
+                                        </p:tgtEl>
+                                        <p:attrNameLst>
+                                          <p:attrName>style.visibility</p:attrName>
+                                        </p:attrNameLst>
+                                      </p:cBhvr>
+                                      <p:to>
+                                        <p:strVal val="visible"/>
+                                      </p:to>
+                                    </p:set>
+                                  </p:childTnLst>
+                                </p:cTn>
+                              </p:par>
+                              <p:par>
+                                <p:cTn id="31" presetID="1" presetClass="entr" presetSubtype="0" fill="hold" grpId="0" nodeType="withEffect">
+                                  <p:stCondLst>
+                                    <p:cond delay="0"/>
+                                  </p:stCondLst>
+                                  <p:childTnLst>
+                                    <p:set>
+                                      <p:cBhvr>
+                                        <p:cTn id="32" dur="1" fill="hold">
+                                          <p:stCondLst>
+                                            <p:cond delay="0"/>
+                                          </p:stCondLst>
+                                        </p:cTn>
+                                        <p:tgtEl>
+                                          <p:spTgt spid="28"/>
+                                        </p:tgtEl>
+                                        <p:attrNameLst>
+                                          <p:attrName>style.visibility</p:attrName>
+                                        </p:attrNameLst>
+                                      </p:cBhvr>
+                                      <p:to>
+                                        <p:strVal val="visible"/>
+                                      </p:to>
+                                    </p:set>
+                                  </p:childTnLst>
+                                </p:cTn>
+                              </p:par>
+                            </p:childTnLst>
+                          </p:cTn>
+                        </p:par>
+                      </p:childTnLst>
+                    </p:cTn>
+                  </p:par>
+                  <p:par>
+                    <p:cTn id="33" fill="hold">
+                      <p:stCondLst>
+                        <p:cond delay="indefinite"/>
+                      </p:stCondLst>
+                      <p:childTnLst>
+                        <p:par>
+                          <p:cTn id="34" fill="hold">
+                            <p:stCondLst>
+                              <p:cond delay="0"/>
+                            </p:stCondLst>
+                            <p:childTnLst>
+                              <p:par>
+                                <p:cTn id="35" presetID="1" presetClass="entr" presetSubtype="0" fill="hold" grpId="0" nodeType="clickEffect">
+                                  <p:stCondLst>
+                                    <p:cond delay="0"/>
+                                  </p:stCondLst>
+                                  <p:childTnLst>
+                                    <p:set>
+                                      <p:cBhvr>
+                                        <p:cTn id="36" dur="1" fill="hold">
+                                          <p:stCondLst>
+                                            <p:cond delay="0"/>
+                                          </p:stCondLst>
+                                        </p:cTn>
+                                        <p:tgtEl>
+                                          <p:spTgt spid="3"/>
+                                        </p:tgtEl>
+                                        <p:attrNameLst>
+                                          <p:attrName>style.visibility</p:attrName>
+                                        </p:attrNameLst>
+                                      </p:cBhvr>
+                                      <p:to>
+                                        <p:strVal val="visible"/>
+                                      </p:to>
+                                    </p:set>
+                                  </p:childTnLst>
+                                </p:cTn>
+                              </p:par>
+                            </p:childTnLst>
+                          </p:cTn>
+                        </p:par>
+                      </p:childTnLst>
+                    </p:cTn>
+                  </p:par>
+                </p:childTnLst>
+              </p:cTn>
+              <p:prevCondLst>
+                <p:cond evt="onPrev" delay="0">
+                  <p:tgtEl>
+                    <p:sldTgt/>
+                  </p:tgtEl>
+                </p:cond>
+              </p:prevCondLst>
+              <p:nextCondLst>
+                <p:cond evt="onNext" delay="0">
+                  <p:tgtEl>
+                    <p:sldTgt/>
+                  </p:tgtEl>
+                </p:cond>
+              </p:nextCondLst>
+            </p:seq>
+          </p:childTnLst>
+        </p:cTn>
+      </p:par>
+    </p:tnLst>
+    <p:bldLst>
+      <p:bldP spid="35" grpId="0" animBg="1"/>
+      <p:bldP spid="34" grpId="0" animBg="1"/>
+      <p:bldP spid="5" grpId="0" build="p"/>
+      <p:bldP spid="11" grpId="0"/>
+      <p:bldP spid="27" grpId="0"/>
+      <p:bldP spid="28" grpId="0"/>
+      <p:bldP spid="3" grpId="0"/>
+      <p:bldP spid="8" grpId="0"/>
+    </p:bldLst>
+  </p:timing>
+</p:sld>
+</file>
+
+<file path=ppt/slides/slide2.xml><?xml version="1.0" encoding="utf-8"?>
+<p:sld xmlns:a="http://schemas.openxmlformats.org/drawingml/2006/main" xmlns:r="http://schemas.openxmlformats.org/officeDocument/2006/relationships" xmlns:p="http://schemas.openxmlformats.org/presentationml/2006/main">
+  <p:cSld>
+    <p:spTree>
+      <p:nvGrpSpPr>
+        <p:cNvPr id="1" name=""/>
+        <p:cNvGrpSpPr/>
+        <p:nvPr/>
+      </p:nvGrpSpPr>
+      <p:grpSpPr>
+        <a:xfrm>
+          <a:off x="0" y="0"/>
+          <a:ext cx="0" cy="0"/>
+          <a:chOff x="0" y="0"/>
+          <a:chExt cx="0" cy="0"/>
+        </a:xfrm>
+      </p:grpSpPr>
+      <p:sp>
+        <p:nvSpPr>
+          <p:cNvPr id="9" name="Pfeil: nach rechts 8">
+            <a:extLst>
+              <a:ext uri="{FF2B5EF4-FFF2-40B4-BE49-F238E27FC236}">
+                <a16:creationId xmlns:a16="http://schemas.microsoft.com/office/drawing/2014/main" id="{A8292768-BB58-F29B-6B45-E1B457B9DE61}"/>
+              </a:ext>
+            </a:extLst>
+          </p:cNvPr>
+          <p:cNvSpPr/>
+          <p:nvPr/>
+        </p:nvSpPr>
+        <p:spPr>
+          <a:xfrm>
+            <a:off x="329112" y="3397590"/>
+            <a:ext cx="10159376" cy="210340"/>
+          </a:xfrm>
+          <a:prstGeom prst="rightArrow">
+            <a:avLst>
+              <a:gd name="adj1" fmla="val 100000"/>
+              <a:gd name="adj2" fmla="val 53498"/>
+            </a:avLst>
+          </a:prstGeom>
+          <a:solidFill>
+            <a:schemeClr val="bg1">
+              <a:lumMod val="75000"/>
+            </a:schemeClr>
+          </a:solidFill>
+          <a:ln w="9525" cap="flat" cmpd="sng" algn="ctr">
+            <a:noFill/>
+            <a:prstDash val="solid"/>
+          </a:ln>
+          <a:effectLst/>
+        </p:spPr>
+        <p:txBody>
+          <a:bodyPr rtlCol="0" anchor="ctr"/>
+          <a:lstStyle/>
+          <a:p>
+            <a:pPr marL="0" marR="0" indent="0" algn="ctr" defTabSz="914400" eaLnBrk="1" fontAlgn="auto" latinLnBrk="0" hangingPunct="1">
+              <a:lnSpc>
+                <a:spcPct val="100000"/>
+              </a:lnSpc>
+              <a:spcBef>
+                <a:spcPts val="0"/>
+              </a:spcBef>
+              <a:spcAft>
+                <a:spcPts val="0"/>
+              </a:spcAft>
+              <a:buClrTx/>
+              <a:buSzTx/>
+              <a:buFontTx/>
+              <a:buNone/>
+              <a:tabLst/>
+            </a:pPr>
+            <a:endParaRPr kumimoji="0" lang="de-DE" sz="1000" b="1" i="0" u="none" strike="noStrike" kern="0" cap="none" spc="0" normalizeH="0" baseline="0" noProof="0" dirty="0">
+              <a:ln>
+                <a:noFill/>
+              </a:ln>
+              <a:effectLst/>
+              <a:uLnTx/>
+              <a:uFillTx/>
+              <a:latin typeface="Arial" panose="020B0604020202020204"/>
+              <a:ea typeface="+mn-ea"/>
+              <a:cs typeface="Arial" panose="020B0604020202020204" pitchFamily="34" charset="0"/>
+            </a:endParaRPr>
+          </a:p>
+        </p:txBody>
+      </p:sp>
+      <p:sp>
+        <p:nvSpPr>
+          <p:cNvPr id="2" name="Datumsplatzhalter 1">
+            <a:extLst>
+              <a:ext uri="{FF2B5EF4-FFF2-40B4-BE49-F238E27FC236}">
+                <a16:creationId xmlns:a16="http://schemas.microsoft.com/office/drawing/2014/main" id="{1DCD62EA-A0F7-4251-9E05-9C1BBFA5A95A}"/>
+              </a:ext>
+            </a:extLst>
+          </p:cNvPr>
+          <p:cNvSpPr>
+            <a:spLocks noGrp="1"/>
+          </p:cNvSpPr>
+          <p:nvPr>
+            <p:ph type="dt" sz="half" idx="10"/>
+          </p:nvPr>
+        </p:nvSpPr>
+        <p:spPr/>
+        <p:txBody>
+          <a:bodyPr/>
+          <a:lstStyle/>
+          <a:p>
+            <a:fld id="{EA33749F-693F-4A8B-AD1F-042F2F274E90}" type="datetime1">
+              <a:rPr lang="de-DE" smtClean="0"/>
+              <a:t>11.06.2025</a:t>
+            </a:fld>
+            <a:endParaRPr lang="de-DE" dirty="0"/>
+          </a:p>
+        </p:txBody>
+      </p:sp>
+      <p:sp>
+        <p:nvSpPr>
+          <p:cNvPr id="4" name="Foliennummernplatzhalter 3">
+            <a:extLst>
+              <a:ext uri="{FF2B5EF4-FFF2-40B4-BE49-F238E27FC236}">
+                <a16:creationId xmlns:a16="http://schemas.microsoft.com/office/drawing/2014/main" id="{96450D58-C923-4965-BE36-8F20DD5400C5}"/>
+              </a:ext>
+            </a:extLst>
+          </p:cNvPr>
+          <p:cNvSpPr>
+            <a:spLocks noGrp="1"/>
+          </p:cNvSpPr>
+          <p:nvPr>
+            <p:ph type="sldNum" sz="quarter" idx="12"/>
+          </p:nvPr>
+        </p:nvSpPr>
+        <p:spPr/>
+        <p:txBody>
+          <a:bodyPr/>
+          <a:lstStyle/>
+          <a:p>
+            <a:fld id="{FE474E4C-431A-524F-A233-B9B84658CEA9}" type="slidenum">
+              <a:rPr lang="de-DE" smtClean="0"/>
+              <a:pPr/>
+              <a:t>2</a:t>
+            </a:fld>
+            <a:endParaRPr lang="de-DE" dirty="0"/>
+          </a:p>
+        </p:txBody>
+      </p:sp>
+      <p:sp>
+        <p:nvSpPr>
+          <p:cNvPr id="6" name="Titel 5">
+            <a:extLst>
+              <a:ext uri="{FF2B5EF4-FFF2-40B4-BE49-F238E27FC236}">
+                <a16:creationId xmlns:a16="http://schemas.microsoft.com/office/drawing/2014/main" id="{7E6B3330-F19B-4AC8-9189-FFB7B8364189}"/>
+              </a:ext>
+            </a:extLst>
+          </p:cNvPr>
+          <p:cNvSpPr>
+            <a:spLocks noGrp="1"/>
+          </p:cNvSpPr>
+          <p:nvPr>
+            <p:ph type="title"/>
+          </p:nvPr>
+        </p:nvSpPr>
+        <p:spPr/>
+        <p:txBody>
+          <a:bodyPr/>
+          <a:lstStyle/>
+          <a:p>
+            <a:r>
+              <a:rPr lang="de-DE" dirty="0"/>
+              <a:t>Spezifikation = Design </a:t>
+            </a:r>
+            <a:r>
+              <a:rPr lang="de-DE" dirty="0" err="1"/>
+              <a:t>before</a:t>
+            </a:r>
+            <a:r>
+              <a:rPr lang="de-DE" dirty="0"/>
+              <a:t> Implementation</a:t>
+            </a:r>
+          </a:p>
+        </p:txBody>
+      </p:sp>
+      <p:sp>
+        <p:nvSpPr>
+          <p:cNvPr id="7" name="Fußzeilenplatzhalter 2">
+            <a:extLst>
+              <a:ext uri="{FF2B5EF4-FFF2-40B4-BE49-F238E27FC236}">
+                <a16:creationId xmlns:a16="http://schemas.microsoft.com/office/drawing/2014/main" id="{A576D1F4-18EB-4DB4-BB18-248EE62393E2}"/>
+              </a:ext>
+            </a:extLst>
+          </p:cNvPr>
+          <p:cNvSpPr>
+            <a:spLocks noGrp="1"/>
+          </p:cNvSpPr>
+          <p:nvPr>
+            <p:ph type="ftr" sz="quarter" idx="11"/>
+          </p:nvPr>
+        </p:nvSpPr>
+        <p:spPr>
+          <a:xfrm>
+            <a:off x="1766713" y="6561601"/>
+            <a:ext cx="8647289" cy="92333"/>
+          </a:xfrm>
+        </p:spPr>
+        <p:txBody>
+          <a:bodyPr/>
+          <a:lstStyle/>
+          <a:p>
+            <a:r>
+              <a:rPr lang="en-US" dirty="0"/>
+              <a:t>© Copyright 2025 • S&amp;N Invent GmbH • All rights reserved.</a:t>
+            </a:r>
+            <a:endParaRPr lang="de-DE" dirty="0"/>
+          </a:p>
+        </p:txBody>
+      </p:sp>
+      <p:sp>
+        <p:nvSpPr>
+          <p:cNvPr id="8" name="Pfeil: Chevron 7">
+            <a:extLst>
+              <a:ext uri="{FF2B5EF4-FFF2-40B4-BE49-F238E27FC236}">
+                <a16:creationId xmlns:a16="http://schemas.microsoft.com/office/drawing/2014/main" id="{4523CC4B-EA09-CFDE-45D5-291E9AE10D63}"/>
+              </a:ext>
+            </a:extLst>
+          </p:cNvPr>
+          <p:cNvSpPr/>
+          <p:nvPr/>
+        </p:nvSpPr>
+        <p:spPr>
+          <a:xfrm>
+            <a:off x="846312" y="2244914"/>
+            <a:ext cx="2088232" cy="1080120"/>
+          </a:xfrm>
+          <a:prstGeom prst="chevron">
+            <a:avLst>
+              <a:gd name="adj" fmla="val 26529"/>
+            </a:avLst>
+          </a:prstGeom>
+          <a:solidFill>
+            <a:srgbClr val="FFC000"/>
+          </a:solidFill>
+          <a:ln w="9525" cap="flat" cmpd="sng" algn="ctr">
+            <a:noFill/>
+            <a:prstDash val="solid"/>
+          </a:ln>
+          <a:effectLst/>
+        </p:spPr>
+        <p:txBody>
+          <a:bodyPr rtlCol="0" anchor="ctr"/>
+          <a:lstStyle/>
+          <a:p>
+            <a:pPr algn="ctr"/>
+            <a:endParaRPr lang="de-DE" sz="2000" dirty="0"/>
+          </a:p>
+          <a:p>
+            <a:pPr algn="ctr"/>
+            <a:r>
+              <a:rPr lang="de-DE" sz="2000" dirty="0"/>
+              <a:t>Kunden-wunsch</a:t>
+            </a:r>
+          </a:p>
+          <a:p>
+            <a:pPr marL="0" marR="0" indent="0" algn="ctr" defTabSz="914400" eaLnBrk="1" fontAlgn="auto" latinLnBrk="0" hangingPunct="1">
+              <a:lnSpc>
+                <a:spcPct val="100000"/>
+              </a:lnSpc>
+              <a:spcBef>
+                <a:spcPts val="0"/>
+              </a:spcBef>
+              <a:spcAft>
+                <a:spcPts val="0"/>
+              </a:spcAft>
+              <a:buClrTx/>
+              <a:buSzTx/>
+              <a:buFontTx/>
+              <a:buNone/>
+              <a:tabLst/>
+            </a:pPr>
+            <a:endParaRPr kumimoji="0" lang="de-DE" sz="2000" b="1" i="0" u="none" strike="noStrike" kern="0" cap="none" spc="0" normalizeH="0" baseline="0" noProof="0" dirty="0">
+              <a:ln>
+                <a:noFill/>
+              </a:ln>
+              <a:effectLst/>
+              <a:uLnTx/>
+              <a:uFillTx/>
+              <a:latin typeface="Arial" panose="020B0604020202020204"/>
+              <a:ea typeface="+mn-ea"/>
+              <a:cs typeface="Arial" panose="020B0604020202020204" pitchFamily="34" charset="0"/>
+            </a:endParaRPr>
+          </a:p>
+        </p:txBody>
+      </p:sp>
+      <p:sp>
+        <p:nvSpPr>
+          <p:cNvPr id="12" name="Pfeil: Chevron 11">
+            <a:extLst>
+              <a:ext uri="{FF2B5EF4-FFF2-40B4-BE49-F238E27FC236}">
+                <a16:creationId xmlns:a16="http://schemas.microsoft.com/office/drawing/2014/main" id="{D03779AC-557C-FD34-4526-C4662C712030}"/>
+              </a:ext>
+            </a:extLst>
+          </p:cNvPr>
+          <p:cNvSpPr/>
+          <p:nvPr/>
+        </p:nvSpPr>
+        <p:spPr>
+          <a:xfrm>
+            <a:off x="2807784" y="2248483"/>
+            <a:ext cx="2088232" cy="1080120"/>
+          </a:xfrm>
+          <a:prstGeom prst="chevron">
+            <a:avLst>
+              <a:gd name="adj" fmla="val 26529"/>
+            </a:avLst>
+          </a:prstGeom>
+          <a:solidFill>
+            <a:srgbClr val="FFC000"/>
+          </a:solidFill>
+          <a:ln w="9525" cap="flat" cmpd="sng" algn="ctr">
+            <a:noFill/>
+            <a:prstDash val="solid"/>
+          </a:ln>
+          <a:effectLst/>
+        </p:spPr>
+        <p:txBody>
+          <a:bodyPr rtlCol="0" anchor="ctr"/>
+          <a:lstStyle/>
+          <a:p>
+            <a:pPr algn="ctr"/>
+            <a:endParaRPr lang="de-DE" sz="2000" dirty="0"/>
+          </a:p>
+          <a:p>
+            <a:pPr algn="ctr"/>
+            <a:r>
+              <a:rPr lang="de-DE" sz="2000" dirty="0"/>
+              <a:t>Ortstermin</a:t>
+            </a:r>
+          </a:p>
+          <a:p>
+            <a:pPr marL="0" marR="0" indent="0" algn="ctr" defTabSz="914400" eaLnBrk="1" fontAlgn="auto" latinLnBrk="0" hangingPunct="1">
+              <a:lnSpc>
+                <a:spcPct val="100000"/>
+              </a:lnSpc>
+              <a:spcBef>
+                <a:spcPts val="0"/>
+              </a:spcBef>
+              <a:spcAft>
+                <a:spcPts val="0"/>
+              </a:spcAft>
+              <a:buClrTx/>
+              <a:buSzTx/>
+              <a:buFontTx/>
+              <a:buNone/>
+              <a:tabLst/>
+            </a:pPr>
+            <a:endParaRPr kumimoji="0" lang="de-DE" sz="2000" b="1" i="0" u="none" strike="noStrike" kern="0" cap="none" spc="0" normalizeH="0" baseline="0" noProof="0" dirty="0">
+              <a:ln>
+                <a:noFill/>
+              </a:ln>
+              <a:effectLst/>
+              <a:uLnTx/>
+              <a:uFillTx/>
+              <a:latin typeface="Arial" panose="020B0604020202020204"/>
+              <a:ea typeface="+mn-ea"/>
+              <a:cs typeface="Arial" panose="020B0604020202020204" pitchFamily="34" charset="0"/>
+            </a:endParaRPr>
+          </a:p>
+        </p:txBody>
+      </p:sp>
+      <p:sp>
+        <p:nvSpPr>
+          <p:cNvPr id="13" name="Pfeil: Chevron 12">
+            <a:extLst>
+              <a:ext uri="{FF2B5EF4-FFF2-40B4-BE49-F238E27FC236}">
+                <a16:creationId xmlns:a16="http://schemas.microsoft.com/office/drawing/2014/main" id="{21D7F417-3054-A005-6CB6-F577A9F84A22}"/>
+              </a:ext>
+            </a:extLst>
+          </p:cNvPr>
+          <p:cNvSpPr/>
+          <p:nvPr/>
+        </p:nvSpPr>
+        <p:spPr>
+          <a:xfrm>
+            <a:off x="4743949" y="2253521"/>
+            <a:ext cx="2088232" cy="1080120"/>
+          </a:xfrm>
+          <a:prstGeom prst="chevron">
+            <a:avLst>
+              <a:gd name="adj" fmla="val 26529"/>
+            </a:avLst>
+          </a:prstGeom>
+          <a:solidFill>
+            <a:srgbClr val="FFC000"/>
+          </a:solidFill>
+          <a:ln w="9525" cap="flat" cmpd="sng" algn="ctr">
+            <a:noFill/>
+            <a:prstDash val="solid"/>
+          </a:ln>
+          <a:effectLst/>
+        </p:spPr>
+        <p:txBody>
+          <a:bodyPr rtlCol="0" anchor="ctr"/>
+          <a:lstStyle/>
+          <a:p>
+            <a:pPr algn="ctr"/>
+            <a:endParaRPr lang="de-DE" sz="2000" dirty="0"/>
+          </a:p>
+          <a:p>
+            <a:pPr algn="ctr"/>
+            <a:r>
+              <a:rPr lang="de-DE" sz="2000" dirty="0"/>
+              <a:t>Entwurf</a:t>
+            </a:r>
+          </a:p>
+          <a:p>
+            <a:pPr marL="0" marR="0" indent="0" algn="ctr" defTabSz="914400" eaLnBrk="1" fontAlgn="auto" latinLnBrk="0" hangingPunct="1">
+              <a:lnSpc>
+                <a:spcPct val="100000"/>
+              </a:lnSpc>
+              <a:spcBef>
+                <a:spcPts val="0"/>
+              </a:spcBef>
+              <a:spcAft>
+                <a:spcPts val="0"/>
+              </a:spcAft>
+              <a:buClrTx/>
+              <a:buSzTx/>
+              <a:buFontTx/>
+              <a:buNone/>
+              <a:tabLst/>
+            </a:pPr>
+            <a:endParaRPr kumimoji="0" lang="de-DE" sz="2000" b="1" i="0" u="none" strike="noStrike" kern="0" cap="none" spc="0" normalizeH="0" baseline="0" noProof="0" dirty="0">
+              <a:ln>
+                <a:noFill/>
+              </a:ln>
+              <a:effectLst/>
+              <a:uLnTx/>
+              <a:uFillTx/>
+              <a:latin typeface="Arial" panose="020B0604020202020204"/>
+              <a:ea typeface="+mn-ea"/>
+              <a:cs typeface="Arial" panose="020B0604020202020204" pitchFamily="34" charset="0"/>
+            </a:endParaRPr>
+          </a:p>
+        </p:txBody>
+      </p:sp>
+      <p:sp>
+        <p:nvSpPr>
+          <p:cNvPr id="15" name="Pfeil: Chevron 14">
+            <a:extLst>
+              <a:ext uri="{FF2B5EF4-FFF2-40B4-BE49-F238E27FC236}">
+                <a16:creationId xmlns:a16="http://schemas.microsoft.com/office/drawing/2014/main" id="{722D41A9-D13E-FEC4-F1C2-BA0634BA551F}"/>
+              </a:ext>
+            </a:extLst>
+          </p:cNvPr>
+          <p:cNvSpPr/>
+          <p:nvPr/>
+        </p:nvSpPr>
+        <p:spPr>
+          <a:xfrm>
+            <a:off x="6672064" y="2249525"/>
+            <a:ext cx="2088232" cy="1080120"/>
+          </a:xfrm>
+          <a:prstGeom prst="chevron">
+            <a:avLst>
+              <a:gd name="adj" fmla="val 26529"/>
+            </a:avLst>
+          </a:prstGeom>
+          <a:solidFill>
+            <a:srgbClr val="FFC000"/>
+          </a:solidFill>
+          <a:ln w="9525" cap="flat" cmpd="sng" algn="ctr">
+            <a:noFill/>
+            <a:prstDash val="solid"/>
+          </a:ln>
+          <a:effectLst/>
+        </p:spPr>
+        <p:txBody>
+          <a:bodyPr rtlCol="0" anchor="ctr"/>
+          <a:lstStyle/>
+          <a:p>
+            <a:pPr algn="ctr"/>
+            <a:endParaRPr lang="de-DE" sz="2000" dirty="0"/>
+          </a:p>
+          <a:p>
+            <a:pPr algn="ctr"/>
+            <a:r>
+              <a:rPr lang="de-DE" sz="2000" dirty="0"/>
+              <a:t>Umsetzung</a:t>
+            </a:r>
+          </a:p>
+          <a:p>
+            <a:pPr marL="0" marR="0" indent="0" algn="ctr" defTabSz="914400" eaLnBrk="1" fontAlgn="auto" latinLnBrk="0" hangingPunct="1">
+              <a:lnSpc>
+                <a:spcPct val="100000"/>
+              </a:lnSpc>
+              <a:spcBef>
+                <a:spcPts val="0"/>
+              </a:spcBef>
+              <a:spcAft>
+                <a:spcPts val="0"/>
+              </a:spcAft>
+              <a:buClrTx/>
+              <a:buSzTx/>
+              <a:buFontTx/>
+              <a:buNone/>
+              <a:tabLst/>
+            </a:pPr>
+            <a:endParaRPr kumimoji="0" lang="de-DE" sz="2000" b="1" i="0" u="none" strike="noStrike" kern="0" cap="none" spc="0" normalizeH="0" baseline="0" noProof="0" dirty="0">
+              <a:ln>
+                <a:noFill/>
+              </a:ln>
+              <a:effectLst/>
+              <a:uLnTx/>
+              <a:uFillTx/>
+              <a:latin typeface="Arial" panose="020B0604020202020204"/>
+              <a:ea typeface="+mn-ea"/>
+              <a:cs typeface="Arial" panose="020B0604020202020204" pitchFamily="34" charset="0"/>
+            </a:endParaRPr>
+          </a:p>
+        </p:txBody>
+      </p:sp>
+      <p:sp>
+        <p:nvSpPr>
+          <p:cNvPr id="16" name="Pfeil: Chevron 15">
+            <a:extLst>
+              <a:ext uri="{FF2B5EF4-FFF2-40B4-BE49-F238E27FC236}">
+                <a16:creationId xmlns:a16="http://schemas.microsoft.com/office/drawing/2014/main" id="{7DB4E27C-C2C7-0013-5B8D-ECCD4A9C19C0}"/>
+              </a:ext>
+            </a:extLst>
+          </p:cNvPr>
+          <p:cNvSpPr/>
+          <p:nvPr/>
+        </p:nvSpPr>
+        <p:spPr>
+          <a:xfrm>
+            <a:off x="8616280" y="2244914"/>
+            <a:ext cx="2088232" cy="1080120"/>
+          </a:xfrm>
+          <a:prstGeom prst="chevron">
+            <a:avLst>
+              <a:gd name="adj" fmla="val 26529"/>
+            </a:avLst>
+          </a:prstGeom>
+          <a:solidFill>
+            <a:srgbClr val="FFC000"/>
+          </a:solidFill>
+          <a:ln w="9525" cap="flat" cmpd="sng" algn="ctr">
+            <a:noFill/>
+            <a:prstDash val="solid"/>
+          </a:ln>
+          <a:effectLst/>
+        </p:spPr>
+        <p:txBody>
+          <a:bodyPr rtlCol="0" anchor="ctr"/>
+          <a:lstStyle/>
+          <a:p>
+            <a:pPr algn="ctr"/>
+            <a:endParaRPr lang="de-DE" sz="2000" dirty="0"/>
+          </a:p>
+          <a:p>
+            <a:pPr algn="ctr"/>
+            <a:r>
+              <a:rPr lang="de-DE" sz="2000" dirty="0"/>
+              <a:t>Bau-abnahme</a:t>
+            </a:r>
+          </a:p>
+          <a:p>
+            <a:pPr marL="0" marR="0" indent="0" algn="ctr" defTabSz="914400" eaLnBrk="1" fontAlgn="auto" latinLnBrk="0" hangingPunct="1">
+              <a:lnSpc>
+                <a:spcPct val="100000"/>
+              </a:lnSpc>
+              <a:spcBef>
+                <a:spcPts val="0"/>
+              </a:spcBef>
+              <a:spcAft>
+                <a:spcPts val="0"/>
+              </a:spcAft>
+              <a:buClrTx/>
+              <a:buSzTx/>
+              <a:buFontTx/>
+              <a:buNone/>
+              <a:tabLst/>
+            </a:pPr>
+            <a:endParaRPr kumimoji="0" lang="de-DE" sz="2000" b="1" i="0" u="none" strike="noStrike" kern="0" cap="none" spc="0" normalizeH="0" baseline="0" noProof="0" dirty="0">
+              <a:ln>
+                <a:noFill/>
+              </a:ln>
+              <a:effectLst/>
+              <a:uLnTx/>
+              <a:uFillTx/>
+              <a:latin typeface="Arial" panose="020B0604020202020204"/>
+              <a:ea typeface="+mn-ea"/>
+              <a:cs typeface="Arial" panose="020B0604020202020204" pitchFamily="34" charset="0"/>
+            </a:endParaRPr>
+          </a:p>
+        </p:txBody>
+      </p:sp>
+      <p:sp>
+        <p:nvSpPr>
+          <p:cNvPr id="18" name="Rechteck 17">
+            <a:extLst>
+              <a:ext uri="{FF2B5EF4-FFF2-40B4-BE49-F238E27FC236}">
+                <a16:creationId xmlns:a16="http://schemas.microsoft.com/office/drawing/2014/main" id="{9D8B12D0-9DAD-A95F-A02F-A04DE541D391}"/>
+              </a:ext>
+            </a:extLst>
+          </p:cNvPr>
+          <p:cNvSpPr/>
+          <p:nvPr/>
+        </p:nvSpPr>
+        <p:spPr>
+          <a:xfrm>
+            <a:off x="973213" y="1516839"/>
+            <a:ext cx="1522387" cy="884582"/>
+          </a:xfrm>
+          <a:prstGeom prst="rect">
+            <a:avLst/>
+          </a:prstGeom>
+          <a:solidFill>
+            <a:schemeClr val="accent1">
+              <a:lumMod val="20000"/>
+              <a:lumOff val="80000"/>
+            </a:schemeClr>
+          </a:solidFill>
+          <a:ln>
+            <a:noFill/>
+          </a:ln>
+        </p:spPr>
+        <p:style>
+          <a:lnRef idx="2">
+            <a:schemeClr val="accent1">
+              <a:shade val="15000"/>
+            </a:schemeClr>
+          </a:lnRef>
+          <a:fillRef idx="1">
+            <a:schemeClr val="accent1"/>
+          </a:fillRef>
+          <a:effectRef idx="0">
+            <a:schemeClr val="accent1"/>
+          </a:effectRef>
+          <a:fontRef idx="minor">
+            <a:schemeClr val="lt1"/>
+          </a:fontRef>
+        </p:style>
+        <p:txBody>
+          <a:bodyPr rtlCol="0" anchor="ctr"/>
+          <a:lstStyle/>
+          <a:p>
+            <a:r>
+              <a:rPr lang="de-DE" sz="1100" dirty="0">
+                <a:solidFill>
+                  <a:schemeClr val="tx1">
+                    <a:lumMod val="75000"/>
+                  </a:schemeClr>
+                </a:solidFill>
+              </a:rPr>
+              <a:t>Eine Terrasse nach Süden raus mit direktem Zugang aus dem Wohnzimmer</a:t>
+            </a:r>
+          </a:p>
+        </p:txBody>
+      </p:sp>
+      <p:sp>
+        <p:nvSpPr>
+          <p:cNvPr id="19" name="Rechteck 18">
+            <a:extLst>
+              <a:ext uri="{FF2B5EF4-FFF2-40B4-BE49-F238E27FC236}">
+                <a16:creationId xmlns:a16="http://schemas.microsoft.com/office/drawing/2014/main" id="{41E5EA9C-6014-0BBE-94F8-A71B11CAA03E}"/>
+              </a:ext>
+            </a:extLst>
+          </p:cNvPr>
+          <p:cNvSpPr/>
+          <p:nvPr/>
+        </p:nvSpPr>
+        <p:spPr>
+          <a:xfrm>
+            <a:off x="1232905" y="3248118"/>
+            <a:ext cx="1085229" cy="555037"/>
+          </a:xfrm>
+          <a:prstGeom prst="rect">
+            <a:avLst/>
+          </a:prstGeom>
+          <a:solidFill>
+            <a:schemeClr val="accent1">
+              <a:lumMod val="20000"/>
+              <a:lumOff val="80000"/>
+            </a:schemeClr>
+          </a:solidFill>
+          <a:ln>
+            <a:noFill/>
+          </a:ln>
+        </p:spPr>
+        <p:style>
+          <a:lnRef idx="2">
+            <a:schemeClr val="accent1">
+              <a:shade val="15000"/>
+            </a:schemeClr>
+          </a:lnRef>
+          <a:fillRef idx="1">
+            <a:schemeClr val="accent1"/>
+          </a:fillRef>
+          <a:effectRef idx="0">
+            <a:schemeClr val="accent1"/>
+          </a:effectRef>
+          <a:fontRef idx="minor">
+            <a:schemeClr val="lt1"/>
+          </a:fontRef>
+        </p:style>
+        <p:txBody>
+          <a:bodyPr rtlCol="0" anchor="ctr"/>
+          <a:lstStyle/>
+          <a:p>
+            <a:r>
+              <a:rPr lang="de-DE" sz="1100" dirty="0">
+                <a:solidFill>
+                  <a:schemeClr val="tx1">
+                    <a:lumMod val="75000"/>
+                  </a:schemeClr>
+                </a:solidFill>
+              </a:rPr>
+              <a:t>Beschreibung „mit Händen und Füßen“</a:t>
+            </a:r>
+          </a:p>
+        </p:txBody>
+      </p:sp>
+      <p:sp>
+        <p:nvSpPr>
+          <p:cNvPr id="20" name="Rechteck 19">
+            <a:extLst>
+              <a:ext uri="{FF2B5EF4-FFF2-40B4-BE49-F238E27FC236}">
+                <a16:creationId xmlns:a16="http://schemas.microsoft.com/office/drawing/2014/main" id="{5F4F8316-1838-5E36-B8E2-ADE2A0EF8D49}"/>
+              </a:ext>
+            </a:extLst>
+          </p:cNvPr>
+          <p:cNvSpPr/>
+          <p:nvPr/>
+        </p:nvSpPr>
+        <p:spPr>
+          <a:xfrm>
+            <a:off x="3061792" y="1516839"/>
+            <a:ext cx="1394792" cy="884582"/>
+          </a:xfrm>
+          <a:prstGeom prst="rect">
+            <a:avLst/>
+          </a:prstGeom>
+          <a:solidFill>
+            <a:schemeClr val="accent1">
+              <a:lumMod val="20000"/>
+              <a:lumOff val="80000"/>
+            </a:schemeClr>
+          </a:solidFill>
+          <a:ln>
+            <a:noFill/>
+          </a:ln>
+        </p:spPr>
+        <p:style>
+          <a:lnRef idx="2">
+            <a:schemeClr val="accent1">
+              <a:shade val="15000"/>
+            </a:schemeClr>
+          </a:lnRef>
+          <a:fillRef idx="1">
+            <a:schemeClr val="accent1"/>
+          </a:fillRef>
+          <a:effectRef idx="0">
+            <a:schemeClr val="accent1"/>
+          </a:effectRef>
+          <a:fontRef idx="minor">
+            <a:schemeClr val="lt1"/>
+          </a:fontRef>
+        </p:style>
+        <p:txBody>
+          <a:bodyPr rtlCol="0" anchor="ctr"/>
+          <a:lstStyle/>
+          <a:p>
+            <a:r>
+              <a:rPr lang="de-DE" sz="1100" dirty="0">
+                <a:solidFill>
+                  <a:schemeClr val="tx1">
+                    <a:lumMod val="75000"/>
+                  </a:schemeClr>
+                </a:solidFill>
+              </a:rPr>
+              <a:t>Architekt kommt vorbei und bringt Pflasterer und Fensterbauer mit</a:t>
+            </a:r>
+          </a:p>
+        </p:txBody>
+      </p:sp>
+      <p:sp>
+        <p:nvSpPr>
+          <p:cNvPr id="21" name="Rechteck 20">
+            <a:extLst>
+              <a:ext uri="{FF2B5EF4-FFF2-40B4-BE49-F238E27FC236}">
+                <a16:creationId xmlns:a16="http://schemas.microsoft.com/office/drawing/2014/main" id="{F7E4C994-1E45-CB29-7F83-E816B0273124}"/>
+              </a:ext>
+            </a:extLst>
+          </p:cNvPr>
+          <p:cNvSpPr/>
+          <p:nvPr/>
+        </p:nvSpPr>
+        <p:spPr>
+          <a:xfrm>
+            <a:off x="3177121" y="3227015"/>
+            <a:ext cx="1085229" cy="767695"/>
+          </a:xfrm>
+          <a:prstGeom prst="rect">
+            <a:avLst/>
+          </a:prstGeom>
+          <a:solidFill>
+            <a:schemeClr val="accent1">
+              <a:lumMod val="20000"/>
+              <a:lumOff val="80000"/>
+            </a:schemeClr>
+          </a:solidFill>
+          <a:ln>
+            <a:noFill/>
+          </a:ln>
+        </p:spPr>
+        <p:style>
+          <a:lnRef idx="2">
+            <a:schemeClr val="accent1">
+              <a:shade val="15000"/>
+            </a:schemeClr>
+          </a:lnRef>
+          <a:fillRef idx="1">
+            <a:schemeClr val="accent1"/>
+          </a:fillRef>
+          <a:effectRef idx="0">
+            <a:schemeClr val="accent1"/>
+          </a:effectRef>
+          <a:fontRef idx="minor">
+            <a:schemeClr val="lt1"/>
+          </a:fontRef>
+        </p:style>
+        <p:txBody>
+          <a:bodyPr rtlCol="0" anchor="ctr"/>
+          <a:lstStyle/>
+          <a:p>
+            <a:r>
+              <a:rPr lang="de-DE" sz="1100" dirty="0">
+                <a:solidFill>
+                  <a:schemeClr val="tx1">
+                    <a:lumMod val="75000"/>
+                  </a:schemeClr>
+                </a:solidFill>
+              </a:rPr>
+              <a:t>Ein paar Skizzen und handschrift-</a:t>
+            </a:r>
+            <a:r>
+              <a:rPr lang="de-DE" sz="1100" dirty="0" err="1">
+                <a:solidFill>
+                  <a:schemeClr val="tx1">
+                    <a:lumMod val="75000"/>
+                  </a:schemeClr>
+                </a:solidFill>
+              </a:rPr>
+              <a:t>liche</a:t>
+            </a:r>
+            <a:r>
+              <a:rPr lang="de-DE" sz="1100" dirty="0">
+                <a:solidFill>
+                  <a:schemeClr val="tx1">
+                    <a:lumMod val="75000"/>
+                  </a:schemeClr>
+                </a:solidFill>
+              </a:rPr>
+              <a:t> Notizen</a:t>
+            </a:r>
+          </a:p>
+        </p:txBody>
+      </p:sp>
+      <p:sp>
+        <p:nvSpPr>
+          <p:cNvPr id="22" name="Rechteck 21">
+            <a:extLst>
+              <a:ext uri="{FF2B5EF4-FFF2-40B4-BE49-F238E27FC236}">
+                <a16:creationId xmlns:a16="http://schemas.microsoft.com/office/drawing/2014/main" id="{F67EA686-356C-B2AD-3445-83E927702A7D}"/>
+              </a:ext>
+            </a:extLst>
+          </p:cNvPr>
+          <p:cNvSpPr/>
+          <p:nvPr/>
+        </p:nvSpPr>
+        <p:spPr>
+          <a:xfrm>
+            <a:off x="5002560" y="3175881"/>
+            <a:ext cx="1309464" cy="873272"/>
+          </a:xfrm>
+          <a:prstGeom prst="rect">
+            <a:avLst/>
+          </a:prstGeom>
+          <a:solidFill>
+            <a:schemeClr val="accent1">
+              <a:lumMod val="20000"/>
+              <a:lumOff val="80000"/>
+            </a:schemeClr>
+          </a:solidFill>
+          <a:ln>
+            <a:noFill/>
+          </a:ln>
+        </p:spPr>
+        <p:style>
+          <a:lnRef idx="2">
+            <a:schemeClr val="accent1">
+              <a:shade val="15000"/>
+            </a:schemeClr>
+          </a:lnRef>
+          <a:fillRef idx="1">
+            <a:schemeClr val="accent1"/>
+          </a:fillRef>
+          <a:effectRef idx="0">
+            <a:schemeClr val="accent1"/>
+          </a:effectRef>
+          <a:fontRef idx="minor">
+            <a:schemeClr val="lt1"/>
+          </a:fontRef>
+        </p:style>
+        <p:txBody>
+          <a:bodyPr rtlCol="0" anchor="ctr"/>
+          <a:lstStyle/>
+          <a:p>
+            <a:r>
+              <a:rPr lang="de-DE" sz="1100" dirty="0">
+                <a:solidFill>
+                  <a:schemeClr val="tx1">
+                    <a:lumMod val="75000"/>
+                  </a:schemeClr>
+                </a:solidFill>
+              </a:rPr>
+              <a:t>Detaillierte Bauzeichnung mit Bemaßungen, vom Bauherrn freizugeben</a:t>
+            </a:r>
+          </a:p>
+        </p:txBody>
+      </p:sp>
+      <p:sp>
+        <p:nvSpPr>
+          <p:cNvPr id="23" name="Rechteck 22">
+            <a:extLst>
+              <a:ext uri="{FF2B5EF4-FFF2-40B4-BE49-F238E27FC236}">
+                <a16:creationId xmlns:a16="http://schemas.microsoft.com/office/drawing/2014/main" id="{85EA5588-315A-EAA5-71C1-047F9D5FAFB1}"/>
+              </a:ext>
+            </a:extLst>
+          </p:cNvPr>
+          <p:cNvSpPr/>
+          <p:nvPr/>
+        </p:nvSpPr>
+        <p:spPr>
+          <a:xfrm>
+            <a:off x="6946776" y="1543457"/>
+            <a:ext cx="1394792" cy="910637"/>
+          </a:xfrm>
+          <a:prstGeom prst="rect">
+            <a:avLst/>
+          </a:prstGeom>
+          <a:solidFill>
+            <a:schemeClr val="accent1">
+              <a:lumMod val="20000"/>
+              <a:lumOff val="80000"/>
+            </a:schemeClr>
+          </a:solidFill>
+          <a:ln>
+            <a:noFill/>
+          </a:ln>
+        </p:spPr>
+        <p:style>
+          <a:lnRef idx="2">
+            <a:schemeClr val="accent1">
+              <a:shade val="15000"/>
+            </a:schemeClr>
+          </a:lnRef>
+          <a:fillRef idx="1">
+            <a:schemeClr val="accent1"/>
+          </a:fillRef>
+          <a:effectRef idx="0">
+            <a:schemeClr val="accent1"/>
+          </a:effectRef>
+          <a:fontRef idx="minor">
+            <a:schemeClr val="lt1"/>
+          </a:fontRef>
+        </p:style>
+        <p:txBody>
+          <a:bodyPr rtlCol="0" anchor="ctr"/>
+          <a:lstStyle/>
+          <a:p>
+            <a:r>
+              <a:rPr lang="de-DE" sz="1100" dirty="0">
+                <a:solidFill>
+                  <a:schemeClr val="tx1">
+                    <a:lumMod val="75000"/>
+                  </a:schemeClr>
+                </a:solidFill>
+              </a:rPr>
+              <a:t>Baumaßnahme nach den Regeln der Handwerks-kunst UND…</a:t>
+            </a:r>
+          </a:p>
+          <a:p>
+            <a:r>
+              <a:rPr lang="de-DE" sz="1100" dirty="0">
+                <a:solidFill>
+                  <a:schemeClr val="tx1">
+                    <a:lumMod val="75000"/>
+                  </a:schemeClr>
+                </a:solidFill>
+              </a:rPr>
+              <a:t>der Bauzeichnung</a:t>
+            </a:r>
+          </a:p>
+        </p:txBody>
+      </p:sp>
+      <p:sp>
+        <p:nvSpPr>
+          <p:cNvPr id="24" name="Rechteck 23">
+            <a:extLst>
+              <a:ext uri="{FF2B5EF4-FFF2-40B4-BE49-F238E27FC236}">
+                <a16:creationId xmlns:a16="http://schemas.microsoft.com/office/drawing/2014/main" id="{F6CE045F-58B9-221D-807E-D1385FEEA273}"/>
+              </a:ext>
+            </a:extLst>
+          </p:cNvPr>
+          <p:cNvSpPr/>
+          <p:nvPr/>
+        </p:nvSpPr>
+        <p:spPr>
+          <a:xfrm>
+            <a:off x="7177919" y="3213782"/>
+            <a:ext cx="890017" cy="566317"/>
+          </a:xfrm>
+          <a:prstGeom prst="rect">
+            <a:avLst/>
+          </a:prstGeom>
+          <a:solidFill>
+            <a:schemeClr val="accent1">
+              <a:lumMod val="20000"/>
+              <a:lumOff val="80000"/>
+            </a:schemeClr>
+          </a:solidFill>
+          <a:ln>
+            <a:noFill/>
+          </a:ln>
+        </p:spPr>
+        <p:style>
+          <a:lnRef idx="2">
+            <a:schemeClr val="accent1">
+              <a:shade val="15000"/>
+            </a:schemeClr>
+          </a:lnRef>
+          <a:fillRef idx="1">
+            <a:schemeClr val="accent1"/>
+          </a:fillRef>
+          <a:effectRef idx="0">
+            <a:schemeClr val="accent1"/>
+          </a:effectRef>
+          <a:fontRef idx="minor">
+            <a:schemeClr val="lt1"/>
+          </a:fontRef>
+        </p:style>
+        <p:txBody>
+          <a:bodyPr rtlCol="0" anchor="ctr"/>
+          <a:lstStyle/>
+          <a:p>
+            <a:r>
+              <a:rPr lang="de-DE" sz="1100" dirty="0">
+                <a:solidFill>
+                  <a:schemeClr val="tx1">
+                    <a:lumMod val="75000"/>
+                  </a:schemeClr>
+                </a:solidFill>
+              </a:rPr>
+              <a:t>Die Terrasse</a:t>
+            </a:r>
+          </a:p>
+        </p:txBody>
+      </p:sp>
+      <p:sp>
+        <p:nvSpPr>
+          <p:cNvPr id="25" name="Rechteck 24">
+            <a:extLst>
+              <a:ext uri="{FF2B5EF4-FFF2-40B4-BE49-F238E27FC236}">
+                <a16:creationId xmlns:a16="http://schemas.microsoft.com/office/drawing/2014/main" id="{8F377EB4-8892-4473-148D-5E76212829CC}"/>
+              </a:ext>
+            </a:extLst>
+          </p:cNvPr>
+          <p:cNvSpPr/>
+          <p:nvPr/>
+        </p:nvSpPr>
+        <p:spPr>
+          <a:xfrm>
+            <a:off x="9120336" y="3187688"/>
+            <a:ext cx="890017" cy="566317"/>
+          </a:xfrm>
+          <a:prstGeom prst="rect">
+            <a:avLst/>
+          </a:prstGeom>
+          <a:solidFill>
+            <a:schemeClr val="accent1">
+              <a:lumMod val="20000"/>
+              <a:lumOff val="80000"/>
+            </a:schemeClr>
+          </a:solidFill>
+          <a:ln>
+            <a:noFill/>
+          </a:ln>
+        </p:spPr>
+        <p:style>
+          <a:lnRef idx="2">
+            <a:schemeClr val="accent1">
+              <a:shade val="15000"/>
+            </a:schemeClr>
+          </a:lnRef>
+          <a:fillRef idx="1">
+            <a:schemeClr val="accent1"/>
+          </a:fillRef>
+          <a:effectRef idx="0">
+            <a:schemeClr val="accent1"/>
+          </a:effectRef>
+          <a:fontRef idx="minor">
+            <a:schemeClr val="lt1"/>
+          </a:fontRef>
+        </p:style>
+        <p:txBody>
+          <a:bodyPr rtlCol="0" anchor="ctr"/>
+          <a:lstStyle/>
+          <a:p>
+            <a:r>
+              <a:rPr lang="de-DE" sz="1100" dirty="0">
+                <a:solidFill>
+                  <a:schemeClr val="tx1">
+                    <a:lumMod val="75000"/>
+                  </a:schemeClr>
+                </a:solidFill>
+              </a:rPr>
+              <a:t>Endgültige Bezahlung</a:t>
+            </a:r>
+          </a:p>
+        </p:txBody>
+      </p:sp>
+      <p:sp>
+        <p:nvSpPr>
+          <p:cNvPr id="26" name="Rechteck 25">
+            <a:extLst>
+              <a:ext uri="{FF2B5EF4-FFF2-40B4-BE49-F238E27FC236}">
+                <a16:creationId xmlns:a16="http://schemas.microsoft.com/office/drawing/2014/main" id="{F0095B18-6DA2-D9DB-0823-470723321373}"/>
+              </a:ext>
+            </a:extLst>
+          </p:cNvPr>
+          <p:cNvSpPr/>
+          <p:nvPr/>
+        </p:nvSpPr>
+        <p:spPr>
+          <a:xfrm>
+            <a:off x="8889912" y="1470116"/>
+            <a:ext cx="1394792" cy="910637"/>
+          </a:xfrm>
+          <a:prstGeom prst="rect">
+            <a:avLst/>
+          </a:prstGeom>
+          <a:solidFill>
+            <a:schemeClr val="accent1">
+              <a:lumMod val="20000"/>
+              <a:lumOff val="80000"/>
+            </a:schemeClr>
+          </a:solidFill>
+          <a:ln>
+            <a:noFill/>
+          </a:ln>
+        </p:spPr>
+        <p:style>
+          <a:lnRef idx="2">
+            <a:schemeClr val="accent1">
+              <a:shade val="15000"/>
+            </a:schemeClr>
+          </a:lnRef>
+          <a:fillRef idx="1">
+            <a:schemeClr val="accent1"/>
+          </a:fillRef>
+          <a:effectRef idx="0">
+            <a:schemeClr val="accent1"/>
+          </a:effectRef>
+          <a:fontRef idx="minor">
+            <a:schemeClr val="lt1"/>
+          </a:fontRef>
+        </p:style>
+        <p:txBody>
+          <a:bodyPr rtlCol="0" anchor="ctr"/>
+          <a:lstStyle/>
+          <a:p>
+            <a:r>
+              <a:rPr lang="de-DE" sz="1100" dirty="0">
+                <a:solidFill>
+                  <a:schemeClr val="tx1">
+                    <a:lumMod val="75000"/>
+                  </a:schemeClr>
+                </a:solidFill>
+              </a:rPr>
+              <a:t>Prüfung auf Einhaltung der handwerklichen Sorgfalt UND…</a:t>
+            </a:r>
+          </a:p>
+          <a:p>
+            <a:r>
+              <a:rPr lang="de-DE" sz="1100" dirty="0">
+                <a:solidFill>
+                  <a:schemeClr val="tx1">
+                    <a:lumMod val="75000"/>
+                  </a:schemeClr>
+                </a:solidFill>
+              </a:rPr>
+              <a:t>der  Bauzeichnung</a:t>
+            </a:r>
+          </a:p>
+        </p:txBody>
+      </p:sp>
+      <p:sp>
+        <p:nvSpPr>
+          <p:cNvPr id="10" name="Textfeld 9">
+            <a:extLst>
+              <a:ext uri="{FF2B5EF4-FFF2-40B4-BE49-F238E27FC236}">
+                <a16:creationId xmlns:a16="http://schemas.microsoft.com/office/drawing/2014/main" id="{57FF0BA4-635F-F5C5-CDAF-C517669281C3}"/>
+              </a:ext>
+            </a:extLst>
+          </p:cNvPr>
+          <p:cNvSpPr txBox="1"/>
+          <p:nvPr/>
+        </p:nvSpPr>
+        <p:spPr>
+          <a:xfrm>
+            <a:off x="322327" y="3379649"/>
+            <a:ext cx="813043" cy="246221"/>
+          </a:xfrm>
+          <a:prstGeom prst="rect">
+            <a:avLst/>
+          </a:prstGeom>
+          <a:noFill/>
+        </p:spPr>
+        <p:txBody>
+          <a:bodyPr wrap="none" rtlCol="0">
+            <a:spAutoFit/>
+          </a:bodyPr>
+          <a:lstStyle/>
+          <a:p>
+            <a:r>
+              <a:rPr lang="de-DE" sz="1000" dirty="0"/>
+              <a:t>Ergebnisse</a:t>
+            </a:r>
+          </a:p>
+        </p:txBody>
+      </p:sp>
+      <p:sp>
+        <p:nvSpPr>
+          <p:cNvPr id="38" name="Textfeld 37">
+            <a:extLst>
+              <a:ext uri="{FF2B5EF4-FFF2-40B4-BE49-F238E27FC236}">
+                <a16:creationId xmlns:a16="http://schemas.microsoft.com/office/drawing/2014/main" id="{CF478221-199D-AF4C-0FED-FB0D256F3434}"/>
+              </a:ext>
+            </a:extLst>
+          </p:cNvPr>
+          <p:cNvSpPr txBox="1"/>
+          <p:nvPr/>
+        </p:nvSpPr>
+        <p:spPr>
+          <a:xfrm>
+            <a:off x="4763943" y="1509957"/>
+            <a:ext cx="1856598" cy="400110"/>
+          </a:xfrm>
+          <a:prstGeom prst="rect">
+            <a:avLst/>
+          </a:prstGeom>
+          <a:noFill/>
+        </p:spPr>
+        <p:txBody>
+          <a:bodyPr wrap="none" rtlCol="0">
+            <a:spAutoFit/>
+          </a:bodyPr>
+          <a:lstStyle/>
+          <a:p>
+            <a:r>
+              <a:rPr lang="de-DE" sz="2000" b="1" dirty="0" err="1"/>
+              <a:t>Craftsmanship</a:t>
+            </a:r>
+            <a:endParaRPr lang="de-DE" sz="2000" b="1" dirty="0"/>
+          </a:p>
+        </p:txBody>
+      </p:sp>
+      <p:grpSp>
+        <p:nvGrpSpPr>
+          <p:cNvPr id="3" name="Gruppieren 2">
+            <a:extLst>
+              <a:ext uri="{FF2B5EF4-FFF2-40B4-BE49-F238E27FC236}">
+                <a16:creationId xmlns:a16="http://schemas.microsoft.com/office/drawing/2014/main" id="{971190BC-F846-BBC2-5180-21DB908E3AC9}"/>
+              </a:ext>
+            </a:extLst>
+          </p:cNvPr>
+          <p:cNvGrpSpPr/>
+          <p:nvPr/>
+        </p:nvGrpSpPr>
+        <p:grpSpPr>
+          <a:xfrm>
+            <a:off x="751379" y="4282226"/>
+            <a:ext cx="9953133" cy="1739062"/>
+            <a:chOff x="751379" y="4282226"/>
+            <a:chExt cx="9953133" cy="1739062"/>
+          </a:xfrm>
+        </p:grpSpPr>
+        <p:sp>
+          <p:nvSpPr>
+            <p:cNvPr id="29" name="Pfeil: Chevron 28">
+              <a:extLst>
+                <a:ext uri="{FF2B5EF4-FFF2-40B4-BE49-F238E27FC236}">
+                  <a16:creationId xmlns:a16="http://schemas.microsoft.com/office/drawing/2014/main" id="{A85A51D4-C46E-0891-FD98-89FF220F8E2F}"/>
+                </a:ext>
+              </a:extLst>
+            </p:cNvPr>
+            <p:cNvSpPr/>
+            <p:nvPr/>
+          </p:nvSpPr>
+          <p:spPr>
+            <a:xfrm>
+              <a:off x="846312" y="4690850"/>
+              <a:ext cx="2088232" cy="1080120"/>
+            </a:xfrm>
+            <a:prstGeom prst="chevron">
+              <a:avLst>
+                <a:gd name="adj" fmla="val 26529"/>
+              </a:avLst>
+            </a:prstGeom>
+            <a:solidFill>
+              <a:srgbClr val="FFC000"/>
+            </a:solidFill>
+            <a:ln w="9525" cap="flat" cmpd="sng" algn="ctr">
+              <a:noFill/>
+              <a:prstDash val="solid"/>
+            </a:ln>
+            <a:effectLst/>
+          </p:spPr>
+          <p:txBody>
+            <a:bodyPr rtlCol="0" anchor="ctr"/>
+            <a:lstStyle/>
+            <a:p>
+              <a:pPr algn="ctr"/>
+              <a:endParaRPr lang="de-DE" sz="2000" dirty="0"/>
+            </a:p>
+            <a:p>
+              <a:pPr algn="ctr"/>
+              <a:r>
+                <a:rPr lang="de-DE" sz="2000" dirty="0"/>
+                <a:t>Change</a:t>
+              </a:r>
+            </a:p>
+            <a:p>
+              <a:pPr algn="ctr"/>
+              <a:r>
+                <a:rPr lang="de-DE" sz="2000" dirty="0"/>
+                <a:t>Request</a:t>
+              </a:r>
+            </a:p>
+            <a:p>
+              <a:pPr marL="0" marR="0" indent="0" algn="ctr" defTabSz="914400" eaLnBrk="1" fontAlgn="auto" latinLnBrk="0" hangingPunct="1">
+                <a:lnSpc>
+                  <a:spcPct val="100000"/>
+                </a:lnSpc>
+                <a:spcBef>
+                  <a:spcPts val="0"/>
+                </a:spcBef>
+                <a:spcAft>
+                  <a:spcPts val="0"/>
+                </a:spcAft>
+                <a:buClrTx/>
+                <a:buSzTx/>
+                <a:buFontTx/>
+                <a:buNone/>
+                <a:tabLst/>
+              </a:pPr>
+              <a:endParaRPr kumimoji="0" lang="de-DE" sz="2000" b="1" i="0" u="none" strike="noStrike" kern="0" cap="none" spc="0" normalizeH="0" baseline="0" noProof="0" dirty="0">
+                <a:ln>
+                  <a:noFill/>
+                </a:ln>
+                <a:effectLst/>
+                <a:uLnTx/>
+                <a:uFillTx/>
+                <a:latin typeface="Arial" panose="020B0604020202020204"/>
+                <a:ea typeface="+mn-ea"/>
+                <a:cs typeface="Arial" panose="020B0604020202020204" pitchFamily="34" charset="0"/>
+              </a:endParaRPr>
+            </a:p>
+          </p:txBody>
+        </p:sp>
+        <p:sp>
+          <p:nvSpPr>
+            <p:cNvPr id="30" name="Pfeil: Chevron 29">
+              <a:extLst>
+                <a:ext uri="{FF2B5EF4-FFF2-40B4-BE49-F238E27FC236}">
+                  <a16:creationId xmlns:a16="http://schemas.microsoft.com/office/drawing/2014/main" id="{1ACD9667-B1FA-D522-12C2-FA5D1286A847}"/>
+                </a:ext>
+              </a:extLst>
+            </p:cNvPr>
+            <p:cNvSpPr/>
+            <p:nvPr/>
+          </p:nvSpPr>
+          <p:spPr>
+            <a:xfrm>
+              <a:off x="2788920" y="4686863"/>
+              <a:ext cx="2088232" cy="1080120"/>
+            </a:xfrm>
+            <a:prstGeom prst="chevron">
+              <a:avLst>
+                <a:gd name="adj" fmla="val 26529"/>
+              </a:avLst>
+            </a:prstGeom>
+            <a:solidFill>
+              <a:srgbClr val="FFC000"/>
+            </a:solidFill>
+            <a:ln w="9525" cap="flat" cmpd="sng" algn="ctr">
+              <a:noFill/>
+              <a:prstDash val="solid"/>
+            </a:ln>
+            <a:effectLst/>
+          </p:spPr>
+          <p:txBody>
+            <a:bodyPr rtlCol="0" anchor="ctr"/>
+            <a:lstStyle/>
+            <a:p>
+              <a:pPr algn="ctr"/>
+              <a:endParaRPr lang="de-DE" sz="2000" dirty="0"/>
+            </a:p>
+            <a:p>
+              <a:pPr algn="ctr"/>
+              <a:r>
+                <a:rPr lang="de-DE" sz="2000" dirty="0" err="1"/>
+                <a:t>Refinement</a:t>
+              </a:r>
+              <a:endParaRPr lang="de-DE" sz="2000" dirty="0"/>
+            </a:p>
+            <a:p>
+              <a:pPr marL="0" marR="0" indent="0" algn="ctr" defTabSz="914400" eaLnBrk="1" fontAlgn="auto" latinLnBrk="0" hangingPunct="1">
+                <a:lnSpc>
+                  <a:spcPct val="100000"/>
+                </a:lnSpc>
+                <a:spcBef>
+                  <a:spcPts val="0"/>
+                </a:spcBef>
+                <a:spcAft>
+                  <a:spcPts val="0"/>
+                </a:spcAft>
+                <a:buClrTx/>
+                <a:buSzTx/>
+                <a:buFontTx/>
+                <a:buNone/>
+                <a:tabLst/>
+              </a:pPr>
+              <a:endParaRPr kumimoji="0" lang="de-DE" sz="2000" b="1" i="0" u="none" strike="noStrike" kern="0" cap="none" spc="0" normalizeH="0" baseline="0" noProof="0" dirty="0">
+                <a:ln>
+                  <a:noFill/>
+                </a:ln>
+                <a:effectLst/>
+                <a:uLnTx/>
+                <a:uFillTx/>
+                <a:latin typeface="Arial" panose="020B0604020202020204"/>
+                <a:ea typeface="+mn-ea"/>
+                <a:cs typeface="Arial" panose="020B0604020202020204" pitchFamily="34" charset="0"/>
+              </a:endParaRPr>
+            </a:p>
+          </p:txBody>
+        </p:sp>
+        <p:sp>
+          <p:nvSpPr>
+            <p:cNvPr id="31" name="Pfeil: Chevron 30">
+              <a:extLst>
+                <a:ext uri="{FF2B5EF4-FFF2-40B4-BE49-F238E27FC236}">
+                  <a16:creationId xmlns:a16="http://schemas.microsoft.com/office/drawing/2014/main" id="{22BCD251-A12D-9382-7780-746A2E996C6E}"/>
+                </a:ext>
+              </a:extLst>
+            </p:cNvPr>
+            <p:cNvSpPr/>
+            <p:nvPr/>
+          </p:nvSpPr>
+          <p:spPr>
+            <a:xfrm>
+              <a:off x="4731373" y="4690850"/>
+              <a:ext cx="2088232" cy="1080120"/>
+            </a:xfrm>
+            <a:prstGeom prst="chevron">
+              <a:avLst>
+                <a:gd name="adj" fmla="val 26529"/>
+              </a:avLst>
+            </a:prstGeom>
+            <a:solidFill>
+              <a:srgbClr val="FFC000"/>
+            </a:solidFill>
+            <a:ln w="9525" cap="flat" cmpd="sng" algn="ctr">
+              <a:noFill/>
+              <a:prstDash val="solid"/>
+            </a:ln>
+            <a:effectLst/>
+          </p:spPr>
+          <p:txBody>
+            <a:bodyPr rtlCol="0" anchor="ctr"/>
+            <a:lstStyle/>
+            <a:p>
+              <a:pPr algn="ctr"/>
+              <a:endParaRPr lang="de-DE" sz="2000" dirty="0"/>
+            </a:p>
+            <a:p>
+              <a:pPr algn="ctr"/>
+              <a:r>
+                <a:rPr lang="de-DE" sz="3200" b="1" dirty="0">
+                  <a:latin typeface="Open Sans" panose="020B0606030504020204" pitchFamily="34" charset="0"/>
+                  <a:ea typeface="Open Sans" panose="020B0606030504020204" pitchFamily="34" charset="0"/>
+                  <a:cs typeface="Open Sans" panose="020B0606030504020204" pitchFamily="34" charset="0"/>
+                </a:rPr>
+                <a:t>?</a:t>
+              </a:r>
+            </a:p>
+            <a:p>
+              <a:pPr marL="0" marR="0" indent="0" algn="ctr" defTabSz="914400" eaLnBrk="1" fontAlgn="auto" latinLnBrk="0" hangingPunct="1">
+                <a:lnSpc>
+                  <a:spcPct val="100000"/>
+                </a:lnSpc>
+                <a:spcBef>
+                  <a:spcPts val="0"/>
+                </a:spcBef>
+                <a:spcAft>
+                  <a:spcPts val="0"/>
+                </a:spcAft>
+                <a:buClrTx/>
+                <a:buSzTx/>
+                <a:buFontTx/>
+                <a:buNone/>
+                <a:tabLst/>
+              </a:pPr>
+              <a:endParaRPr kumimoji="0" lang="de-DE" sz="2000" b="1" i="0" u="none" strike="noStrike" kern="0" cap="none" spc="0" normalizeH="0" baseline="0" noProof="0" dirty="0">
+                <a:ln>
+                  <a:noFill/>
+                </a:ln>
+                <a:effectLst/>
+                <a:uLnTx/>
+                <a:uFillTx/>
+                <a:latin typeface="Arial" panose="020B0604020202020204"/>
+                <a:ea typeface="+mn-ea"/>
+                <a:cs typeface="Arial" panose="020B0604020202020204" pitchFamily="34" charset="0"/>
+              </a:endParaRPr>
+            </a:p>
+          </p:txBody>
+        </p:sp>
+        <p:sp>
+          <p:nvSpPr>
+            <p:cNvPr id="32" name="Pfeil: Chevron 31">
+              <a:extLst>
+                <a:ext uri="{FF2B5EF4-FFF2-40B4-BE49-F238E27FC236}">
+                  <a16:creationId xmlns:a16="http://schemas.microsoft.com/office/drawing/2014/main" id="{45B47365-D35F-BB0C-46EF-1950C2F220C5}"/>
+                </a:ext>
+              </a:extLst>
+            </p:cNvPr>
+            <p:cNvSpPr/>
+            <p:nvPr/>
+          </p:nvSpPr>
+          <p:spPr>
+            <a:xfrm>
+              <a:off x="6672064" y="4702657"/>
+              <a:ext cx="2088232" cy="1080120"/>
+            </a:xfrm>
+            <a:prstGeom prst="chevron">
+              <a:avLst>
+                <a:gd name="adj" fmla="val 26529"/>
+              </a:avLst>
+            </a:prstGeom>
+            <a:solidFill>
+              <a:srgbClr val="FFC000"/>
+            </a:solidFill>
+            <a:ln w="9525" cap="flat" cmpd="sng" algn="ctr">
+              <a:noFill/>
+              <a:prstDash val="solid"/>
+            </a:ln>
+            <a:effectLst/>
+          </p:spPr>
+          <p:txBody>
+            <a:bodyPr rtlCol="0" anchor="ctr"/>
+            <a:lstStyle/>
+            <a:p>
+              <a:pPr algn="ctr"/>
+              <a:endParaRPr lang="de-DE" sz="2000" dirty="0"/>
+            </a:p>
+            <a:p>
+              <a:pPr algn="ctr"/>
+              <a:r>
+                <a:rPr lang="de-DE" sz="2000" dirty="0" err="1"/>
+                <a:t>Implemen-tierung</a:t>
+              </a:r>
+              <a:endParaRPr lang="de-DE" sz="2000" dirty="0"/>
+            </a:p>
+            <a:p>
+              <a:pPr marL="0" marR="0" indent="0" algn="ctr" defTabSz="914400" eaLnBrk="1" fontAlgn="auto" latinLnBrk="0" hangingPunct="1">
+                <a:lnSpc>
+                  <a:spcPct val="100000"/>
+                </a:lnSpc>
+                <a:spcBef>
+                  <a:spcPts val="0"/>
+                </a:spcBef>
+                <a:spcAft>
+                  <a:spcPts val="0"/>
+                </a:spcAft>
+                <a:buClrTx/>
+                <a:buSzTx/>
+                <a:buFontTx/>
+                <a:buNone/>
+                <a:tabLst/>
+              </a:pPr>
+              <a:endParaRPr kumimoji="0" lang="de-DE" sz="2000" b="1" i="0" u="none" strike="noStrike" kern="0" cap="none" spc="0" normalizeH="0" baseline="0" noProof="0" dirty="0">
+                <a:ln>
+                  <a:noFill/>
+                </a:ln>
+                <a:effectLst/>
+                <a:uLnTx/>
+                <a:uFillTx/>
+                <a:latin typeface="Arial" panose="020B0604020202020204"/>
+                <a:ea typeface="+mn-ea"/>
+                <a:cs typeface="Arial" panose="020B0604020202020204" pitchFamily="34" charset="0"/>
+              </a:endParaRPr>
+            </a:p>
+          </p:txBody>
+        </p:sp>
+        <p:sp>
+          <p:nvSpPr>
+            <p:cNvPr id="33" name="Pfeil: Chevron 32">
+              <a:extLst>
+                <a:ext uri="{FF2B5EF4-FFF2-40B4-BE49-F238E27FC236}">
+                  <a16:creationId xmlns:a16="http://schemas.microsoft.com/office/drawing/2014/main" id="{98892B3B-6C34-827D-9635-A38513A38425}"/>
+                </a:ext>
+              </a:extLst>
+            </p:cNvPr>
+            <p:cNvSpPr/>
+            <p:nvPr/>
+          </p:nvSpPr>
+          <p:spPr>
+            <a:xfrm>
+              <a:off x="8616280" y="4701530"/>
+              <a:ext cx="2088232" cy="1080120"/>
+            </a:xfrm>
+            <a:prstGeom prst="chevron">
+              <a:avLst>
+                <a:gd name="adj" fmla="val 26529"/>
+              </a:avLst>
+            </a:prstGeom>
+            <a:solidFill>
+              <a:srgbClr val="FFC000"/>
+            </a:solidFill>
+            <a:ln w="9525" cap="flat" cmpd="sng" algn="ctr">
+              <a:noFill/>
+              <a:prstDash val="solid"/>
+            </a:ln>
+            <a:effectLst/>
+          </p:spPr>
+          <p:txBody>
+            <a:bodyPr rtlCol="0" anchor="ctr"/>
+            <a:lstStyle/>
+            <a:p>
+              <a:pPr algn="ctr"/>
+              <a:endParaRPr lang="de-DE" sz="2000" dirty="0"/>
+            </a:p>
+            <a:p>
+              <a:pPr algn="ctr"/>
+              <a:r>
+                <a:rPr lang="de-DE" sz="2000" dirty="0"/>
+                <a:t>Akzeptanz-test</a:t>
+              </a:r>
+            </a:p>
+            <a:p>
+              <a:pPr marL="0" marR="0" indent="0" algn="ctr" defTabSz="914400" eaLnBrk="1" fontAlgn="auto" latinLnBrk="0" hangingPunct="1">
+                <a:lnSpc>
+                  <a:spcPct val="100000"/>
+                </a:lnSpc>
+                <a:spcBef>
+                  <a:spcPts val="0"/>
+                </a:spcBef>
+                <a:spcAft>
+                  <a:spcPts val="0"/>
+                </a:spcAft>
+                <a:buClrTx/>
+                <a:buSzTx/>
+                <a:buFontTx/>
+                <a:buNone/>
+                <a:tabLst/>
+              </a:pPr>
+              <a:endParaRPr kumimoji="0" lang="de-DE" sz="2000" b="1" i="0" u="none" strike="noStrike" kern="0" cap="none" spc="0" normalizeH="0" baseline="0" noProof="0" dirty="0">
+                <a:ln>
+                  <a:noFill/>
+                </a:ln>
+                <a:effectLst/>
+                <a:uLnTx/>
+                <a:uFillTx/>
+                <a:latin typeface="Arial" panose="020B0604020202020204"/>
+                <a:ea typeface="+mn-ea"/>
+                <a:cs typeface="Arial" panose="020B0604020202020204" pitchFamily="34" charset="0"/>
+              </a:endParaRPr>
+            </a:p>
+          </p:txBody>
+        </p:sp>
+        <p:sp>
+          <p:nvSpPr>
+            <p:cNvPr id="39" name="Textfeld 38">
+              <a:extLst>
+                <a:ext uri="{FF2B5EF4-FFF2-40B4-BE49-F238E27FC236}">
+                  <a16:creationId xmlns:a16="http://schemas.microsoft.com/office/drawing/2014/main" id="{6738E563-6448-29A0-A8FD-C14905D10A50}"/>
+                </a:ext>
+              </a:extLst>
+            </p:cNvPr>
+            <p:cNvSpPr txBox="1"/>
+            <p:nvPr/>
+          </p:nvSpPr>
+          <p:spPr>
+            <a:xfrm>
+              <a:off x="751379" y="4282226"/>
+              <a:ext cx="2940228" cy="400110"/>
+            </a:xfrm>
+            <a:prstGeom prst="rect">
+              <a:avLst/>
+            </a:prstGeom>
+            <a:noFill/>
+          </p:spPr>
+          <p:txBody>
+            <a:bodyPr wrap="none" rtlCol="0">
+              <a:spAutoFit/>
+            </a:bodyPr>
+            <a:lstStyle/>
+            <a:p>
+              <a:r>
+                <a:rPr lang="de-DE" sz="2000" b="1" dirty="0"/>
+                <a:t>Software </a:t>
+              </a:r>
+              <a:r>
+                <a:rPr lang="de-DE" sz="2000" b="1" dirty="0" err="1"/>
+                <a:t>Craftsmanship</a:t>
+              </a:r>
+              <a:endParaRPr lang="de-DE" sz="2000" b="1" dirty="0"/>
+            </a:p>
+          </p:txBody>
+        </p:sp>
+        <p:sp>
+          <p:nvSpPr>
+            <p:cNvPr id="41" name="Textfeld 40">
+              <a:extLst>
+                <a:ext uri="{FF2B5EF4-FFF2-40B4-BE49-F238E27FC236}">
+                  <a16:creationId xmlns:a16="http://schemas.microsoft.com/office/drawing/2014/main" id="{CA3508D3-D3E2-FE35-F9AB-143FE218DA85}"/>
+                </a:ext>
+              </a:extLst>
+            </p:cNvPr>
+            <p:cNvSpPr txBox="1"/>
+            <p:nvPr/>
+          </p:nvSpPr>
+          <p:spPr>
+            <a:xfrm>
+              <a:off x="1232905" y="5775067"/>
+              <a:ext cx="8040216" cy="246221"/>
+            </a:xfrm>
+            <a:prstGeom prst="rect">
+              <a:avLst/>
+            </a:prstGeom>
+            <a:noFill/>
+          </p:spPr>
+          <p:txBody>
+            <a:bodyPr wrap="square">
+              <a:spAutoFit/>
+            </a:bodyPr>
+            <a:lstStyle/>
+            <a:p>
+              <a:r>
+                <a:rPr lang="de-DE" sz="1000" dirty="0"/>
+                <a:t>Design </a:t>
+              </a:r>
+              <a:r>
+                <a:rPr lang="de-DE" sz="1000" dirty="0" err="1"/>
+                <a:t>before</a:t>
+              </a:r>
+              <a:r>
+                <a:rPr lang="de-DE" sz="1000" dirty="0"/>
+                <a:t> Implementation: https://clean-code-developer.de/en/the-straight/blue-degree/#elementor-toc__heading-anchor-5</a:t>
+              </a:r>
+            </a:p>
+          </p:txBody>
+        </p:sp>
+      </p:grpSp>
+      <p:sp>
+        <p:nvSpPr>
+          <p:cNvPr id="5" name="Textfeld 4">
+            <a:extLst>
+              <a:ext uri="{FF2B5EF4-FFF2-40B4-BE49-F238E27FC236}">
+                <a16:creationId xmlns:a16="http://schemas.microsoft.com/office/drawing/2014/main" id="{16FDA4B5-FDE3-B5D8-39A0-BDBC7C45E5E6}"/>
+              </a:ext>
+            </a:extLst>
+          </p:cNvPr>
+          <p:cNvSpPr txBox="1"/>
+          <p:nvPr/>
+        </p:nvSpPr>
+        <p:spPr>
+          <a:xfrm rot="20912112">
+            <a:off x="5039329" y="5026868"/>
+            <a:ext cx="1635384" cy="400110"/>
+          </a:xfrm>
+          <a:prstGeom prst="rect">
+            <a:avLst/>
+          </a:prstGeom>
+          <a:solidFill>
+            <a:srgbClr val="FFC000"/>
+          </a:solidFill>
+        </p:spPr>
+        <p:txBody>
+          <a:bodyPr wrap="none" rtlCol="0">
+            <a:spAutoFit/>
+          </a:bodyPr>
+          <a:lstStyle/>
+          <a:p>
+            <a:r>
+              <a:rPr lang="de-DE" sz="2000" b="1" dirty="0"/>
+              <a:t>Spezifikation</a:t>
+            </a:r>
+          </a:p>
+        </p:txBody>
+      </p:sp>
+    </p:spTree>
+    <p:extLst>
+      <p:ext uri="{BB962C8B-B14F-4D97-AF65-F5344CB8AC3E}">
+        <p14:creationId xmlns:p14="http://schemas.microsoft.com/office/powerpoint/2010/main" val="4083945008"/>
+      </p:ext>
+    </p:extLst>
+  </p:cSld>
+  <p:clrMapOvr>
+    <a:masterClrMapping/>
+  </p:clrMapOvr>
+  <p:timing>
+    <p:tnLst>
+      <p:par>
+        <p:cTn id="1" dur="indefinite" restart="never" nodeType="tmRoot">
+          <p:childTnLst>
+            <p:seq concurrent="1" nextAc="seek">
+              <p:cTn id="2" dur="indefinite" nodeType="mainSeq">
+                <p:childTnLst>
+                  <p:par>
+                    <p:cTn id="3" fill="hold">
+                      <p:stCondLst>
+                        <p:cond delay="indefinite"/>
+                      </p:stCondLst>
+                      <p:childTnLst>
+                        <p:par>
+                          <p:cTn id="4" fill="hold">
+                            <p:stCondLst>
+                              <p:cond delay="0"/>
+                            </p:stCondLst>
+                            <p:childTnLst>
+                              <p:par>
+                                <p:cTn id="5" presetID="22" presetClass="entr" presetSubtype="8" fill="hold" nodeType="clickEffect">
+                                  <p:stCondLst>
+                                    <p:cond delay="0"/>
+                                  </p:stCondLst>
+                                  <p:childTnLst>
+                                    <p:set>
+                                      <p:cBhvr>
+                                        <p:cTn id="6" dur="1" fill="hold">
+                                          <p:stCondLst>
+                                            <p:cond delay="0"/>
+                                          </p:stCondLst>
+                                        </p:cTn>
+                                        <p:tgtEl>
+                                          <p:spTgt spid="3"/>
+                                        </p:tgtEl>
+                                        <p:attrNameLst>
+                                          <p:attrName>style.visibility</p:attrName>
+                                        </p:attrNameLst>
+                                      </p:cBhvr>
+                                      <p:to>
+                                        <p:strVal val="visible"/>
+                                      </p:to>
+                                    </p:set>
+                                    <p:animEffect transition="in" filter="wipe(left)">
+                                      <p:cBhvr>
+                                        <p:cTn id="7" dur="500"/>
+                                        <p:tgtEl>
+                                          <p:spTgt spid="3"/>
+                                        </p:tgtEl>
+                                      </p:cBhvr>
+                                    </p:animEffect>
+                                  </p:childTnLst>
+                                </p:cTn>
+                              </p:par>
+                            </p:childTnLst>
+                          </p:cTn>
+                        </p:par>
+                      </p:childTnLst>
+                    </p:cTn>
+                  </p:par>
+                  <p:par>
+                    <p:cTn id="8" fill="hold">
+                      <p:stCondLst>
+                        <p:cond delay="indefinite"/>
+                      </p:stCondLst>
+                      <p:childTnLst>
+                        <p:par>
+                          <p:cTn id="9" fill="hold">
+                            <p:stCondLst>
+                              <p:cond delay="0"/>
+                            </p:stCondLst>
+                            <p:childTnLst>
+                              <p:par>
+                                <p:cTn id="10" presetID="31" presetClass="entr" presetSubtype="0" fill="hold" grpId="0" nodeType="clickEffect">
+                                  <p:stCondLst>
+                                    <p:cond delay="0"/>
+                                  </p:stCondLst>
+                                  <p:childTnLst>
+                                    <p:set>
+                                      <p:cBhvr>
+                                        <p:cTn id="11" dur="1" fill="hold">
+                                          <p:stCondLst>
+                                            <p:cond delay="0"/>
+                                          </p:stCondLst>
+                                        </p:cTn>
+                                        <p:tgtEl>
+                                          <p:spTgt spid="5"/>
+                                        </p:tgtEl>
+                                        <p:attrNameLst>
+                                          <p:attrName>style.visibility</p:attrName>
+                                        </p:attrNameLst>
+                                      </p:cBhvr>
+                                      <p:to>
+                                        <p:strVal val="visible"/>
+                                      </p:to>
+                                    </p:set>
+                                    <p:anim calcmode="lin" valueType="num">
+                                      <p:cBhvr>
+                                        <p:cTn id="12" dur="1000" fill="hold"/>
+                                        <p:tgtEl>
+                                          <p:spTgt spid="5"/>
+                                        </p:tgtEl>
+                                        <p:attrNameLst>
+                                          <p:attrName>ppt_w</p:attrName>
+                                        </p:attrNameLst>
+                                      </p:cBhvr>
+                                      <p:tavLst>
+                                        <p:tav tm="0">
+                                          <p:val>
+                                            <p:fltVal val="0"/>
+                                          </p:val>
+                                        </p:tav>
+                                        <p:tav tm="100000">
+                                          <p:val>
+                                            <p:strVal val="#ppt_w"/>
+                                          </p:val>
+                                        </p:tav>
+                                      </p:tavLst>
+                                    </p:anim>
+                                    <p:anim calcmode="lin" valueType="num">
+                                      <p:cBhvr>
+                                        <p:cTn id="13" dur="1000" fill="hold"/>
+                                        <p:tgtEl>
+                                          <p:spTgt spid="5"/>
+                                        </p:tgtEl>
+                                        <p:attrNameLst>
+                                          <p:attrName>ppt_h</p:attrName>
+                                        </p:attrNameLst>
+                                      </p:cBhvr>
+                                      <p:tavLst>
+                                        <p:tav tm="0">
+                                          <p:val>
+                                            <p:fltVal val="0"/>
+                                          </p:val>
+                                        </p:tav>
+                                        <p:tav tm="100000">
+                                          <p:val>
+                                            <p:strVal val="#ppt_h"/>
+                                          </p:val>
+                                        </p:tav>
+                                      </p:tavLst>
+                                    </p:anim>
+                                    <p:anim calcmode="lin" valueType="num">
+                                      <p:cBhvr>
+                                        <p:cTn id="14" dur="1000" fill="hold"/>
+                                        <p:tgtEl>
+                                          <p:spTgt spid="5"/>
+                                        </p:tgtEl>
+                                        <p:attrNameLst>
+                                          <p:attrName>style.rotation</p:attrName>
+                                        </p:attrNameLst>
+                                      </p:cBhvr>
+                                      <p:tavLst>
+                                        <p:tav tm="0">
+                                          <p:val>
+                                            <p:fltVal val="90"/>
+                                          </p:val>
+                                        </p:tav>
+                                        <p:tav tm="100000">
+                                          <p:val>
+                                            <p:fltVal val="0"/>
+                                          </p:val>
+                                        </p:tav>
+                                      </p:tavLst>
+                                    </p:anim>
+                                    <p:animEffect transition="in" filter="fade">
+                                      <p:cBhvr>
+                                        <p:cTn id="15" dur="1000"/>
+                                        <p:tgtEl>
+                                          <p:spTgt spid="5"/>
+                                        </p:tgtEl>
+                                      </p:cBhvr>
+                                    </p:animEffect>
+                                  </p:childTnLst>
+                                </p:cTn>
+                              </p:par>
+                            </p:childTnLst>
+                          </p:cTn>
+                        </p:par>
+                      </p:childTnLst>
+                    </p:cTn>
+                  </p:par>
+                </p:childTnLst>
+              </p:cTn>
+              <p:prevCondLst>
+                <p:cond evt="onPrev" delay="0">
+                  <p:tgtEl>
+                    <p:sldTgt/>
+                  </p:tgtEl>
+                </p:cond>
+              </p:prevCondLst>
+              <p:nextCondLst>
+                <p:cond evt="onNext" delay="0">
+                  <p:tgtEl>
+                    <p:sldTgt/>
+                  </p:tgtEl>
+                </p:cond>
+              </p:nextCondLst>
+            </p:seq>
+          </p:childTnLst>
+        </p:cTn>
+      </p:par>
+    </p:tnLst>
+    <p:bldLst>
+      <p:bldP spid="5" grpId="0" animBg="1"/>
+    </p:bldLst>
+  </p:timing>
 </p:sld>
 </file>
 
@@ -14368,6 +16904,39 @@
 </file>
 
 <file path=customXml/item1.xml><?xml version="1.0" encoding="utf-8"?>
+<?mso-contentType ?>
+<FormTemplates xmlns="http://schemas.microsoft.com/sharepoint/v3/contenttype/forms">
+  <Display>DocumentLibraryForm</Display>
+  <Edit>DocumentLibraryForm</Edit>
+  <New>DocumentLibraryForm</New>
+</FormTemplates>
+</file>
+
+<file path=customXml/item2.xml><?xml version="1.0" encoding="utf-8"?>
+<?mso-contentType ?>
+<p:Policy xmlns:p="office.server.policy" id="" local="true">
+  <p:Name>Dokument</p:Name>
+  <p:Description/>
+  <p:Statement/>
+  <p:PolicyItems>
+    <p:PolicyItem featureId="Microsoft.Office.RecordsManagement.PolicyFeatures.PolicyLabel" staticId="0x010100EF5765CEE729E1418BE065284ADE3D31|2097993778" UniqueId="018cb3dd-2760-4978-a79e-fe94012d8686">
+      <p:Name>Bezeichnungen</p:Name>
+      <p:Description>Generiert Bezeichnungen, die in Microsoft Office-Dokumente eingefügt werden können, um sicherzustellen, dass Dokumenteigenschaften oder sonstige wichtige Informationen beim Drucken von Dokumenten enthalten sind. Bezeichnungen können auch für die Suche nach Dokumenten verwendet werden.</p:Description>
+      <p:CustomData>
+        <label>
+          <properties>
+            <lock>True</lock>
+          </properties>
+          <segment type="literal">v.</segment>
+          <segment type="metadata">_UIVersionString</segment>
+        </label>
+      </p:CustomData>
+    </p:PolicyItem>
+  </p:PolicyItems>
+</p:Policy>
+</file>
+
+<file path=customXml/item3.xml><?xml version="1.0" encoding="utf-8"?>
 <p:properties xmlns:p="http://schemas.microsoft.com/office/2006/metadata/properties" xmlns:xsi="http://www.w3.org/2001/XMLSchema-instance" xmlns:pc="http://schemas.microsoft.com/office/infopath/2007/PartnerControls">
   <documentManagement>
     <_dlc_DocId xmlns="3ba2c390-782e-48d2-92a4-4ceacf62dc83">SNID-180-47</_dlc_DocId>
@@ -14401,40 +16970,57 @@
 </p:properties>
 </file>
 
-<file path=customXml/item2.xml><?xml version="1.0" encoding="utf-8"?>
+<file path=customXml/item4.xml><?xml version="1.0" encoding="utf-8"?>
 <?mso-contentType ?>
-<p:Policy xmlns:p="office.server.policy" id="" local="true">
-  <p:Name>Dokument</p:Name>
-  <p:Description/>
-  <p:Statement/>
-  <p:PolicyItems>
-    <p:PolicyItem featureId="Microsoft.Office.RecordsManagement.PolicyFeatures.PolicyLabel" staticId="0x010100EF5765CEE729E1418BE065284ADE3D31|2097993778" UniqueId="018cb3dd-2760-4978-a79e-fe94012d8686">
-      <p:Name>Bezeichnungen</p:Name>
-      <p:Description>Generiert Bezeichnungen, die in Microsoft Office-Dokumente eingefügt werden können, um sicherzustellen, dass Dokumenteigenschaften oder sonstige wichtige Informationen beim Drucken von Dokumenten enthalten sind. Bezeichnungen können auch für die Suche nach Dokumenten verwendet werden.</p:Description>
-      <p:CustomData>
-        <label>
-          <properties>
-            <lock>True</lock>
-          </properties>
-          <segment type="literal">v.</segment>
-          <segment type="metadata">_UIVersionString</segment>
-        </label>
-      </p:CustomData>
-    </p:PolicyItem>
-  </p:PolicyItems>
-</p:Policy>
+<spe:Receivers xmlns:spe="http://schemas.microsoft.com/sharepoint/events">
+  <Receiver>
+    <Name>Document ID Generator</Name>
+    <Synchronization>Synchronous</Synchronization>
+    <Type>10001</Type>
+    <SequenceNumber>1000</SequenceNumber>
+    <Url/>
+    <Assembly>Microsoft.Office.DocumentManagement, Version=15.0.0.0, Culture=neutral, PublicKeyToken=71e9bce111e9429c</Assembly>
+    <Class>Microsoft.Office.DocumentManagement.Internal.DocIdHandler</Class>
+    <Data/>
+    <Filter/>
+  </Receiver>
+  <Receiver>
+    <Name>Document ID Generator</Name>
+    <Synchronization>Synchronous</Synchronization>
+    <Type>10002</Type>
+    <SequenceNumber>1001</SequenceNumber>
+    <Url/>
+    <Assembly>Microsoft.Office.DocumentManagement, Version=15.0.0.0, Culture=neutral, PublicKeyToken=71e9bce111e9429c</Assembly>
+    <Class>Microsoft.Office.DocumentManagement.Internal.DocIdHandler</Class>
+    <Data/>
+    <Filter/>
+  </Receiver>
+  <Receiver>
+    <Name>Document ID Generator</Name>
+    <Synchronization>Synchronous</Synchronization>
+    <Type>10004</Type>
+    <SequenceNumber>1002</SequenceNumber>
+    <Url/>
+    <Assembly>Microsoft.Office.DocumentManagement, Version=15.0.0.0, Culture=neutral, PublicKeyToken=71e9bce111e9429c</Assembly>
+    <Class>Microsoft.Office.DocumentManagement.Internal.DocIdHandler</Class>
+    <Data/>
+    <Filter/>
+  </Receiver>
+  <Receiver>
+    <Name>Document ID Generator</Name>
+    <Synchronization>Synchronous</Synchronization>
+    <Type>10006</Type>
+    <SequenceNumber>1003</SequenceNumber>
+    <Url/>
+    <Assembly>Microsoft.Office.DocumentManagement, Version=15.0.0.0, Culture=neutral, PublicKeyToken=71e9bce111e9429c</Assembly>
+    <Class>Microsoft.Office.DocumentManagement.Internal.DocIdHandler</Class>
+    <Data/>
+    <Filter/>
+  </Receiver>
+</spe:Receivers>
 </file>
 
-<file path=customXml/item3.xml><?xml version="1.0" encoding="utf-8"?>
-<?mso-contentType ?>
-<FormTemplates xmlns="http://schemas.microsoft.com/sharepoint/v3/contenttype/forms">
-  <Display>DocumentLibraryForm</Display>
-  <Edit>DocumentLibraryForm</Edit>
-  <New>DocumentLibraryForm</New>
-</FormTemplates>
-</file>
-
-<file path=customXml/item4.xml><?xml version="1.0" encoding="utf-8"?>
+<file path=customXml/item5.xml><?xml version="1.0" encoding="utf-8"?>
 <ct:contentTypeSchema xmlns:ct="http://schemas.microsoft.com/office/2006/metadata/contentType" xmlns:ma="http://schemas.microsoft.com/office/2006/metadata/properties/metaAttributes" ct:_="" ma:_="" ma:contentTypeName="Dokument" ma:contentTypeID="0x010100EF5765CEE729E1418BE065284ADE3D31" ma:contentTypeVersion="29" ma:contentTypeDescription="Ein neues Dokument erstellen." ma:contentTypeScope="" ma:versionID="3d50e400cca5a7bd800a74eb9a530f8f">
   <xsd:schema xmlns:xsd="http://www.w3.org/2001/XMLSchema" xmlns:xs="http://www.w3.org/2001/XMLSchema" xmlns:p="http://schemas.microsoft.com/office/2006/metadata/properties" xmlns:ns1="http://schemas.microsoft.com/sharepoint/v3" xmlns:ns2="b5c6ba39-e055-4528-8d96-942d43fd41f6" xmlns:ns3="3ba2c390-782e-48d2-92a4-4ceacf62dc83" xmlns:ns4="1561a55d-4589-43de-94bb-8dded3e84ec0" targetNamespace="http://schemas.microsoft.com/office/2006/metadata/properties" ma:root="true" ma:fieldsID="5a6f0763cb74c2d9ba07ecaec821d4b1" ns1:_="" ns2:_="" ns3:_="" ns4:_="">
     <xsd:import namespace="http://schemas.microsoft.com/sharepoint/v3"/>
@@ -14779,57 +17365,23 @@
 </ct:contentTypeSchema>
 </file>
 
-<file path=customXml/item5.xml><?xml version="1.0" encoding="utf-8"?>
-<?mso-contentType ?>
-<spe:Receivers xmlns:spe="http://schemas.microsoft.com/sharepoint/events">
-  <Receiver>
-    <Name>Document ID Generator</Name>
-    <Synchronization>Synchronous</Synchronization>
-    <Type>10001</Type>
-    <SequenceNumber>1000</SequenceNumber>
-    <Url/>
-    <Assembly>Microsoft.Office.DocumentManagement, Version=15.0.0.0, Culture=neutral, PublicKeyToken=71e9bce111e9429c</Assembly>
-    <Class>Microsoft.Office.DocumentManagement.Internal.DocIdHandler</Class>
-    <Data/>
-    <Filter/>
-  </Receiver>
-  <Receiver>
-    <Name>Document ID Generator</Name>
-    <Synchronization>Synchronous</Synchronization>
-    <Type>10002</Type>
-    <SequenceNumber>1001</SequenceNumber>
-    <Url/>
-    <Assembly>Microsoft.Office.DocumentManagement, Version=15.0.0.0, Culture=neutral, PublicKeyToken=71e9bce111e9429c</Assembly>
-    <Class>Microsoft.Office.DocumentManagement.Internal.DocIdHandler</Class>
-    <Data/>
-    <Filter/>
-  </Receiver>
-  <Receiver>
-    <Name>Document ID Generator</Name>
-    <Synchronization>Synchronous</Synchronization>
-    <Type>10004</Type>
-    <SequenceNumber>1002</SequenceNumber>
-    <Url/>
-    <Assembly>Microsoft.Office.DocumentManagement, Version=15.0.0.0, Culture=neutral, PublicKeyToken=71e9bce111e9429c</Assembly>
-    <Class>Microsoft.Office.DocumentManagement.Internal.DocIdHandler</Class>
-    <Data/>
-    <Filter/>
-  </Receiver>
-  <Receiver>
-    <Name>Document ID Generator</Name>
-    <Synchronization>Synchronous</Synchronization>
-    <Type>10006</Type>
-    <SequenceNumber>1003</SequenceNumber>
-    <Url/>
-    <Assembly>Microsoft.Office.DocumentManagement, Version=15.0.0.0, Culture=neutral, PublicKeyToken=71e9bce111e9429c</Assembly>
-    <Class>Microsoft.Office.DocumentManagement.Internal.DocIdHandler</Class>
-    <Data/>
-    <Filter/>
-  </Receiver>
-</spe:Receivers>
+<file path=customXml/itemProps1.xml><?xml version="1.0" encoding="utf-8"?>
+<ds:datastoreItem xmlns:ds="http://schemas.openxmlformats.org/officeDocument/2006/customXml" ds:itemID="{BF9375A8-3119-4DA8-B304-E0F5F369DCAD}">
+  <ds:schemaRefs>
+    <ds:schemaRef ds:uri="http://schemas.microsoft.com/sharepoint/v3/contenttype/forms"/>
+  </ds:schemaRefs>
+</ds:datastoreItem>
 </file>
 
-<file path=customXml/itemProps1.xml><?xml version="1.0" encoding="utf-8"?>
+<file path=customXml/itemProps2.xml><?xml version="1.0" encoding="utf-8"?>
+<ds:datastoreItem xmlns:ds="http://schemas.openxmlformats.org/officeDocument/2006/customXml" ds:itemID="{1D4355BD-3339-4747-A9BA-2F7E78B26BF6}">
+  <ds:schemaRefs>
+    <ds:schemaRef ds:uri="office.server.policy"/>
+  </ds:schemaRefs>
+</ds:datastoreItem>
+</file>
+
+<file path=customXml/itemProps3.xml><?xml version="1.0" encoding="utf-8"?>
 <ds:datastoreItem xmlns:ds="http://schemas.openxmlformats.org/officeDocument/2006/customXml" ds:itemID="{E5519D02-F5E4-4D45-BACB-7D3735C24017}">
   <ds:schemaRefs>
     <ds:schemaRef ds:uri="http://schemas.microsoft.com/office/infopath/2007/PartnerControls"/>
@@ -14848,23 +17400,15 @@
 </ds:datastoreItem>
 </file>
 
-<file path=customXml/itemProps2.xml><?xml version="1.0" encoding="utf-8"?>
-<ds:datastoreItem xmlns:ds="http://schemas.openxmlformats.org/officeDocument/2006/customXml" ds:itemID="{1D4355BD-3339-4747-A9BA-2F7E78B26BF6}">
+<file path=customXml/itemProps4.xml><?xml version="1.0" encoding="utf-8"?>
+<ds:datastoreItem xmlns:ds="http://schemas.openxmlformats.org/officeDocument/2006/customXml" ds:itemID="{38B952D7-EB30-489B-97CD-4DF8165C4AB9}">
   <ds:schemaRefs>
-    <ds:schemaRef ds:uri="office.server.policy"/>
+    <ds:schemaRef ds:uri="http://schemas.microsoft.com/sharepoint/events"/>
   </ds:schemaRefs>
 </ds:datastoreItem>
 </file>
 
-<file path=customXml/itemProps3.xml><?xml version="1.0" encoding="utf-8"?>
-<ds:datastoreItem xmlns:ds="http://schemas.openxmlformats.org/officeDocument/2006/customXml" ds:itemID="{BF9375A8-3119-4DA8-B304-E0F5F369DCAD}">
-  <ds:schemaRefs>
-    <ds:schemaRef ds:uri="http://schemas.microsoft.com/sharepoint/v3/contenttype/forms"/>
-  </ds:schemaRefs>
-</ds:datastoreItem>
-</file>
-
-<file path=customXml/itemProps4.xml><?xml version="1.0" encoding="utf-8"?>
+<file path=customXml/itemProps5.xml><?xml version="1.0" encoding="utf-8"?>
 <ds:datastoreItem xmlns:ds="http://schemas.openxmlformats.org/officeDocument/2006/customXml" ds:itemID="{BBCE9F00-598A-4817-82B0-FFE08B1F3937}">
   <ds:schemaRefs>
     <ds:schemaRef ds:uri="http://schemas.microsoft.com/office/2006/metadata/contentType"/>
@@ -14883,12 +17427,4 @@
     <ds:schemaRef ds:uri="http://schemas.microsoft.com/internal/obd"/>
   </ds:schemaRefs>
 </ds:datastoreItem>
-</file>
-
-<file path=customXml/itemProps5.xml><?xml version="1.0" encoding="utf-8"?>
-<ds:datastoreItem xmlns:ds="http://schemas.openxmlformats.org/officeDocument/2006/customXml" ds:itemID="{38B952D7-EB30-489B-97CD-4DF8165C4AB9}">
-  <ds:schemaRefs>
-    <ds:schemaRef ds:uri="http://schemas.microsoft.com/sharepoint/events"/>
-  </ds:schemaRefs>
-</ds:datastoreItem>
 </file>
</xml_diff>

<commit_message>
Starting point für Dojo 2
</commit_message>
<xml_diff>
--- a/ki-thementag-dojos.pptx
+++ b/ki-thementag-dojos.pptx
@@ -5,13 +5,14 @@
     <p:sldMasterId id="2147483661" r:id="rId6"/>
   </p:sldMasterIdLst>
   <p:notesMasterIdLst>
-    <p:notesMasterId r:id="rId8"/>
+    <p:notesMasterId r:id="rId9"/>
   </p:notesMasterIdLst>
   <p:handoutMasterIdLst>
-    <p:handoutMasterId r:id="rId9"/>
+    <p:handoutMasterId r:id="rId10"/>
   </p:handoutMasterIdLst>
   <p:sldIdLst>
     <p:sldId id="1329" r:id="rId7"/>
+    <p:sldId id="1331" r:id="rId8"/>
   </p:sldIdLst>
   <p:sldSz cx="12192000" cy="6858000"/>
   <p:notesSz cx="6858000" cy="9144000"/>
@@ -12875,214 +12876,235 @@
           </a:p>
         </p:txBody>
       </p:sp>
-      <p:sp>
-        <p:nvSpPr>
-          <p:cNvPr id="14" name="Inhaltsplatzhalter 4">
-            <a:extLst>
-              <a:ext uri="{FF2B5EF4-FFF2-40B4-BE49-F238E27FC236}">
-                <a16:creationId xmlns:a16="http://schemas.microsoft.com/office/drawing/2014/main" id="{E7A0ACCC-7805-73F9-B351-8863AA5B80DB}"/>
-              </a:ext>
-            </a:extLst>
-          </p:cNvPr>
-          <p:cNvSpPr txBox="1">
-            <a:spLocks/>
-          </p:cNvSpPr>
+      <p:grpSp>
+        <p:nvGrpSpPr>
+          <p:cNvPr id="9" name="Gruppieren 8">
+            <a:extLst>
+              <a:ext uri="{FF2B5EF4-FFF2-40B4-BE49-F238E27FC236}">
+                <a16:creationId xmlns:a16="http://schemas.microsoft.com/office/drawing/2014/main" id="{B3088B3B-64E7-C6F7-B55A-998DE2895A58}"/>
+              </a:ext>
+            </a:extLst>
+          </p:cNvPr>
+          <p:cNvGrpSpPr/>
           <p:nvPr/>
-        </p:nvSpPr>
-        <p:spPr>
-          <a:xfrm>
-            <a:off x="563628" y="5017454"/>
-            <a:ext cx="5616624" cy="1363873"/>
-          </a:xfrm>
-          <a:prstGeom prst="rect">
-            <a:avLst/>
-          </a:prstGeom>
-        </p:spPr>
-        <p:txBody>
-          <a:bodyPr vert="horz" lIns="91440" tIns="45720" rIns="91440" bIns="45720" rtlCol="0">
-            <a:normAutofit/>
-          </a:bodyPr>
-          <a:lstStyle>
-            <a:lvl1pPr marL="342900" indent="-342900" defTabSz="457200">
-              <a:spcBef>
-                <a:spcPts val="600"/>
-              </a:spcBef>
-              <a:buClr>
-                <a:schemeClr val="accent1"/>
-              </a:buClr>
-              <a:buFont typeface="Wingdings" panose="05000000000000000000" pitchFamily="2" charset="2"/>
-              <a:buChar char="§"/>
-              <a:defRPr>
-                <a:latin typeface="Open Sans Light" panose="020B0306030504020204" pitchFamily="34" charset="0"/>
-                <a:ea typeface="Open Sans Light" panose="020B0306030504020204" pitchFamily="34" charset="0"/>
-                <a:cs typeface="Open Sans Light" panose="020B0306030504020204" pitchFamily="34" charset="0"/>
-              </a:defRPr>
-            </a:lvl1pPr>
-            <a:lvl2pPr marL="742950" indent="-285750" defTabSz="457200">
-              <a:spcBef>
-                <a:spcPts val="600"/>
-              </a:spcBef>
-              <a:buClr>
-                <a:schemeClr val="accent1"/>
-              </a:buClr>
-              <a:buFont typeface="Wingdings" panose="05000000000000000000" pitchFamily="2" charset="2"/>
-              <a:buChar char="§"/>
-              <a:defRPr sz="2000">
-                <a:latin typeface="Open Sans Light" panose="020B0306030504020204" pitchFamily="34" charset="0"/>
-                <a:ea typeface="Open Sans Light" panose="020B0306030504020204" pitchFamily="34" charset="0"/>
-                <a:cs typeface="Open Sans Light" panose="020B0306030504020204" pitchFamily="34" charset="0"/>
-              </a:defRPr>
-            </a:lvl2pPr>
-            <a:lvl3pPr marL="1143000" indent="-228600" defTabSz="457200">
-              <a:spcBef>
-                <a:spcPts val="600"/>
-              </a:spcBef>
-              <a:buClr>
-                <a:schemeClr val="accent1"/>
-              </a:buClr>
-              <a:buFont typeface="Wingdings" panose="05000000000000000000" pitchFamily="2" charset="2"/>
-              <a:buChar char="§"/>
-              <a:defRPr sz="1600">
-                <a:latin typeface="Open Sans Light" panose="020B0306030504020204" pitchFamily="34" charset="0"/>
-                <a:ea typeface="Open Sans Light" panose="020B0306030504020204" pitchFamily="34" charset="0"/>
-                <a:cs typeface="Open Sans Light" panose="020B0306030504020204" pitchFamily="34" charset="0"/>
-              </a:defRPr>
-            </a:lvl3pPr>
-            <a:lvl4pPr marL="1600200" indent="-228600" defTabSz="457200">
-              <a:spcBef>
-                <a:spcPts val="600"/>
-              </a:spcBef>
-              <a:buClr>
-                <a:schemeClr val="accent1"/>
-              </a:buClr>
-              <a:buFont typeface="Symbol" panose="05050102010706020507" pitchFamily="18" charset="2"/>
-              <a:buChar char="-"/>
-              <a:defRPr sz="1600">
-                <a:latin typeface="Open Sans Light" panose="020B0306030504020204" pitchFamily="34" charset="0"/>
-                <a:ea typeface="Open Sans Light" panose="020B0306030504020204" pitchFamily="34" charset="0"/>
-                <a:cs typeface="Open Sans Light" panose="020B0306030504020204" pitchFamily="34" charset="0"/>
-              </a:defRPr>
-            </a:lvl4pPr>
-            <a:lvl5pPr marL="2057400" indent="-228600" defTabSz="457200">
-              <a:spcBef>
-                <a:spcPts val="600"/>
-              </a:spcBef>
-              <a:buClr>
-                <a:schemeClr val="accent1"/>
-              </a:buClr>
-              <a:buFont typeface="Symbol" panose="05050102010706020507" pitchFamily="18" charset="2"/>
-              <a:buChar char="-"/>
-              <a:defRPr sz="1200">
-                <a:latin typeface="Open Sans Light" panose="020B0306030504020204" pitchFamily="34" charset="0"/>
-                <a:ea typeface="Open Sans Light" panose="020B0306030504020204" pitchFamily="34" charset="0"/>
-                <a:cs typeface="Open Sans Light" panose="020B0306030504020204" pitchFamily="34" charset="0"/>
-              </a:defRPr>
-            </a:lvl5pPr>
-            <a:lvl6pPr marL="2514600" indent="-228600" defTabSz="457200">
-              <a:spcBef>
-                <a:spcPct val="20000"/>
-              </a:spcBef>
-              <a:buFont typeface="Arial"/>
-              <a:buChar char="•"/>
-              <a:defRPr sz="2000"/>
-            </a:lvl6pPr>
-            <a:lvl7pPr marL="2971800" indent="-228600" defTabSz="457200">
-              <a:spcBef>
-                <a:spcPct val="20000"/>
-              </a:spcBef>
-              <a:buFont typeface="Arial"/>
-              <a:buChar char="•"/>
-              <a:defRPr sz="2000"/>
-            </a:lvl7pPr>
-            <a:lvl8pPr marL="3429000" indent="-228600" defTabSz="457200">
-              <a:spcBef>
-                <a:spcPct val="20000"/>
-              </a:spcBef>
-              <a:buFont typeface="Arial"/>
-              <a:buChar char="•"/>
-              <a:defRPr sz="2000"/>
-            </a:lvl8pPr>
-            <a:lvl9pPr marL="3886200" indent="-228600" defTabSz="457200">
-              <a:spcBef>
-                <a:spcPct val="20000"/>
-              </a:spcBef>
-              <a:buFont typeface="Arial"/>
-              <a:buChar char="•"/>
-              <a:defRPr sz="2000"/>
-            </a:lvl9pPr>
-          </a:lstStyle>
-          <a:p>
-            <a:r>
-              <a:rPr lang="de-DE" dirty="0" err="1"/>
-              <a:t>Refactoring</a:t>
-            </a:r>
-            <a:endParaRPr lang="de-DE" dirty="0"/>
-          </a:p>
-          <a:p>
-            <a:r>
-              <a:rPr lang="de-DE" dirty="0"/>
-              <a:t>Aufräumen des </a:t>
-            </a:r>
-            <a:r>
-              <a:rPr lang="de-DE" dirty="0" err="1"/>
-              <a:t>Spagetticodes</a:t>
-            </a:r>
-            <a:r>
-              <a:rPr lang="de-DE" dirty="0"/>
-              <a:t> mit </a:t>
-            </a:r>
-            <a:r>
-              <a:rPr lang="de-DE" dirty="0" err="1"/>
-              <a:t>Junie</a:t>
-            </a:r>
-            <a:r>
-              <a:rPr lang="de-DE" dirty="0"/>
-              <a:t> Chat</a:t>
-            </a:r>
-          </a:p>
-          <a:p>
-            <a:r>
-              <a:rPr lang="de-DE" dirty="0"/>
-              <a:t>Ggf. parallel mit H.I.</a:t>
-            </a:r>
-          </a:p>
-        </p:txBody>
-      </p:sp>
-      <p:sp>
-        <p:nvSpPr>
-          <p:cNvPr id="17" name="Textfeld 16">
-            <a:extLst>
-              <a:ext uri="{FF2B5EF4-FFF2-40B4-BE49-F238E27FC236}">
-                <a16:creationId xmlns:a16="http://schemas.microsoft.com/office/drawing/2014/main" id="{4CC1568A-F8C6-CD98-2159-5A7A4A0D0068}"/>
-              </a:ext>
-            </a:extLst>
-          </p:cNvPr>
-          <p:cNvSpPr txBox="1"/>
-          <p:nvPr/>
-        </p:nvSpPr>
-        <p:spPr>
+        </p:nvGrpSpPr>
+        <p:grpSpPr>
           <a:xfrm>
             <a:off x="473468" y="4606347"/>
-            <a:ext cx="1499128" cy="461665"/>
-          </a:xfrm>
-          <a:prstGeom prst="rect">
-            <a:avLst/>
-          </a:prstGeom>
-          <a:noFill/>
-        </p:spPr>
-        <p:txBody>
-          <a:bodyPr wrap="none" rtlCol="0">
-            <a:spAutoFit/>
-          </a:bodyPr>
-          <a:lstStyle/>
-          <a:p>
-            <a:r>
-              <a:rPr lang="de-DE" sz="2400" b="1" dirty="0"/>
-              <a:t>2. Stunde</a:t>
-            </a:r>
-          </a:p>
-        </p:txBody>
-      </p:sp>
+            <a:ext cx="5706784" cy="1774980"/>
+            <a:chOff x="473468" y="4606347"/>
+            <a:chExt cx="5706784" cy="1774980"/>
+          </a:xfrm>
+        </p:grpSpPr>
+        <p:sp>
+          <p:nvSpPr>
+            <p:cNvPr id="14" name="Inhaltsplatzhalter 4">
+              <a:extLst>
+                <a:ext uri="{FF2B5EF4-FFF2-40B4-BE49-F238E27FC236}">
+                  <a16:creationId xmlns:a16="http://schemas.microsoft.com/office/drawing/2014/main" id="{E7A0ACCC-7805-73F9-B351-8863AA5B80DB}"/>
+                </a:ext>
+              </a:extLst>
+            </p:cNvPr>
+            <p:cNvSpPr txBox="1">
+              <a:spLocks/>
+            </p:cNvSpPr>
+            <p:nvPr/>
+          </p:nvSpPr>
+          <p:spPr>
+            <a:xfrm>
+              <a:off x="563628" y="5017454"/>
+              <a:ext cx="5616624" cy="1363873"/>
+            </a:xfrm>
+            <a:prstGeom prst="rect">
+              <a:avLst/>
+            </a:prstGeom>
+          </p:spPr>
+          <p:txBody>
+            <a:bodyPr vert="horz" lIns="91440" tIns="45720" rIns="91440" bIns="45720" rtlCol="0">
+              <a:normAutofit/>
+            </a:bodyPr>
+            <a:lstStyle>
+              <a:lvl1pPr marL="342900" indent="-342900" defTabSz="457200">
+                <a:spcBef>
+                  <a:spcPts val="600"/>
+                </a:spcBef>
+                <a:buClr>
+                  <a:schemeClr val="accent1"/>
+                </a:buClr>
+                <a:buFont typeface="Wingdings" panose="05000000000000000000" pitchFamily="2" charset="2"/>
+                <a:buChar char="§"/>
+                <a:defRPr>
+                  <a:latin typeface="Open Sans Light" panose="020B0306030504020204" pitchFamily="34" charset="0"/>
+                  <a:ea typeface="Open Sans Light" panose="020B0306030504020204" pitchFamily="34" charset="0"/>
+                  <a:cs typeface="Open Sans Light" panose="020B0306030504020204" pitchFamily="34" charset="0"/>
+                </a:defRPr>
+              </a:lvl1pPr>
+              <a:lvl2pPr marL="742950" indent="-285750" defTabSz="457200">
+                <a:spcBef>
+                  <a:spcPts val="600"/>
+                </a:spcBef>
+                <a:buClr>
+                  <a:schemeClr val="accent1"/>
+                </a:buClr>
+                <a:buFont typeface="Wingdings" panose="05000000000000000000" pitchFamily="2" charset="2"/>
+                <a:buChar char="§"/>
+                <a:defRPr sz="2000">
+                  <a:latin typeface="Open Sans Light" panose="020B0306030504020204" pitchFamily="34" charset="0"/>
+                  <a:ea typeface="Open Sans Light" panose="020B0306030504020204" pitchFamily="34" charset="0"/>
+                  <a:cs typeface="Open Sans Light" panose="020B0306030504020204" pitchFamily="34" charset="0"/>
+                </a:defRPr>
+              </a:lvl2pPr>
+              <a:lvl3pPr marL="1143000" indent="-228600" defTabSz="457200">
+                <a:spcBef>
+                  <a:spcPts val="600"/>
+                </a:spcBef>
+                <a:buClr>
+                  <a:schemeClr val="accent1"/>
+                </a:buClr>
+                <a:buFont typeface="Wingdings" panose="05000000000000000000" pitchFamily="2" charset="2"/>
+                <a:buChar char="§"/>
+                <a:defRPr sz="1600">
+                  <a:latin typeface="Open Sans Light" panose="020B0306030504020204" pitchFamily="34" charset="0"/>
+                  <a:ea typeface="Open Sans Light" panose="020B0306030504020204" pitchFamily="34" charset="0"/>
+                  <a:cs typeface="Open Sans Light" panose="020B0306030504020204" pitchFamily="34" charset="0"/>
+                </a:defRPr>
+              </a:lvl3pPr>
+              <a:lvl4pPr marL="1600200" indent="-228600" defTabSz="457200">
+                <a:spcBef>
+                  <a:spcPts val="600"/>
+                </a:spcBef>
+                <a:buClr>
+                  <a:schemeClr val="accent1"/>
+                </a:buClr>
+                <a:buFont typeface="Symbol" panose="05050102010706020507" pitchFamily="18" charset="2"/>
+                <a:buChar char="-"/>
+                <a:defRPr sz="1600">
+                  <a:latin typeface="Open Sans Light" panose="020B0306030504020204" pitchFamily="34" charset="0"/>
+                  <a:ea typeface="Open Sans Light" panose="020B0306030504020204" pitchFamily="34" charset="0"/>
+                  <a:cs typeface="Open Sans Light" panose="020B0306030504020204" pitchFamily="34" charset="0"/>
+                </a:defRPr>
+              </a:lvl4pPr>
+              <a:lvl5pPr marL="2057400" indent="-228600" defTabSz="457200">
+                <a:spcBef>
+                  <a:spcPts val="600"/>
+                </a:spcBef>
+                <a:buClr>
+                  <a:schemeClr val="accent1"/>
+                </a:buClr>
+                <a:buFont typeface="Symbol" panose="05050102010706020507" pitchFamily="18" charset="2"/>
+                <a:buChar char="-"/>
+                <a:defRPr sz="1200">
+                  <a:latin typeface="Open Sans Light" panose="020B0306030504020204" pitchFamily="34" charset="0"/>
+                  <a:ea typeface="Open Sans Light" panose="020B0306030504020204" pitchFamily="34" charset="0"/>
+                  <a:cs typeface="Open Sans Light" panose="020B0306030504020204" pitchFamily="34" charset="0"/>
+                </a:defRPr>
+              </a:lvl5pPr>
+              <a:lvl6pPr marL="2514600" indent="-228600" defTabSz="457200">
+                <a:spcBef>
+                  <a:spcPct val="20000"/>
+                </a:spcBef>
+                <a:buFont typeface="Arial"/>
+                <a:buChar char="•"/>
+                <a:defRPr sz="2000"/>
+              </a:lvl6pPr>
+              <a:lvl7pPr marL="2971800" indent="-228600" defTabSz="457200">
+                <a:spcBef>
+                  <a:spcPct val="20000"/>
+                </a:spcBef>
+                <a:buFont typeface="Arial"/>
+                <a:buChar char="•"/>
+                <a:defRPr sz="2000"/>
+              </a:lvl7pPr>
+              <a:lvl8pPr marL="3429000" indent="-228600" defTabSz="457200">
+                <a:spcBef>
+                  <a:spcPct val="20000"/>
+                </a:spcBef>
+                <a:buFont typeface="Arial"/>
+                <a:buChar char="•"/>
+                <a:defRPr sz="2000"/>
+              </a:lvl8pPr>
+              <a:lvl9pPr marL="3886200" indent="-228600" defTabSz="457200">
+                <a:spcBef>
+                  <a:spcPct val="20000"/>
+                </a:spcBef>
+                <a:buFont typeface="Arial"/>
+                <a:buChar char="•"/>
+                <a:defRPr sz="2000"/>
+              </a:lvl9pPr>
+            </a:lstStyle>
+            <a:p>
+              <a:r>
+                <a:rPr lang="de-DE" dirty="0" err="1"/>
+                <a:t>Refactoring</a:t>
+              </a:r>
+              <a:endParaRPr lang="de-DE" dirty="0"/>
+            </a:p>
+            <a:p>
+              <a:r>
+                <a:rPr lang="de-DE" dirty="0"/>
+                <a:t>Aufräumen des </a:t>
+              </a:r>
+              <a:r>
+                <a:rPr lang="de-DE" dirty="0" err="1"/>
+                <a:t>Spagetticodes</a:t>
+              </a:r>
+              <a:r>
+                <a:rPr lang="de-DE" dirty="0"/>
+                <a:t> mit </a:t>
+              </a:r>
+              <a:r>
+                <a:rPr lang="de-DE" dirty="0" err="1"/>
+                <a:t>Junie</a:t>
+              </a:r>
+              <a:r>
+                <a:rPr lang="de-DE" dirty="0"/>
+                <a:t> Chat</a:t>
+              </a:r>
+            </a:p>
+            <a:p>
+              <a:r>
+                <a:rPr lang="de-DE" dirty="0"/>
+                <a:t>Ggf. parallel mit H.I.</a:t>
+              </a:r>
+            </a:p>
+          </p:txBody>
+        </p:sp>
+        <p:sp>
+          <p:nvSpPr>
+            <p:cNvPr id="17" name="Textfeld 16">
+              <a:extLst>
+                <a:ext uri="{FF2B5EF4-FFF2-40B4-BE49-F238E27FC236}">
+                  <a16:creationId xmlns:a16="http://schemas.microsoft.com/office/drawing/2014/main" id="{4CC1568A-F8C6-CD98-2159-5A7A4A0D0068}"/>
+                </a:ext>
+              </a:extLst>
+            </p:cNvPr>
+            <p:cNvSpPr txBox="1"/>
+            <p:nvPr/>
+          </p:nvSpPr>
+          <p:spPr>
+            <a:xfrm>
+              <a:off x="473468" y="4606347"/>
+              <a:ext cx="1499128" cy="461665"/>
+            </a:xfrm>
+            <a:prstGeom prst="rect">
+              <a:avLst/>
+            </a:prstGeom>
+            <a:noFill/>
+          </p:spPr>
+          <p:txBody>
+            <a:bodyPr wrap="none" rtlCol="0">
+              <a:spAutoFit/>
+            </a:bodyPr>
+            <a:lstStyle/>
+            <a:p>
+              <a:r>
+                <a:rPr lang="de-DE" sz="2400" b="1" dirty="0"/>
+                <a:t>2. Stunde</a:t>
+              </a:r>
+            </a:p>
+          </p:txBody>
+        </p:sp>
+      </p:grpSp>
       <p:sp>
         <p:nvSpPr>
           <p:cNvPr id="27" name="Inhaltsplatzhalter 4">
@@ -13483,6 +13505,2520 @@
   <p:clrMapOvr>
     <a:masterClrMapping/>
   </p:clrMapOvr>
+  <p:timing>
+    <p:tnLst>
+      <p:par>
+        <p:cTn id="1" dur="indefinite" restart="never" nodeType="tmRoot">
+          <p:childTnLst>
+            <p:seq concurrent="1" nextAc="seek">
+              <p:cTn id="2" dur="indefinite" nodeType="mainSeq">
+                <p:childTnLst>
+                  <p:par>
+                    <p:cTn id="3" fill="hold">
+                      <p:stCondLst>
+                        <p:cond delay="indefinite"/>
+                      </p:stCondLst>
+                      <p:childTnLst>
+                        <p:par>
+                          <p:cTn id="4" fill="hold">
+                            <p:stCondLst>
+                              <p:cond delay="0"/>
+                            </p:stCondLst>
+                            <p:childTnLst>
+                              <p:par>
+                                <p:cTn id="5" presetID="1" presetClass="entr" presetSubtype="0" fill="hold" grpId="0" nodeType="clickEffect">
+                                  <p:stCondLst>
+                                    <p:cond delay="0"/>
+                                  </p:stCondLst>
+                                  <p:childTnLst>
+                                    <p:set>
+                                      <p:cBhvr>
+                                        <p:cTn id="6" dur="1" fill="hold">
+                                          <p:stCondLst>
+                                            <p:cond delay="0"/>
+                                          </p:stCondLst>
+                                        </p:cTn>
+                                        <p:tgtEl>
+                                          <p:spTgt spid="35"/>
+                                        </p:tgtEl>
+                                        <p:attrNameLst>
+                                          <p:attrName>style.visibility</p:attrName>
+                                        </p:attrNameLst>
+                                      </p:cBhvr>
+                                      <p:to>
+                                        <p:strVal val="visible"/>
+                                      </p:to>
+                                    </p:set>
+                                  </p:childTnLst>
+                                </p:cTn>
+                              </p:par>
+                              <p:par>
+                                <p:cTn id="7" presetID="1" presetClass="entr" presetSubtype="0" fill="hold" grpId="0" nodeType="withEffect">
+                                  <p:stCondLst>
+                                    <p:cond delay="0"/>
+                                  </p:stCondLst>
+                                  <p:childTnLst>
+                                    <p:set>
+                                      <p:cBhvr>
+                                        <p:cTn id="8" dur="1" fill="hold">
+                                          <p:stCondLst>
+                                            <p:cond delay="0"/>
+                                          </p:stCondLst>
+                                        </p:cTn>
+                                        <p:tgtEl>
+                                          <p:spTgt spid="8"/>
+                                        </p:tgtEl>
+                                        <p:attrNameLst>
+                                          <p:attrName>style.visibility</p:attrName>
+                                        </p:attrNameLst>
+                                      </p:cBhvr>
+                                      <p:to>
+                                        <p:strVal val="visible"/>
+                                      </p:to>
+                                    </p:set>
+                                  </p:childTnLst>
+                                </p:cTn>
+                              </p:par>
+                              <p:par>
+                                <p:cTn id="9" presetID="1" presetClass="entr" presetSubtype="0" fill="hold" grpId="0" nodeType="withEffect">
+                                  <p:stCondLst>
+                                    <p:cond delay="0"/>
+                                  </p:stCondLst>
+                                  <p:childTnLst>
+                                    <p:set>
+                                      <p:cBhvr>
+                                        <p:cTn id="10" dur="1" fill="hold">
+                                          <p:stCondLst>
+                                            <p:cond delay="0"/>
+                                          </p:stCondLst>
+                                        </p:cTn>
+                                        <p:tgtEl>
+                                          <p:spTgt spid="11"/>
+                                        </p:tgtEl>
+                                        <p:attrNameLst>
+                                          <p:attrName>style.visibility</p:attrName>
+                                        </p:attrNameLst>
+                                      </p:cBhvr>
+                                      <p:to>
+                                        <p:strVal val="visible"/>
+                                      </p:to>
+                                    </p:set>
+                                  </p:childTnLst>
+                                </p:cTn>
+                              </p:par>
+                              <p:par>
+                                <p:cTn id="11" presetID="1" presetClass="entr" presetSubtype="0" fill="hold" grpId="0" nodeType="withEffect">
+                                  <p:stCondLst>
+                                    <p:cond delay="0"/>
+                                  </p:stCondLst>
+                                  <p:childTnLst>
+                                    <p:set>
+                                      <p:cBhvr>
+                                        <p:cTn id="12" dur="1" fill="hold">
+                                          <p:stCondLst>
+                                            <p:cond delay="0"/>
+                                          </p:stCondLst>
+                                        </p:cTn>
+                                        <p:tgtEl>
+                                          <p:spTgt spid="5">
+                                            <p:txEl>
+                                              <p:pRg st="0" end="0"/>
+                                            </p:txEl>
+                                          </p:spTgt>
+                                        </p:tgtEl>
+                                        <p:attrNameLst>
+                                          <p:attrName>style.visibility</p:attrName>
+                                        </p:attrNameLst>
+                                      </p:cBhvr>
+                                      <p:to>
+                                        <p:strVal val="visible"/>
+                                      </p:to>
+                                    </p:set>
+                                  </p:childTnLst>
+                                </p:cTn>
+                              </p:par>
+                              <p:par>
+                                <p:cTn id="13" presetID="1" presetClass="entr" presetSubtype="0" fill="hold" grpId="0" nodeType="withEffect">
+                                  <p:stCondLst>
+                                    <p:cond delay="0"/>
+                                  </p:stCondLst>
+                                  <p:childTnLst>
+                                    <p:set>
+                                      <p:cBhvr>
+                                        <p:cTn id="14" dur="1" fill="hold">
+                                          <p:stCondLst>
+                                            <p:cond delay="0"/>
+                                          </p:stCondLst>
+                                        </p:cTn>
+                                        <p:tgtEl>
+                                          <p:spTgt spid="5">
+                                            <p:txEl>
+                                              <p:pRg st="1" end="1"/>
+                                            </p:txEl>
+                                          </p:spTgt>
+                                        </p:tgtEl>
+                                        <p:attrNameLst>
+                                          <p:attrName>style.visibility</p:attrName>
+                                        </p:attrNameLst>
+                                      </p:cBhvr>
+                                      <p:to>
+                                        <p:strVal val="visible"/>
+                                      </p:to>
+                                    </p:set>
+                                  </p:childTnLst>
+                                </p:cTn>
+                              </p:par>
+                              <p:par>
+                                <p:cTn id="15" presetID="1" presetClass="entr" presetSubtype="0" fill="hold" grpId="0" nodeType="withEffect">
+                                  <p:stCondLst>
+                                    <p:cond delay="0"/>
+                                  </p:stCondLst>
+                                  <p:childTnLst>
+                                    <p:set>
+                                      <p:cBhvr>
+                                        <p:cTn id="16" dur="1" fill="hold">
+                                          <p:stCondLst>
+                                            <p:cond delay="0"/>
+                                          </p:stCondLst>
+                                        </p:cTn>
+                                        <p:tgtEl>
+                                          <p:spTgt spid="5">
+                                            <p:txEl>
+                                              <p:pRg st="2" end="2"/>
+                                            </p:txEl>
+                                          </p:spTgt>
+                                        </p:tgtEl>
+                                        <p:attrNameLst>
+                                          <p:attrName>style.visibility</p:attrName>
+                                        </p:attrNameLst>
+                                      </p:cBhvr>
+                                      <p:to>
+                                        <p:strVal val="visible"/>
+                                      </p:to>
+                                    </p:set>
+                                  </p:childTnLst>
+                                </p:cTn>
+                              </p:par>
+                              <p:par>
+                                <p:cTn id="17" presetID="1" presetClass="entr" presetSubtype="0" fill="hold" grpId="0" nodeType="withEffect">
+                                  <p:stCondLst>
+                                    <p:cond delay="0"/>
+                                  </p:stCondLst>
+                                  <p:childTnLst>
+                                    <p:set>
+                                      <p:cBhvr>
+                                        <p:cTn id="18" dur="1" fill="hold">
+                                          <p:stCondLst>
+                                            <p:cond delay="0"/>
+                                          </p:stCondLst>
+                                        </p:cTn>
+                                        <p:tgtEl>
+                                          <p:spTgt spid="5">
+                                            <p:txEl>
+                                              <p:pRg st="3" end="3"/>
+                                            </p:txEl>
+                                          </p:spTgt>
+                                        </p:tgtEl>
+                                        <p:attrNameLst>
+                                          <p:attrName>style.visibility</p:attrName>
+                                        </p:attrNameLst>
+                                      </p:cBhvr>
+                                      <p:to>
+                                        <p:strVal val="visible"/>
+                                      </p:to>
+                                    </p:set>
+                                  </p:childTnLst>
+                                </p:cTn>
+                              </p:par>
+                              <p:par>
+                                <p:cTn id="19" presetID="1" presetClass="entr" presetSubtype="0" fill="hold" grpId="0" nodeType="withEffect">
+                                  <p:stCondLst>
+                                    <p:cond delay="0"/>
+                                  </p:stCondLst>
+                                  <p:childTnLst>
+                                    <p:set>
+                                      <p:cBhvr>
+                                        <p:cTn id="20" dur="1" fill="hold">
+                                          <p:stCondLst>
+                                            <p:cond delay="0"/>
+                                          </p:stCondLst>
+                                        </p:cTn>
+                                        <p:tgtEl>
+                                          <p:spTgt spid="5">
+                                            <p:txEl>
+                                              <p:pRg st="4" end="4"/>
+                                            </p:txEl>
+                                          </p:spTgt>
+                                        </p:tgtEl>
+                                        <p:attrNameLst>
+                                          <p:attrName>style.visibility</p:attrName>
+                                        </p:attrNameLst>
+                                      </p:cBhvr>
+                                      <p:to>
+                                        <p:strVal val="visible"/>
+                                      </p:to>
+                                    </p:set>
+                                  </p:childTnLst>
+                                </p:cTn>
+                              </p:par>
+                            </p:childTnLst>
+                          </p:cTn>
+                        </p:par>
+                      </p:childTnLst>
+                    </p:cTn>
+                  </p:par>
+                  <p:par>
+                    <p:cTn id="21" fill="hold">
+                      <p:stCondLst>
+                        <p:cond delay="indefinite"/>
+                      </p:stCondLst>
+                      <p:childTnLst>
+                        <p:par>
+                          <p:cTn id="22" fill="hold">
+                            <p:stCondLst>
+                              <p:cond delay="0"/>
+                            </p:stCondLst>
+                            <p:childTnLst>
+                              <p:par>
+                                <p:cTn id="23" presetID="1" presetClass="entr" presetSubtype="0" fill="hold" nodeType="clickEffect">
+                                  <p:stCondLst>
+                                    <p:cond delay="0"/>
+                                  </p:stCondLst>
+                                  <p:childTnLst>
+                                    <p:set>
+                                      <p:cBhvr>
+                                        <p:cTn id="24" dur="1" fill="hold">
+                                          <p:stCondLst>
+                                            <p:cond delay="0"/>
+                                          </p:stCondLst>
+                                        </p:cTn>
+                                        <p:tgtEl>
+                                          <p:spTgt spid="9"/>
+                                        </p:tgtEl>
+                                        <p:attrNameLst>
+                                          <p:attrName>style.visibility</p:attrName>
+                                        </p:attrNameLst>
+                                      </p:cBhvr>
+                                      <p:to>
+                                        <p:strVal val="visible"/>
+                                      </p:to>
+                                    </p:set>
+                                  </p:childTnLst>
+                                </p:cTn>
+                              </p:par>
+                            </p:childTnLst>
+                          </p:cTn>
+                        </p:par>
+                      </p:childTnLst>
+                    </p:cTn>
+                  </p:par>
+                  <p:par>
+                    <p:cTn id="25" fill="hold">
+                      <p:stCondLst>
+                        <p:cond delay="indefinite"/>
+                      </p:stCondLst>
+                      <p:childTnLst>
+                        <p:par>
+                          <p:cTn id="26" fill="hold">
+                            <p:stCondLst>
+                              <p:cond delay="0"/>
+                            </p:stCondLst>
+                            <p:childTnLst>
+                              <p:par>
+                                <p:cTn id="27" presetID="1" presetClass="entr" presetSubtype="0" fill="hold" grpId="0" nodeType="clickEffect">
+                                  <p:stCondLst>
+                                    <p:cond delay="0"/>
+                                  </p:stCondLst>
+                                  <p:childTnLst>
+                                    <p:set>
+                                      <p:cBhvr>
+                                        <p:cTn id="28" dur="1" fill="hold">
+                                          <p:stCondLst>
+                                            <p:cond delay="0"/>
+                                          </p:stCondLst>
+                                        </p:cTn>
+                                        <p:tgtEl>
+                                          <p:spTgt spid="34"/>
+                                        </p:tgtEl>
+                                        <p:attrNameLst>
+                                          <p:attrName>style.visibility</p:attrName>
+                                        </p:attrNameLst>
+                                      </p:cBhvr>
+                                      <p:to>
+                                        <p:strVal val="visible"/>
+                                      </p:to>
+                                    </p:set>
+                                  </p:childTnLst>
+                                </p:cTn>
+                              </p:par>
+                              <p:par>
+                                <p:cTn id="29" presetID="1" presetClass="entr" presetSubtype="0" fill="hold" grpId="0" nodeType="withEffect">
+                                  <p:stCondLst>
+                                    <p:cond delay="0"/>
+                                  </p:stCondLst>
+                                  <p:childTnLst>
+                                    <p:set>
+                                      <p:cBhvr>
+                                        <p:cTn id="30" dur="1" fill="hold">
+                                          <p:stCondLst>
+                                            <p:cond delay="0"/>
+                                          </p:stCondLst>
+                                        </p:cTn>
+                                        <p:tgtEl>
+                                          <p:spTgt spid="27"/>
+                                        </p:tgtEl>
+                                        <p:attrNameLst>
+                                          <p:attrName>style.visibility</p:attrName>
+                                        </p:attrNameLst>
+                                      </p:cBhvr>
+                                      <p:to>
+                                        <p:strVal val="visible"/>
+                                      </p:to>
+                                    </p:set>
+                                  </p:childTnLst>
+                                </p:cTn>
+                              </p:par>
+                              <p:par>
+                                <p:cTn id="31" presetID="1" presetClass="entr" presetSubtype="0" fill="hold" grpId="0" nodeType="withEffect">
+                                  <p:stCondLst>
+                                    <p:cond delay="0"/>
+                                  </p:stCondLst>
+                                  <p:childTnLst>
+                                    <p:set>
+                                      <p:cBhvr>
+                                        <p:cTn id="32" dur="1" fill="hold">
+                                          <p:stCondLst>
+                                            <p:cond delay="0"/>
+                                          </p:stCondLst>
+                                        </p:cTn>
+                                        <p:tgtEl>
+                                          <p:spTgt spid="28"/>
+                                        </p:tgtEl>
+                                        <p:attrNameLst>
+                                          <p:attrName>style.visibility</p:attrName>
+                                        </p:attrNameLst>
+                                      </p:cBhvr>
+                                      <p:to>
+                                        <p:strVal val="visible"/>
+                                      </p:to>
+                                    </p:set>
+                                  </p:childTnLst>
+                                </p:cTn>
+                              </p:par>
+                            </p:childTnLst>
+                          </p:cTn>
+                        </p:par>
+                      </p:childTnLst>
+                    </p:cTn>
+                  </p:par>
+                  <p:par>
+                    <p:cTn id="33" fill="hold">
+                      <p:stCondLst>
+                        <p:cond delay="indefinite"/>
+                      </p:stCondLst>
+                      <p:childTnLst>
+                        <p:par>
+                          <p:cTn id="34" fill="hold">
+                            <p:stCondLst>
+                              <p:cond delay="0"/>
+                            </p:stCondLst>
+                            <p:childTnLst>
+                              <p:par>
+                                <p:cTn id="35" presetID="1" presetClass="entr" presetSubtype="0" fill="hold" grpId="0" nodeType="clickEffect">
+                                  <p:stCondLst>
+                                    <p:cond delay="0"/>
+                                  </p:stCondLst>
+                                  <p:childTnLst>
+                                    <p:set>
+                                      <p:cBhvr>
+                                        <p:cTn id="36" dur="1" fill="hold">
+                                          <p:stCondLst>
+                                            <p:cond delay="0"/>
+                                          </p:stCondLst>
+                                        </p:cTn>
+                                        <p:tgtEl>
+                                          <p:spTgt spid="3"/>
+                                        </p:tgtEl>
+                                        <p:attrNameLst>
+                                          <p:attrName>style.visibility</p:attrName>
+                                        </p:attrNameLst>
+                                      </p:cBhvr>
+                                      <p:to>
+                                        <p:strVal val="visible"/>
+                                      </p:to>
+                                    </p:set>
+                                  </p:childTnLst>
+                                </p:cTn>
+                              </p:par>
+                            </p:childTnLst>
+                          </p:cTn>
+                        </p:par>
+                      </p:childTnLst>
+                    </p:cTn>
+                  </p:par>
+                </p:childTnLst>
+              </p:cTn>
+              <p:prevCondLst>
+                <p:cond evt="onPrev" delay="0">
+                  <p:tgtEl>
+                    <p:sldTgt/>
+                  </p:tgtEl>
+                </p:cond>
+              </p:prevCondLst>
+              <p:nextCondLst>
+                <p:cond evt="onNext" delay="0">
+                  <p:tgtEl>
+                    <p:sldTgt/>
+                  </p:tgtEl>
+                </p:cond>
+              </p:nextCondLst>
+            </p:seq>
+          </p:childTnLst>
+        </p:cTn>
+      </p:par>
+    </p:tnLst>
+    <p:bldLst>
+      <p:bldP spid="35" grpId="0" animBg="1"/>
+      <p:bldP spid="34" grpId="0" animBg="1"/>
+      <p:bldP spid="5" grpId="0" build="p"/>
+      <p:bldP spid="11" grpId="0"/>
+      <p:bldP spid="27" grpId="0"/>
+      <p:bldP spid="28" grpId="0"/>
+      <p:bldP spid="3" grpId="0"/>
+      <p:bldP spid="8" grpId="0"/>
+    </p:bldLst>
+  </p:timing>
+</p:sld>
+</file>
+
+<file path=ppt/slides/slide2.xml><?xml version="1.0" encoding="utf-8"?>
+<p:sld xmlns:a="http://schemas.openxmlformats.org/drawingml/2006/main" xmlns:r="http://schemas.openxmlformats.org/officeDocument/2006/relationships" xmlns:p="http://schemas.openxmlformats.org/presentationml/2006/main">
+  <p:cSld>
+    <p:spTree>
+      <p:nvGrpSpPr>
+        <p:cNvPr id="1" name=""/>
+        <p:cNvGrpSpPr/>
+        <p:nvPr/>
+      </p:nvGrpSpPr>
+      <p:grpSpPr>
+        <a:xfrm>
+          <a:off x="0" y="0"/>
+          <a:ext cx="0" cy="0"/>
+          <a:chOff x="0" y="0"/>
+          <a:chExt cx="0" cy="0"/>
+        </a:xfrm>
+      </p:grpSpPr>
+      <p:sp>
+        <p:nvSpPr>
+          <p:cNvPr id="9" name="Pfeil: nach rechts 8">
+            <a:extLst>
+              <a:ext uri="{FF2B5EF4-FFF2-40B4-BE49-F238E27FC236}">
+                <a16:creationId xmlns:a16="http://schemas.microsoft.com/office/drawing/2014/main" id="{A8292768-BB58-F29B-6B45-E1B457B9DE61}"/>
+              </a:ext>
+            </a:extLst>
+          </p:cNvPr>
+          <p:cNvSpPr/>
+          <p:nvPr/>
+        </p:nvSpPr>
+        <p:spPr>
+          <a:xfrm>
+            <a:off x="329112" y="3397590"/>
+            <a:ext cx="10159376" cy="210340"/>
+          </a:xfrm>
+          <a:prstGeom prst="rightArrow">
+            <a:avLst>
+              <a:gd name="adj1" fmla="val 100000"/>
+              <a:gd name="adj2" fmla="val 53498"/>
+            </a:avLst>
+          </a:prstGeom>
+          <a:solidFill>
+            <a:schemeClr val="bg1">
+              <a:lumMod val="75000"/>
+            </a:schemeClr>
+          </a:solidFill>
+          <a:ln w="9525" cap="flat" cmpd="sng" algn="ctr">
+            <a:noFill/>
+            <a:prstDash val="solid"/>
+          </a:ln>
+          <a:effectLst/>
+        </p:spPr>
+        <p:txBody>
+          <a:bodyPr rtlCol="0" anchor="ctr"/>
+          <a:lstStyle/>
+          <a:p>
+            <a:pPr marL="0" marR="0" indent="0" algn="ctr" defTabSz="914400" eaLnBrk="1" fontAlgn="auto" latinLnBrk="0" hangingPunct="1">
+              <a:lnSpc>
+                <a:spcPct val="100000"/>
+              </a:lnSpc>
+              <a:spcBef>
+                <a:spcPts val="0"/>
+              </a:spcBef>
+              <a:spcAft>
+                <a:spcPts val="0"/>
+              </a:spcAft>
+              <a:buClrTx/>
+              <a:buSzTx/>
+              <a:buFontTx/>
+              <a:buNone/>
+              <a:tabLst/>
+            </a:pPr>
+            <a:endParaRPr kumimoji="0" lang="de-DE" sz="1000" b="1" i="0" u="none" strike="noStrike" kern="0" cap="none" spc="0" normalizeH="0" baseline="0" noProof="0" dirty="0">
+              <a:ln>
+                <a:noFill/>
+              </a:ln>
+              <a:effectLst/>
+              <a:uLnTx/>
+              <a:uFillTx/>
+              <a:latin typeface="Arial" panose="020B0604020202020204"/>
+              <a:ea typeface="+mn-ea"/>
+              <a:cs typeface="Arial" panose="020B0604020202020204" pitchFamily="34" charset="0"/>
+            </a:endParaRPr>
+          </a:p>
+        </p:txBody>
+      </p:sp>
+      <p:sp>
+        <p:nvSpPr>
+          <p:cNvPr id="2" name="Datumsplatzhalter 1">
+            <a:extLst>
+              <a:ext uri="{FF2B5EF4-FFF2-40B4-BE49-F238E27FC236}">
+                <a16:creationId xmlns:a16="http://schemas.microsoft.com/office/drawing/2014/main" id="{1DCD62EA-A0F7-4251-9E05-9C1BBFA5A95A}"/>
+              </a:ext>
+            </a:extLst>
+          </p:cNvPr>
+          <p:cNvSpPr>
+            <a:spLocks noGrp="1"/>
+          </p:cNvSpPr>
+          <p:nvPr>
+            <p:ph type="dt" sz="half" idx="10"/>
+          </p:nvPr>
+        </p:nvSpPr>
+        <p:spPr/>
+        <p:txBody>
+          <a:bodyPr/>
+          <a:lstStyle/>
+          <a:p>
+            <a:fld id="{EA33749F-693F-4A8B-AD1F-042F2F274E90}" type="datetime1">
+              <a:rPr lang="de-DE" smtClean="0"/>
+              <a:t>11.06.2025</a:t>
+            </a:fld>
+            <a:endParaRPr lang="de-DE" dirty="0"/>
+          </a:p>
+        </p:txBody>
+      </p:sp>
+      <p:sp>
+        <p:nvSpPr>
+          <p:cNvPr id="4" name="Foliennummernplatzhalter 3">
+            <a:extLst>
+              <a:ext uri="{FF2B5EF4-FFF2-40B4-BE49-F238E27FC236}">
+                <a16:creationId xmlns:a16="http://schemas.microsoft.com/office/drawing/2014/main" id="{96450D58-C923-4965-BE36-8F20DD5400C5}"/>
+              </a:ext>
+            </a:extLst>
+          </p:cNvPr>
+          <p:cNvSpPr>
+            <a:spLocks noGrp="1"/>
+          </p:cNvSpPr>
+          <p:nvPr>
+            <p:ph type="sldNum" sz="quarter" idx="12"/>
+          </p:nvPr>
+        </p:nvSpPr>
+        <p:spPr/>
+        <p:txBody>
+          <a:bodyPr/>
+          <a:lstStyle/>
+          <a:p>
+            <a:fld id="{FE474E4C-431A-524F-A233-B9B84658CEA9}" type="slidenum">
+              <a:rPr lang="de-DE" smtClean="0"/>
+              <a:pPr/>
+              <a:t>2</a:t>
+            </a:fld>
+            <a:endParaRPr lang="de-DE" dirty="0"/>
+          </a:p>
+        </p:txBody>
+      </p:sp>
+      <p:sp>
+        <p:nvSpPr>
+          <p:cNvPr id="6" name="Titel 5">
+            <a:extLst>
+              <a:ext uri="{FF2B5EF4-FFF2-40B4-BE49-F238E27FC236}">
+                <a16:creationId xmlns:a16="http://schemas.microsoft.com/office/drawing/2014/main" id="{7E6B3330-F19B-4AC8-9189-FFB7B8364189}"/>
+              </a:ext>
+            </a:extLst>
+          </p:cNvPr>
+          <p:cNvSpPr>
+            <a:spLocks noGrp="1"/>
+          </p:cNvSpPr>
+          <p:nvPr>
+            <p:ph type="title"/>
+          </p:nvPr>
+        </p:nvSpPr>
+        <p:spPr/>
+        <p:txBody>
+          <a:bodyPr/>
+          <a:lstStyle/>
+          <a:p>
+            <a:r>
+              <a:rPr lang="de-DE" dirty="0"/>
+              <a:t>Spezifikation = Design </a:t>
+            </a:r>
+            <a:r>
+              <a:rPr lang="de-DE" dirty="0" err="1"/>
+              <a:t>before</a:t>
+            </a:r>
+            <a:r>
+              <a:rPr lang="de-DE" dirty="0"/>
+              <a:t> Implementation</a:t>
+            </a:r>
+          </a:p>
+        </p:txBody>
+      </p:sp>
+      <p:sp>
+        <p:nvSpPr>
+          <p:cNvPr id="7" name="Fußzeilenplatzhalter 2">
+            <a:extLst>
+              <a:ext uri="{FF2B5EF4-FFF2-40B4-BE49-F238E27FC236}">
+                <a16:creationId xmlns:a16="http://schemas.microsoft.com/office/drawing/2014/main" id="{A576D1F4-18EB-4DB4-BB18-248EE62393E2}"/>
+              </a:ext>
+            </a:extLst>
+          </p:cNvPr>
+          <p:cNvSpPr>
+            <a:spLocks noGrp="1"/>
+          </p:cNvSpPr>
+          <p:nvPr>
+            <p:ph type="ftr" sz="quarter" idx="11"/>
+          </p:nvPr>
+        </p:nvSpPr>
+        <p:spPr>
+          <a:xfrm>
+            <a:off x="1766713" y="6561601"/>
+            <a:ext cx="8647289" cy="92333"/>
+          </a:xfrm>
+        </p:spPr>
+        <p:txBody>
+          <a:bodyPr/>
+          <a:lstStyle/>
+          <a:p>
+            <a:r>
+              <a:rPr lang="en-US" dirty="0"/>
+              <a:t>© Copyright 2025 • S&amp;N Invent GmbH • All rights reserved.</a:t>
+            </a:r>
+            <a:endParaRPr lang="de-DE" dirty="0"/>
+          </a:p>
+        </p:txBody>
+      </p:sp>
+      <p:sp>
+        <p:nvSpPr>
+          <p:cNvPr id="8" name="Pfeil: Chevron 7">
+            <a:extLst>
+              <a:ext uri="{FF2B5EF4-FFF2-40B4-BE49-F238E27FC236}">
+                <a16:creationId xmlns:a16="http://schemas.microsoft.com/office/drawing/2014/main" id="{4523CC4B-EA09-CFDE-45D5-291E9AE10D63}"/>
+              </a:ext>
+            </a:extLst>
+          </p:cNvPr>
+          <p:cNvSpPr/>
+          <p:nvPr/>
+        </p:nvSpPr>
+        <p:spPr>
+          <a:xfrm>
+            <a:off x="846312" y="2244914"/>
+            <a:ext cx="2088232" cy="1080120"/>
+          </a:xfrm>
+          <a:prstGeom prst="chevron">
+            <a:avLst>
+              <a:gd name="adj" fmla="val 26529"/>
+            </a:avLst>
+          </a:prstGeom>
+          <a:solidFill>
+            <a:srgbClr val="FFC000"/>
+          </a:solidFill>
+          <a:ln w="9525" cap="flat" cmpd="sng" algn="ctr">
+            <a:noFill/>
+            <a:prstDash val="solid"/>
+          </a:ln>
+          <a:effectLst/>
+        </p:spPr>
+        <p:txBody>
+          <a:bodyPr rtlCol="0" anchor="ctr"/>
+          <a:lstStyle/>
+          <a:p>
+            <a:pPr algn="ctr"/>
+            <a:endParaRPr lang="de-DE" sz="2000" dirty="0"/>
+          </a:p>
+          <a:p>
+            <a:pPr algn="ctr"/>
+            <a:r>
+              <a:rPr lang="de-DE" sz="2000" dirty="0"/>
+              <a:t>Kunden-wunsch</a:t>
+            </a:r>
+          </a:p>
+          <a:p>
+            <a:pPr marL="0" marR="0" indent="0" algn="ctr" defTabSz="914400" eaLnBrk="1" fontAlgn="auto" latinLnBrk="0" hangingPunct="1">
+              <a:lnSpc>
+                <a:spcPct val="100000"/>
+              </a:lnSpc>
+              <a:spcBef>
+                <a:spcPts val="0"/>
+              </a:spcBef>
+              <a:spcAft>
+                <a:spcPts val="0"/>
+              </a:spcAft>
+              <a:buClrTx/>
+              <a:buSzTx/>
+              <a:buFontTx/>
+              <a:buNone/>
+              <a:tabLst/>
+            </a:pPr>
+            <a:endParaRPr kumimoji="0" lang="de-DE" sz="2000" b="1" i="0" u="none" strike="noStrike" kern="0" cap="none" spc="0" normalizeH="0" baseline="0" noProof="0" dirty="0">
+              <a:ln>
+                <a:noFill/>
+              </a:ln>
+              <a:effectLst/>
+              <a:uLnTx/>
+              <a:uFillTx/>
+              <a:latin typeface="Arial" panose="020B0604020202020204"/>
+              <a:ea typeface="+mn-ea"/>
+              <a:cs typeface="Arial" panose="020B0604020202020204" pitchFamily="34" charset="0"/>
+            </a:endParaRPr>
+          </a:p>
+        </p:txBody>
+      </p:sp>
+      <p:sp>
+        <p:nvSpPr>
+          <p:cNvPr id="12" name="Pfeil: Chevron 11">
+            <a:extLst>
+              <a:ext uri="{FF2B5EF4-FFF2-40B4-BE49-F238E27FC236}">
+                <a16:creationId xmlns:a16="http://schemas.microsoft.com/office/drawing/2014/main" id="{D03779AC-557C-FD34-4526-C4662C712030}"/>
+              </a:ext>
+            </a:extLst>
+          </p:cNvPr>
+          <p:cNvSpPr/>
+          <p:nvPr/>
+        </p:nvSpPr>
+        <p:spPr>
+          <a:xfrm>
+            <a:off x="2807784" y="2248483"/>
+            <a:ext cx="2088232" cy="1080120"/>
+          </a:xfrm>
+          <a:prstGeom prst="chevron">
+            <a:avLst>
+              <a:gd name="adj" fmla="val 26529"/>
+            </a:avLst>
+          </a:prstGeom>
+          <a:solidFill>
+            <a:srgbClr val="FFC000"/>
+          </a:solidFill>
+          <a:ln w="9525" cap="flat" cmpd="sng" algn="ctr">
+            <a:noFill/>
+            <a:prstDash val="solid"/>
+          </a:ln>
+          <a:effectLst/>
+        </p:spPr>
+        <p:txBody>
+          <a:bodyPr rtlCol="0" anchor="ctr"/>
+          <a:lstStyle/>
+          <a:p>
+            <a:pPr algn="ctr"/>
+            <a:endParaRPr lang="de-DE" sz="2000" dirty="0"/>
+          </a:p>
+          <a:p>
+            <a:pPr algn="ctr"/>
+            <a:r>
+              <a:rPr lang="de-DE" sz="2000" dirty="0"/>
+              <a:t>Ortstermin</a:t>
+            </a:r>
+          </a:p>
+          <a:p>
+            <a:pPr marL="0" marR="0" indent="0" algn="ctr" defTabSz="914400" eaLnBrk="1" fontAlgn="auto" latinLnBrk="0" hangingPunct="1">
+              <a:lnSpc>
+                <a:spcPct val="100000"/>
+              </a:lnSpc>
+              <a:spcBef>
+                <a:spcPts val="0"/>
+              </a:spcBef>
+              <a:spcAft>
+                <a:spcPts val="0"/>
+              </a:spcAft>
+              <a:buClrTx/>
+              <a:buSzTx/>
+              <a:buFontTx/>
+              <a:buNone/>
+              <a:tabLst/>
+            </a:pPr>
+            <a:endParaRPr kumimoji="0" lang="de-DE" sz="2000" b="1" i="0" u="none" strike="noStrike" kern="0" cap="none" spc="0" normalizeH="0" baseline="0" noProof="0" dirty="0">
+              <a:ln>
+                <a:noFill/>
+              </a:ln>
+              <a:effectLst/>
+              <a:uLnTx/>
+              <a:uFillTx/>
+              <a:latin typeface="Arial" panose="020B0604020202020204"/>
+              <a:ea typeface="+mn-ea"/>
+              <a:cs typeface="Arial" panose="020B0604020202020204" pitchFamily="34" charset="0"/>
+            </a:endParaRPr>
+          </a:p>
+        </p:txBody>
+      </p:sp>
+      <p:sp>
+        <p:nvSpPr>
+          <p:cNvPr id="13" name="Pfeil: Chevron 12">
+            <a:extLst>
+              <a:ext uri="{FF2B5EF4-FFF2-40B4-BE49-F238E27FC236}">
+                <a16:creationId xmlns:a16="http://schemas.microsoft.com/office/drawing/2014/main" id="{21D7F417-3054-A005-6CB6-F577A9F84A22}"/>
+              </a:ext>
+            </a:extLst>
+          </p:cNvPr>
+          <p:cNvSpPr/>
+          <p:nvPr/>
+        </p:nvSpPr>
+        <p:spPr>
+          <a:xfrm>
+            <a:off x="4743949" y="2253521"/>
+            <a:ext cx="2088232" cy="1080120"/>
+          </a:xfrm>
+          <a:prstGeom prst="chevron">
+            <a:avLst>
+              <a:gd name="adj" fmla="val 26529"/>
+            </a:avLst>
+          </a:prstGeom>
+          <a:solidFill>
+            <a:srgbClr val="FFC000"/>
+          </a:solidFill>
+          <a:ln w="9525" cap="flat" cmpd="sng" algn="ctr">
+            <a:noFill/>
+            <a:prstDash val="solid"/>
+          </a:ln>
+          <a:effectLst/>
+        </p:spPr>
+        <p:txBody>
+          <a:bodyPr rtlCol="0" anchor="ctr"/>
+          <a:lstStyle/>
+          <a:p>
+            <a:pPr algn="ctr"/>
+            <a:endParaRPr lang="de-DE" sz="2000" dirty="0"/>
+          </a:p>
+          <a:p>
+            <a:pPr algn="ctr"/>
+            <a:r>
+              <a:rPr lang="de-DE" sz="2000" dirty="0"/>
+              <a:t>Entwurf</a:t>
+            </a:r>
+          </a:p>
+          <a:p>
+            <a:pPr marL="0" marR="0" indent="0" algn="ctr" defTabSz="914400" eaLnBrk="1" fontAlgn="auto" latinLnBrk="0" hangingPunct="1">
+              <a:lnSpc>
+                <a:spcPct val="100000"/>
+              </a:lnSpc>
+              <a:spcBef>
+                <a:spcPts val="0"/>
+              </a:spcBef>
+              <a:spcAft>
+                <a:spcPts val="0"/>
+              </a:spcAft>
+              <a:buClrTx/>
+              <a:buSzTx/>
+              <a:buFontTx/>
+              <a:buNone/>
+              <a:tabLst/>
+            </a:pPr>
+            <a:endParaRPr kumimoji="0" lang="de-DE" sz="2000" b="1" i="0" u="none" strike="noStrike" kern="0" cap="none" spc="0" normalizeH="0" baseline="0" noProof="0" dirty="0">
+              <a:ln>
+                <a:noFill/>
+              </a:ln>
+              <a:effectLst/>
+              <a:uLnTx/>
+              <a:uFillTx/>
+              <a:latin typeface="Arial" panose="020B0604020202020204"/>
+              <a:ea typeface="+mn-ea"/>
+              <a:cs typeface="Arial" panose="020B0604020202020204" pitchFamily="34" charset="0"/>
+            </a:endParaRPr>
+          </a:p>
+        </p:txBody>
+      </p:sp>
+      <p:sp>
+        <p:nvSpPr>
+          <p:cNvPr id="15" name="Pfeil: Chevron 14">
+            <a:extLst>
+              <a:ext uri="{FF2B5EF4-FFF2-40B4-BE49-F238E27FC236}">
+                <a16:creationId xmlns:a16="http://schemas.microsoft.com/office/drawing/2014/main" id="{722D41A9-D13E-FEC4-F1C2-BA0634BA551F}"/>
+              </a:ext>
+            </a:extLst>
+          </p:cNvPr>
+          <p:cNvSpPr/>
+          <p:nvPr/>
+        </p:nvSpPr>
+        <p:spPr>
+          <a:xfrm>
+            <a:off x="6672064" y="2249525"/>
+            <a:ext cx="2088232" cy="1080120"/>
+          </a:xfrm>
+          <a:prstGeom prst="chevron">
+            <a:avLst>
+              <a:gd name="adj" fmla="val 26529"/>
+            </a:avLst>
+          </a:prstGeom>
+          <a:solidFill>
+            <a:srgbClr val="FFC000"/>
+          </a:solidFill>
+          <a:ln w="9525" cap="flat" cmpd="sng" algn="ctr">
+            <a:noFill/>
+            <a:prstDash val="solid"/>
+          </a:ln>
+          <a:effectLst/>
+        </p:spPr>
+        <p:txBody>
+          <a:bodyPr rtlCol="0" anchor="ctr"/>
+          <a:lstStyle/>
+          <a:p>
+            <a:pPr algn="ctr"/>
+            <a:endParaRPr lang="de-DE" sz="2000" dirty="0"/>
+          </a:p>
+          <a:p>
+            <a:pPr algn="ctr"/>
+            <a:r>
+              <a:rPr lang="de-DE" sz="2000" dirty="0"/>
+              <a:t>Umsetzung</a:t>
+            </a:r>
+          </a:p>
+          <a:p>
+            <a:pPr marL="0" marR="0" indent="0" algn="ctr" defTabSz="914400" eaLnBrk="1" fontAlgn="auto" latinLnBrk="0" hangingPunct="1">
+              <a:lnSpc>
+                <a:spcPct val="100000"/>
+              </a:lnSpc>
+              <a:spcBef>
+                <a:spcPts val="0"/>
+              </a:spcBef>
+              <a:spcAft>
+                <a:spcPts val="0"/>
+              </a:spcAft>
+              <a:buClrTx/>
+              <a:buSzTx/>
+              <a:buFontTx/>
+              <a:buNone/>
+              <a:tabLst/>
+            </a:pPr>
+            <a:endParaRPr kumimoji="0" lang="de-DE" sz="2000" b="1" i="0" u="none" strike="noStrike" kern="0" cap="none" spc="0" normalizeH="0" baseline="0" noProof="0" dirty="0">
+              <a:ln>
+                <a:noFill/>
+              </a:ln>
+              <a:effectLst/>
+              <a:uLnTx/>
+              <a:uFillTx/>
+              <a:latin typeface="Arial" panose="020B0604020202020204"/>
+              <a:ea typeface="+mn-ea"/>
+              <a:cs typeface="Arial" panose="020B0604020202020204" pitchFamily="34" charset="0"/>
+            </a:endParaRPr>
+          </a:p>
+        </p:txBody>
+      </p:sp>
+      <p:sp>
+        <p:nvSpPr>
+          <p:cNvPr id="16" name="Pfeil: Chevron 15">
+            <a:extLst>
+              <a:ext uri="{FF2B5EF4-FFF2-40B4-BE49-F238E27FC236}">
+                <a16:creationId xmlns:a16="http://schemas.microsoft.com/office/drawing/2014/main" id="{7DB4E27C-C2C7-0013-5B8D-ECCD4A9C19C0}"/>
+              </a:ext>
+            </a:extLst>
+          </p:cNvPr>
+          <p:cNvSpPr/>
+          <p:nvPr/>
+        </p:nvSpPr>
+        <p:spPr>
+          <a:xfrm>
+            <a:off x="8616280" y="2244914"/>
+            <a:ext cx="2088232" cy="1080120"/>
+          </a:xfrm>
+          <a:prstGeom prst="chevron">
+            <a:avLst>
+              <a:gd name="adj" fmla="val 26529"/>
+            </a:avLst>
+          </a:prstGeom>
+          <a:solidFill>
+            <a:srgbClr val="FFC000"/>
+          </a:solidFill>
+          <a:ln w="9525" cap="flat" cmpd="sng" algn="ctr">
+            <a:noFill/>
+            <a:prstDash val="solid"/>
+          </a:ln>
+          <a:effectLst/>
+        </p:spPr>
+        <p:txBody>
+          <a:bodyPr rtlCol="0" anchor="ctr"/>
+          <a:lstStyle/>
+          <a:p>
+            <a:pPr algn="ctr"/>
+            <a:endParaRPr lang="de-DE" sz="2000" dirty="0"/>
+          </a:p>
+          <a:p>
+            <a:pPr algn="ctr"/>
+            <a:r>
+              <a:rPr lang="de-DE" sz="2000" dirty="0"/>
+              <a:t>Bau-abnahme</a:t>
+            </a:r>
+          </a:p>
+          <a:p>
+            <a:pPr marL="0" marR="0" indent="0" algn="ctr" defTabSz="914400" eaLnBrk="1" fontAlgn="auto" latinLnBrk="0" hangingPunct="1">
+              <a:lnSpc>
+                <a:spcPct val="100000"/>
+              </a:lnSpc>
+              <a:spcBef>
+                <a:spcPts val="0"/>
+              </a:spcBef>
+              <a:spcAft>
+                <a:spcPts val="0"/>
+              </a:spcAft>
+              <a:buClrTx/>
+              <a:buSzTx/>
+              <a:buFontTx/>
+              <a:buNone/>
+              <a:tabLst/>
+            </a:pPr>
+            <a:endParaRPr kumimoji="0" lang="de-DE" sz="2000" b="1" i="0" u="none" strike="noStrike" kern="0" cap="none" spc="0" normalizeH="0" baseline="0" noProof="0" dirty="0">
+              <a:ln>
+                <a:noFill/>
+              </a:ln>
+              <a:effectLst/>
+              <a:uLnTx/>
+              <a:uFillTx/>
+              <a:latin typeface="Arial" panose="020B0604020202020204"/>
+              <a:ea typeface="+mn-ea"/>
+              <a:cs typeface="Arial" panose="020B0604020202020204" pitchFamily="34" charset="0"/>
+            </a:endParaRPr>
+          </a:p>
+        </p:txBody>
+      </p:sp>
+      <p:sp>
+        <p:nvSpPr>
+          <p:cNvPr id="18" name="Rechteck 17">
+            <a:extLst>
+              <a:ext uri="{FF2B5EF4-FFF2-40B4-BE49-F238E27FC236}">
+                <a16:creationId xmlns:a16="http://schemas.microsoft.com/office/drawing/2014/main" id="{9D8B12D0-9DAD-A95F-A02F-A04DE541D391}"/>
+              </a:ext>
+            </a:extLst>
+          </p:cNvPr>
+          <p:cNvSpPr/>
+          <p:nvPr/>
+        </p:nvSpPr>
+        <p:spPr>
+          <a:xfrm>
+            <a:off x="973213" y="1516839"/>
+            <a:ext cx="1522387" cy="884582"/>
+          </a:xfrm>
+          <a:prstGeom prst="rect">
+            <a:avLst/>
+          </a:prstGeom>
+          <a:solidFill>
+            <a:schemeClr val="accent1">
+              <a:lumMod val="20000"/>
+              <a:lumOff val="80000"/>
+            </a:schemeClr>
+          </a:solidFill>
+          <a:ln>
+            <a:noFill/>
+          </a:ln>
+        </p:spPr>
+        <p:style>
+          <a:lnRef idx="2">
+            <a:schemeClr val="accent1">
+              <a:shade val="15000"/>
+            </a:schemeClr>
+          </a:lnRef>
+          <a:fillRef idx="1">
+            <a:schemeClr val="accent1"/>
+          </a:fillRef>
+          <a:effectRef idx="0">
+            <a:schemeClr val="accent1"/>
+          </a:effectRef>
+          <a:fontRef idx="minor">
+            <a:schemeClr val="lt1"/>
+          </a:fontRef>
+        </p:style>
+        <p:txBody>
+          <a:bodyPr rtlCol="0" anchor="ctr"/>
+          <a:lstStyle/>
+          <a:p>
+            <a:r>
+              <a:rPr lang="de-DE" sz="1100" dirty="0">
+                <a:solidFill>
+                  <a:schemeClr val="tx1">
+                    <a:lumMod val="75000"/>
+                  </a:schemeClr>
+                </a:solidFill>
+              </a:rPr>
+              <a:t>Eine Terrasse nach Süden raus mit direktem Zugang aus dem Wohnzimmer</a:t>
+            </a:r>
+          </a:p>
+        </p:txBody>
+      </p:sp>
+      <p:sp>
+        <p:nvSpPr>
+          <p:cNvPr id="19" name="Rechteck 18">
+            <a:extLst>
+              <a:ext uri="{FF2B5EF4-FFF2-40B4-BE49-F238E27FC236}">
+                <a16:creationId xmlns:a16="http://schemas.microsoft.com/office/drawing/2014/main" id="{41E5EA9C-6014-0BBE-94F8-A71B11CAA03E}"/>
+              </a:ext>
+            </a:extLst>
+          </p:cNvPr>
+          <p:cNvSpPr/>
+          <p:nvPr/>
+        </p:nvSpPr>
+        <p:spPr>
+          <a:xfrm>
+            <a:off x="1232905" y="3248118"/>
+            <a:ext cx="1085229" cy="555037"/>
+          </a:xfrm>
+          <a:prstGeom prst="rect">
+            <a:avLst/>
+          </a:prstGeom>
+          <a:solidFill>
+            <a:schemeClr val="accent1">
+              <a:lumMod val="20000"/>
+              <a:lumOff val="80000"/>
+            </a:schemeClr>
+          </a:solidFill>
+          <a:ln>
+            <a:noFill/>
+          </a:ln>
+        </p:spPr>
+        <p:style>
+          <a:lnRef idx="2">
+            <a:schemeClr val="accent1">
+              <a:shade val="15000"/>
+            </a:schemeClr>
+          </a:lnRef>
+          <a:fillRef idx="1">
+            <a:schemeClr val="accent1"/>
+          </a:fillRef>
+          <a:effectRef idx="0">
+            <a:schemeClr val="accent1"/>
+          </a:effectRef>
+          <a:fontRef idx="minor">
+            <a:schemeClr val="lt1"/>
+          </a:fontRef>
+        </p:style>
+        <p:txBody>
+          <a:bodyPr rtlCol="0" anchor="ctr"/>
+          <a:lstStyle/>
+          <a:p>
+            <a:r>
+              <a:rPr lang="de-DE" sz="1100" dirty="0">
+                <a:solidFill>
+                  <a:schemeClr val="tx1">
+                    <a:lumMod val="75000"/>
+                  </a:schemeClr>
+                </a:solidFill>
+              </a:rPr>
+              <a:t>Beschreibung „mit Händen und Füßen“</a:t>
+            </a:r>
+          </a:p>
+        </p:txBody>
+      </p:sp>
+      <p:sp>
+        <p:nvSpPr>
+          <p:cNvPr id="20" name="Rechteck 19">
+            <a:extLst>
+              <a:ext uri="{FF2B5EF4-FFF2-40B4-BE49-F238E27FC236}">
+                <a16:creationId xmlns:a16="http://schemas.microsoft.com/office/drawing/2014/main" id="{5F4F8316-1838-5E36-B8E2-ADE2A0EF8D49}"/>
+              </a:ext>
+            </a:extLst>
+          </p:cNvPr>
+          <p:cNvSpPr/>
+          <p:nvPr/>
+        </p:nvSpPr>
+        <p:spPr>
+          <a:xfrm>
+            <a:off x="3061792" y="1516839"/>
+            <a:ext cx="1394792" cy="884582"/>
+          </a:xfrm>
+          <a:prstGeom prst="rect">
+            <a:avLst/>
+          </a:prstGeom>
+          <a:solidFill>
+            <a:schemeClr val="accent1">
+              <a:lumMod val="20000"/>
+              <a:lumOff val="80000"/>
+            </a:schemeClr>
+          </a:solidFill>
+          <a:ln>
+            <a:noFill/>
+          </a:ln>
+        </p:spPr>
+        <p:style>
+          <a:lnRef idx="2">
+            <a:schemeClr val="accent1">
+              <a:shade val="15000"/>
+            </a:schemeClr>
+          </a:lnRef>
+          <a:fillRef idx="1">
+            <a:schemeClr val="accent1"/>
+          </a:fillRef>
+          <a:effectRef idx="0">
+            <a:schemeClr val="accent1"/>
+          </a:effectRef>
+          <a:fontRef idx="minor">
+            <a:schemeClr val="lt1"/>
+          </a:fontRef>
+        </p:style>
+        <p:txBody>
+          <a:bodyPr rtlCol="0" anchor="ctr"/>
+          <a:lstStyle/>
+          <a:p>
+            <a:r>
+              <a:rPr lang="de-DE" sz="1100" dirty="0">
+                <a:solidFill>
+                  <a:schemeClr val="tx1">
+                    <a:lumMod val="75000"/>
+                  </a:schemeClr>
+                </a:solidFill>
+              </a:rPr>
+              <a:t>Architekt kommt vorbei und bringt Pflasterer und Fensterbauer mit</a:t>
+            </a:r>
+          </a:p>
+        </p:txBody>
+      </p:sp>
+      <p:sp>
+        <p:nvSpPr>
+          <p:cNvPr id="21" name="Rechteck 20">
+            <a:extLst>
+              <a:ext uri="{FF2B5EF4-FFF2-40B4-BE49-F238E27FC236}">
+                <a16:creationId xmlns:a16="http://schemas.microsoft.com/office/drawing/2014/main" id="{F7E4C994-1E45-CB29-7F83-E816B0273124}"/>
+              </a:ext>
+            </a:extLst>
+          </p:cNvPr>
+          <p:cNvSpPr/>
+          <p:nvPr/>
+        </p:nvSpPr>
+        <p:spPr>
+          <a:xfrm>
+            <a:off x="3177121" y="3227015"/>
+            <a:ext cx="1085229" cy="767695"/>
+          </a:xfrm>
+          <a:prstGeom prst="rect">
+            <a:avLst/>
+          </a:prstGeom>
+          <a:solidFill>
+            <a:schemeClr val="accent1">
+              <a:lumMod val="20000"/>
+              <a:lumOff val="80000"/>
+            </a:schemeClr>
+          </a:solidFill>
+          <a:ln>
+            <a:noFill/>
+          </a:ln>
+        </p:spPr>
+        <p:style>
+          <a:lnRef idx="2">
+            <a:schemeClr val="accent1">
+              <a:shade val="15000"/>
+            </a:schemeClr>
+          </a:lnRef>
+          <a:fillRef idx="1">
+            <a:schemeClr val="accent1"/>
+          </a:fillRef>
+          <a:effectRef idx="0">
+            <a:schemeClr val="accent1"/>
+          </a:effectRef>
+          <a:fontRef idx="minor">
+            <a:schemeClr val="lt1"/>
+          </a:fontRef>
+        </p:style>
+        <p:txBody>
+          <a:bodyPr rtlCol="0" anchor="ctr"/>
+          <a:lstStyle/>
+          <a:p>
+            <a:r>
+              <a:rPr lang="de-DE" sz="1100" dirty="0">
+                <a:solidFill>
+                  <a:schemeClr val="tx1">
+                    <a:lumMod val="75000"/>
+                  </a:schemeClr>
+                </a:solidFill>
+              </a:rPr>
+              <a:t>Ein paar Skizzen und handschrift-</a:t>
+            </a:r>
+            <a:r>
+              <a:rPr lang="de-DE" sz="1100" dirty="0" err="1">
+                <a:solidFill>
+                  <a:schemeClr val="tx1">
+                    <a:lumMod val="75000"/>
+                  </a:schemeClr>
+                </a:solidFill>
+              </a:rPr>
+              <a:t>liche</a:t>
+            </a:r>
+            <a:r>
+              <a:rPr lang="de-DE" sz="1100" dirty="0">
+                <a:solidFill>
+                  <a:schemeClr val="tx1">
+                    <a:lumMod val="75000"/>
+                  </a:schemeClr>
+                </a:solidFill>
+              </a:rPr>
+              <a:t> Notizen</a:t>
+            </a:r>
+          </a:p>
+        </p:txBody>
+      </p:sp>
+      <p:sp>
+        <p:nvSpPr>
+          <p:cNvPr id="22" name="Rechteck 21">
+            <a:extLst>
+              <a:ext uri="{FF2B5EF4-FFF2-40B4-BE49-F238E27FC236}">
+                <a16:creationId xmlns:a16="http://schemas.microsoft.com/office/drawing/2014/main" id="{F67EA686-356C-B2AD-3445-83E927702A7D}"/>
+              </a:ext>
+            </a:extLst>
+          </p:cNvPr>
+          <p:cNvSpPr/>
+          <p:nvPr/>
+        </p:nvSpPr>
+        <p:spPr>
+          <a:xfrm>
+            <a:off x="5002560" y="3175881"/>
+            <a:ext cx="1309464" cy="873272"/>
+          </a:xfrm>
+          <a:prstGeom prst="rect">
+            <a:avLst/>
+          </a:prstGeom>
+          <a:solidFill>
+            <a:schemeClr val="accent1">
+              <a:lumMod val="20000"/>
+              <a:lumOff val="80000"/>
+            </a:schemeClr>
+          </a:solidFill>
+          <a:ln>
+            <a:noFill/>
+          </a:ln>
+        </p:spPr>
+        <p:style>
+          <a:lnRef idx="2">
+            <a:schemeClr val="accent1">
+              <a:shade val="15000"/>
+            </a:schemeClr>
+          </a:lnRef>
+          <a:fillRef idx="1">
+            <a:schemeClr val="accent1"/>
+          </a:fillRef>
+          <a:effectRef idx="0">
+            <a:schemeClr val="accent1"/>
+          </a:effectRef>
+          <a:fontRef idx="minor">
+            <a:schemeClr val="lt1"/>
+          </a:fontRef>
+        </p:style>
+        <p:txBody>
+          <a:bodyPr rtlCol="0" anchor="ctr"/>
+          <a:lstStyle/>
+          <a:p>
+            <a:r>
+              <a:rPr lang="de-DE" sz="1100" dirty="0">
+                <a:solidFill>
+                  <a:schemeClr val="tx1">
+                    <a:lumMod val="75000"/>
+                  </a:schemeClr>
+                </a:solidFill>
+              </a:rPr>
+              <a:t>Detaillierte Bauzeichnung mit Bemaßungen, vom Bauherrn freizugeben</a:t>
+            </a:r>
+          </a:p>
+        </p:txBody>
+      </p:sp>
+      <p:sp>
+        <p:nvSpPr>
+          <p:cNvPr id="23" name="Rechteck 22">
+            <a:extLst>
+              <a:ext uri="{FF2B5EF4-FFF2-40B4-BE49-F238E27FC236}">
+                <a16:creationId xmlns:a16="http://schemas.microsoft.com/office/drawing/2014/main" id="{85EA5588-315A-EAA5-71C1-047F9D5FAFB1}"/>
+              </a:ext>
+            </a:extLst>
+          </p:cNvPr>
+          <p:cNvSpPr/>
+          <p:nvPr/>
+        </p:nvSpPr>
+        <p:spPr>
+          <a:xfrm>
+            <a:off x="6946776" y="1543457"/>
+            <a:ext cx="1394792" cy="910637"/>
+          </a:xfrm>
+          <a:prstGeom prst="rect">
+            <a:avLst/>
+          </a:prstGeom>
+          <a:solidFill>
+            <a:schemeClr val="accent1">
+              <a:lumMod val="20000"/>
+              <a:lumOff val="80000"/>
+            </a:schemeClr>
+          </a:solidFill>
+          <a:ln>
+            <a:noFill/>
+          </a:ln>
+        </p:spPr>
+        <p:style>
+          <a:lnRef idx="2">
+            <a:schemeClr val="accent1">
+              <a:shade val="15000"/>
+            </a:schemeClr>
+          </a:lnRef>
+          <a:fillRef idx="1">
+            <a:schemeClr val="accent1"/>
+          </a:fillRef>
+          <a:effectRef idx="0">
+            <a:schemeClr val="accent1"/>
+          </a:effectRef>
+          <a:fontRef idx="minor">
+            <a:schemeClr val="lt1"/>
+          </a:fontRef>
+        </p:style>
+        <p:txBody>
+          <a:bodyPr rtlCol="0" anchor="ctr"/>
+          <a:lstStyle/>
+          <a:p>
+            <a:r>
+              <a:rPr lang="de-DE" sz="1100" dirty="0">
+                <a:solidFill>
+                  <a:schemeClr val="tx1">
+                    <a:lumMod val="75000"/>
+                  </a:schemeClr>
+                </a:solidFill>
+              </a:rPr>
+              <a:t>Baumaßnahme nach den Regeln der Handwerks-kunst UND…</a:t>
+            </a:r>
+          </a:p>
+          <a:p>
+            <a:r>
+              <a:rPr lang="de-DE" sz="1100" dirty="0">
+                <a:solidFill>
+                  <a:schemeClr val="tx1">
+                    <a:lumMod val="75000"/>
+                  </a:schemeClr>
+                </a:solidFill>
+              </a:rPr>
+              <a:t>der Bauzeichnung</a:t>
+            </a:r>
+          </a:p>
+        </p:txBody>
+      </p:sp>
+      <p:sp>
+        <p:nvSpPr>
+          <p:cNvPr id="24" name="Rechteck 23">
+            <a:extLst>
+              <a:ext uri="{FF2B5EF4-FFF2-40B4-BE49-F238E27FC236}">
+                <a16:creationId xmlns:a16="http://schemas.microsoft.com/office/drawing/2014/main" id="{F6CE045F-58B9-221D-807E-D1385FEEA273}"/>
+              </a:ext>
+            </a:extLst>
+          </p:cNvPr>
+          <p:cNvSpPr/>
+          <p:nvPr/>
+        </p:nvSpPr>
+        <p:spPr>
+          <a:xfrm>
+            <a:off x="7177919" y="3213782"/>
+            <a:ext cx="890017" cy="566317"/>
+          </a:xfrm>
+          <a:prstGeom prst="rect">
+            <a:avLst/>
+          </a:prstGeom>
+          <a:solidFill>
+            <a:schemeClr val="accent1">
+              <a:lumMod val="20000"/>
+              <a:lumOff val="80000"/>
+            </a:schemeClr>
+          </a:solidFill>
+          <a:ln>
+            <a:noFill/>
+          </a:ln>
+        </p:spPr>
+        <p:style>
+          <a:lnRef idx="2">
+            <a:schemeClr val="accent1">
+              <a:shade val="15000"/>
+            </a:schemeClr>
+          </a:lnRef>
+          <a:fillRef idx="1">
+            <a:schemeClr val="accent1"/>
+          </a:fillRef>
+          <a:effectRef idx="0">
+            <a:schemeClr val="accent1"/>
+          </a:effectRef>
+          <a:fontRef idx="minor">
+            <a:schemeClr val="lt1"/>
+          </a:fontRef>
+        </p:style>
+        <p:txBody>
+          <a:bodyPr rtlCol="0" anchor="ctr"/>
+          <a:lstStyle/>
+          <a:p>
+            <a:r>
+              <a:rPr lang="de-DE" sz="1100" dirty="0">
+                <a:solidFill>
+                  <a:schemeClr val="tx1">
+                    <a:lumMod val="75000"/>
+                  </a:schemeClr>
+                </a:solidFill>
+              </a:rPr>
+              <a:t>Die Terrasse</a:t>
+            </a:r>
+          </a:p>
+        </p:txBody>
+      </p:sp>
+      <p:sp>
+        <p:nvSpPr>
+          <p:cNvPr id="25" name="Rechteck 24">
+            <a:extLst>
+              <a:ext uri="{FF2B5EF4-FFF2-40B4-BE49-F238E27FC236}">
+                <a16:creationId xmlns:a16="http://schemas.microsoft.com/office/drawing/2014/main" id="{8F377EB4-8892-4473-148D-5E76212829CC}"/>
+              </a:ext>
+            </a:extLst>
+          </p:cNvPr>
+          <p:cNvSpPr/>
+          <p:nvPr/>
+        </p:nvSpPr>
+        <p:spPr>
+          <a:xfrm>
+            <a:off x="9120336" y="3187688"/>
+            <a:ext cx="890017" cy="566317"/>
+          </a:xfrm>
+          <a:prstGeom prst="rect">
+            <a:avLst/>
+          </a:prstGeom>
+          <a:solidFill>
+            <a:schemeClr val="accent1">
+              <a:lumMod val="20000"/>
+              <a:lumOff val="80000"/>
+            </a:schemeClr>
+          </a:solidFill>
+          <a:ln>
+            <a:noFill/>
+          </a:ln>
+        </p:spPr>
+        <p:style>
+          <a:lnRef idx="2">
+            <a:schemeClr val="accent1">
+              <a:shade val="15000"/>
+            </a:schemeClr>
+          </a:lnRef>
+          <a:fillRef idx="1">
+            <a:schemeClr val="accent1"/>
+          </a:fillRef>
+          <a:effectRef idx="0">
+            <a:schemeClr val="accent1"/>
+          </a:effectRef>
+          <a:fontRef idx="minor">
+            <a:schemeClr val="lt1"/>
+          </a:fontRef>
+        </p:style>
+        <p:txBody>
+          <a:bodyPr rtlCol="0" anchor="ctr"/>
+          <a:lstStyle/>
+          <a:p>
+            <a:r>
+              <a:rPr lang="de-DE" sz="1100" dirty="0">
+                <a:solidFill>
+                  <a:schemeClr val="tx1">
+                    <a:lumMod val="75000"/>
+                  </a:schemeClr>
+                </a:solidFill>
+              </a:rPr>
+              <a:t>Endgültige Bezahlung</a:t>
+            </a:r>
+          </a:p>
+        </p:txBody>
+      </p:sp>
+      <p:sp>
+        <p:nvSpPr>
+          <p:cNvPr id="26" name="Rechteck 25">
+            <a:extLst>
+              <a:ext uri="{FF2B5EF4-FFF2-40B4-BE49-F238E27FC236}">
+                <a16:creationId xmlns:a16="http://schemas.microsoft.com/office/drawing/2014/main" id="{F0095B18-6DA2-D9DB-0823-470723321373}"/>
+              </a:ext>
+            </a:extLst>
+          </p:cNvPr>
+          <p:cNvSpPr/>
+          <p:nvPr/>
+        </p:nvSpPr>
+        <p:spPr>
+          <a:xfrm>
+            <a:off x="8889912" y="1470116"/>
+            <a:ext cx="1394792" cy="910637"/>
+          </a:xfrm>
+          <a:prstGeom prst="rect">
+            <a:avLst/>
+          </a:prstGeom>
+          <a:solidFill>
+            <a:schemeClr val="accent1">
+              <a:lumMod val="20000"/>
+              <a:lumOff val="80000"/>
+            </a:schemeClr>
+          </a:solidFill>
+          <a:ln>
+            <a:noFill/>
+          </a:ln>
+        </p:spPr>
+        <p:style>
+          <a:lnRef idx="2">
+            <a:schemeClr val="accent1">
+              <a:shade val="15000"/>
+            </a:schemeClr>
+          </a:lnRef>
+          <a:fillRef idx="1">
+            <a:schemeClr val="accent1"/>
+          </a:fillRef>
+          <a:effectRef idx="0">
+            <a:schemeClr val="accent1"/>
+          </a:effectRef>
+          <a:fontRef idx="minor">
+            <a:schemeClr val="lt1"/>
+          </a:fontRef>
+        </p:style>
+        <p:txBody>
+          <a:bodyPr rtlCol="0" anchor="ctr"/>
+          <a:lstStyle/>
+          <a:p>
+            <a:r>
+              <a:rPr lang="de-DE" sz="1100" dirty="0">
+                <a:solidFill>
+                  <a:schemeClr val="tx1">
+                    <a:lumMod val="75000"/>
+                  </a:schemeClr>
+                </a:solidFill>
+              </a:rPr>
+              <a:t>Prüfung auf Einhaltung der handwerklichen Sorgfalt UND…</a:t>
+            </a:r>
+          </a:p>
+          <a:p>
+            <a:r>
+              <a:rPr lang="de-DE" sz="1100" dirty="0">
+                <a:solidFill>
+                  <a:schemeClr val="tx1">
+                    <a:lumMod val="75000"/>
+                  </a:schemeClr>
+                </a:solidFill>
+              </a:rPr>
+              <a:t>der  Bauzeichnung</a:t>
+            </a:r>
+          </a:p>
+        </p:txBody>
+      </p:sp>
+      <p:sp>
+        <p:nvSpPr>
+          <p:cNvPr id="10" name="Textfeld 9">
+            <a:extLst>
+              <a:ext uri="{FF2B5EF4-FFF2-40B4-BE49-F238E27FC236}">
+                <a16:creationId xmlns:a16="http://schemas.microsoft.com/office/drawing/2014/main" id="{57FF0BA4-635F-F5C5-CDAF-C517669281C3}"/>
+              </a:ext>
+            </a:extLst>
+          </p:cNvPr>
+          <p:cNvSpPr txBox="1"/>
+          <p:nvPr/>
+        </p:nvSpPr>
+        <p:spPr>
+          <a:xfrm>
+            <a:off x="322327" y="3379649"/>
+            <a:ext cx="813043" cy="246221"/>
+          </a:xfrm>
+          <a:prstGeom prst="rect">
+            <a:avLst/>
+          </a:prstGeom>
+          <a:noFill/>
+        </p:spPr>
+        <p:txBody>
+          <a:bodyPr wrap="none" rtlCol="0">
+            <a:spAutoFit/>
+          </a:bodyPr>
+          <a:lstStyle/>
+          <a:p>
+            <a:r>
+              <a:rPr lang="de-DE" sz="1000" dirty="0"/>
+              <a:t>Ergebnisse</a:t>
+            </a:r>
+          </a:p>
+        </p:txBody>
+      </p:sp>
+      <p:sp>
+        <p:nvSpPr>
+          <p:cNvPr id="38" name="Textfeld 37">
+            <a:extLst>
+              <a:ext uri="{FF2B5EF4-FFF2-40B4-BE49-F238E27FC236}">
+                <a16:creationId xmlns:a16="http://schemas.microsoft.com/office/drawing/2014/main" id="{CF478221-199D-AF4C-0FED-FB0D256F3434}"/>
+              </a:ext>
+            </a:extLst>
+          </p:cNvPr>
+          <p:cNvSpPr txBox="1"/>
+          <p:nvPr/>
+        </p:nvSpPr>
+        <p:spPr>
+          <a:xfrm>
+            <a:off x="4763943" y="1509957"/>
+            <a:ext cx="1856598" cy="400110"/>
+          </a:xfrm>
+          <a:prstGeom prst="rect">
+            <a:avLst/>
+          </a:prstGeom>
+          <a:noFill/>
+        </p:spPr>
+        <p:txBody>
+          <a:bodyPr wrap="none" rtlCol="0">
+            <a:spAutoFit/>
+          </a:bodyPr>
+          <a:lstStyle/>
+          <a:p>
+            <a:r>
+              <a:rPr lang="de-DE" sz="2000" b="1" dirty="0" err="1"/>
+              <a:t>Craftsmanship</a:t>
+            </a:r>
+            <a:endParaRPr lang="de-DE" sz="2000" b="1" dirty="0"/>
+          </a:p>
+        </p:txBody>
+      </p:sp>
+      <p:grpSp>
+        <p:nvGrpSpPr>
+          <p:cNvPr id="3" name="Gruppieren 2">
+            <a:extLst>
+              <a:ext uri="{FF2B5EF4-FFF2-40B4-BE49-F238E27FC236}">
+                <a16:creationId xmlns:a16="http://schemas.microsoft.com/office/drawing/2014/main" id="{971190BC-F846-BBC2-5180-21DB908E3AC9}"/>
+              </a:ext>
+            </a:extLst>
+          </p:cNvPr>
+          <p:cNvGrpSpPr/>
+          <p:nvPr/>
+        </p:nvGrpSpPr>
+        <p:grpSpPr>
+          <a:xfrm>
+            <a:off x="751379" y="4282226"/>
+            <a:ext cx="9953133" cy="1739062"/>
+            <a:chOff x="751379" y="4282226"/>
+            <a:chExt cx="9953133" cy="1739062"/>
+          </a:xfrm>
+        </p:grpSpPr>
+        <p:sp>
+          <p:nvSpPr>
+            <p:cNvPr id="29" name="Pfeil: Chevron 28">
+              <a:extLst>
+                <a:ext uri="{FF2B5EF4-FFF2-40B4-BE49-F238E27FC236}">
+                  <a16:creationId xmlns:a16="http://schemas.microsoft.com/office/drawing/2014/main" id="{A85A51D4-C46E-0891-FD98-89FF220F8E2F}"/>
+                </a:ext>
+              </a:extLst>
+            </p:cNvPr>
+            <p:cNvSpPr/>
+            <p:nvPr/>
+          </p:nvSpPr>
+          <p:spPr>
+            <a:xfrm>
+              <a:off x="846312" y="4690850"/>
+              <a:ext cx="2088232" cy="1080120"/>
+            </a:xfrm>
+            <a:prstGeom prst="chevron">
+              <a:avLst>
+                <a:gd name="adj" fmla="val 26529"/>
+              </a:avLst>
+            </a:prstGeom>
+            <a:solidFill>
+              <a:srgbClr val="FFC000"/>
+            </a:solidFill>
+            <a:ln w="9525" cap="flat" cmpd="sng" algn="ctr">
+              <a:noFill/>
+              <a:prstDash val="solid"/>
+            </a:ln>
+            <a:effectLst/>
+          </p:spPr>
+          <p:txBody>
+            <a:bodyPr rtlCol="0" anchor="ctr"/>
+            <a:lstStyle/>
+            <a:p>
+              <a:pPr algn="ctr"/>
+              <a:endParaRPr lang="de-DE" sz="2000" dirty="0"/>
+            </a:p>
+            <a:p>
+              <a:pPr algn="ctr"/>
+              <a:r>
+                <a:rPr lang="de-DE" sz="2000" dirty="0"/>
+                <a:t>Change</a:t>
+              </a:r>
+            </a:p>
+            <a:p>
+              <a:pPr algn="ctr"/>
+              <a:r>
+                <a:rPr lang="de-DE" sz="2000" dirty="0"/>
+                <a:t>Request</a:t>
+              </a:r>
+            </a:p>
+            <a:p>
+              <a:pPr marL="0" marR="0" indent="0" algn="ctr" defTabSz="914400" eaLnBrk="1" fontAlgn="auto" latinLnBrk="0" hangingPunct="1">
+                <a:lnSpc>
+                  <a:spcPct val="100000"/>
+                </a:lnSpc>
+                <a:spcBef>
+                  <a:spcPts val="0"/>
+                </a:spcBef>
+                <a:spcAft>
+                  <a:spcPts val="0"/>
+                </a:spcAft>
+                <a:buClrTx/>
+                <a:buSzTx/>
+                <a:buFontTx/>
+                <a:buNone/>
+                <a:tabLst/>
+              </a:pPr>
+              <a:endParaRPr kumimoji="0" lang="de-DE" sz="2000" b="1" i="0" u="none" strike="noStrike" kern="0" cap="none" spc="0" normalizeH="0" baseline="0" noProof="0" dirty="0">
+                <a:ln>
+                  <a:noFill/>
+                </a:ln>
+                <a:effectLst/>
+                <a:uLnTx/>
+                <a:uFillTx/>
+                <a:latin typeface="Arial" panose="020B0604020202020204"/>
+                <a:ea typeface="+mn-ea"/>
+                <a:cs typeface="Arial" panose="020B0604020202020204" pitchFamily="34" charset="0"/>
+              </a:endParaRPr>
+            </a:p>
+          </p:txBody>
+        </p:sp>
+        <p:sp>
+          <p:nvSpPr>
+            <p:cNvPr id="30" name="Pfeil: Chevron 29">
+              <a:extLst>
+                <a:ext uri="{FF2B5EF4-FFF2-40B4-BE49-F238E27FC236}">
+                  <a16:creationId xmlns:a16="http://schemas.microsoft.com/office/drawing/2014/main" id="{1ACD9667-B1FA-D522-12C2-FA5D1286A847}"/>
+                </a:ext>
+              </a:extLst>
+            </p:cNvPr>
+            <p:cNvSpPr/>
+            <p:nvPr/>
+          </p:nvSpPr>
+          <p:spPr>
+            <a:xfrm>
+              <a:off x="2788920" y="4686863"/>
+              <a:ext cx="2088232" cy="1080120"/>
+            </a:xfrm>
+            <a:prstGeom prst="chevron">
+              <a:avLst>
+                <a:gd name="adj" fmla="val 26529"/>
+              </a:avLst>
+            </a:prstGeom>
+            <a:solidFill>
+              <a:srgbClr val="FFC000"/>
+            </a:solidFill>
+            <a:ln w="9525" cap="flat" cmpd="sng" algn="ctr">
+              <a:noFill/>
+              <a:prstDash val="solid"/>
+            </a:ln>
+            <a:effectLst/>
+          </p:spPr>
+          <p:txBody>
+            <a:bodyPr rtlCol="0" anchor="ctr"/>
+            <a:lstStyle/>
+            <a:p>
+              <a:pPr algn="ctr"/>
+              <a:endParaRPr lang="de-DE" sz="2000" dirty="0"/>
+            </a:p>
+            <a:p>
+              <a:pPr algn="ctr"/>
+              <a:r>
+                <a:rPr lang="de-DE" sz="2000" dirty="0" err="1"/>
+                <a:t>Refinement</a:t>
+              </a:r>
+              <a:endParaRPr lang="de-DE" sz="2000" dirty="0"/>
+            </a:p>
+            <a:p>
+              <a:pPr marL="0" marR="0" indent="0" algn="ctr" defTabSz="914400" eaLnBrk="1" fontAlgn="auto" latinLnBrk="0" hangingPunct="1">
+                <a:lnSpc>
+                  <a:spcPct val="100000"/>
+                </a:lnSpc>
+                <a:spcBef>
+                  <a:spcPts val="0"/>
+                </a:spcBef>
+                <a:spcAft>
+                  <a:spcPts val="0"/>
+                </a:spcAft>
+                <a:buClrTx/>
+                <a:buSzTx/>
+                <a:buFontTx/>
+                <a:buNone/>
+                <a:tabLst/>
+              </a:pPr>
+              <a:endParaRPr kumimoji="0" lang="de-DE" sz="2000" b="1" i="0" u="none" strike="noStrike" kern="0" cap="none" spc="0" normalizeH="0" baseline="0" noProof="0" dirty="0">
+                <a:ln>
+                  <a:noFill/>
+                </a:ln>
+                <a:effectLst/>
+                <a:uLnTx/>
+                <a:uFillTx/>
+                <a:latin typeface="Arial" panose="020B0604020202020204"/>
+                <a:ea typeface="+mn-ea"/>
+                <a:cs typeface="Arial" panose="020B0604020202020204" pitchFamily="34" charset="0"/>
+              </a:endParaRPr>
+            </a:p>
+          </p:txBody>
+        </p:sp>
+        <p:sp>
+          <p:nvSpPr>
+            <p:cNvPr id="31" name="Pfeil: Chevron 30">
+              <a:extLst>
+                <a:ext uri="{FF2B5EF4-FFF2-40B4-BE49-F238E27FC236}">
+                  <a16:creationId xmlns:a16="http://schemas.microsoft.com/office/drawing/2014/main" id="{22BCD251-A12D-9382-7780-746A2E996C6E}"/>
+                </a:ext>
+              </a:extLst>
+            </p:cNvPr>
+            <p:cNvSpPr/>
+            <p:nvPr/>
+          </p:nvSpPr>
+          <p:spPr>
+            <a:xfrm>
+              <a:off x="4731373" y="4690850"/>
+              <a:ext cx="2088232" cy="1080120"/>
+            </a:xfrm>
+            <a:prstGeom prst="chevron">
+              <a:avLst>
+                <a:gd name="adj" fmla="val 26529"/>
+              </a:avLst>
+            </a:prstGeom>
+            <a:solidFill>
+              <a:srgbClr val="FFC000"/>
+            </a:solidFill>
+            <a:ln w="9525" cap="flat" cmpd="sng" algn="ctr">
+              <a:noFill/>
+              <a:prstDash val="solid"/>
+            </a:ln>
+            <a:effectLst/>
+          </p:spPr>
+          <p:txBody>
+            <a:bodyPr rtlCol="0" anchor="ctr"/>
+            <a:lstStyle/>
+            <a:p>
+              <a:pPr algn="ctr"/>
+              <a:endParaRPr lang="de-DE" sz="2000" dirty="0"/>
+            </a:p>
+            <a:p>
+              <a:pPr algn="ctr"/>
+              <a:r>
+                <a:rPr lang="de-DE" sz="3200" b="1" dirty="0">
+                  <a:latin typeface="Open Sans" panose="020B0606030504020204" pitchFamily="34" charset="0"/>
+                  <a:ea typeface="Open Sans" panose="020B0606030504020204" pitchFamily="34" charset="0"/>
+                  <a:cs typeface="Open Sans" panose="020B0606030504020204" pitchFamily="34" charset="0"/>
+                </a:rPr>
+                <a:t>?</a:t>
+              </a:r>
+            </a:p>
+            <a:p>
+              <a:pPr marL="0" marR="0" indent="0" algn="ctr" defTabSz="914400" eaLnBrk="1" fontAlgn="auto" latinLnBrk="0" hangingPunct="1">
+                <a:lnSpc>
+                  <a:spcPct val="100000"/>
+                </a:lnSpc>
+                <a:spcBef>
+                  <a:spcPts val="0"/>
+                </a:spcBef>
+                <a:spcAft>
+                  <a:spcPts val="0"/>
+                </a:spcAft>
+                <a:buClrTx/>
+                <a:buSzTx/>
+                <a:buFontTx/>
+                <a:buNone/>
+                <a:tabLst/>
+              </a:pPr>
+              <a:endParaRPr kumimoji="0" lang="de-DE" sz="2000" b="1" i="0" u="none" strike="noStrike" kern="0" cap="none" spc="0" normalizeH="0" baseline="0" noProof="0" dirty="0">
+                <a:ln>
+                  <a:noFill/>
+                </a:ln>
+                <a:effectLst/>
+                <a:uLnTx/>
+                <a:uFillTx/>
+                <a:latin typeface="Arial" panose="020B0604020202020204"/>
+                <a:ea typeface="+mn-ea"/>
+                <a:cs typeface="Arial" panose="020B0604020202020204" pitchFamily="34" charset="0"/>
+              </a:endParaRPr>
+            </a:p>
+          </p:txBody>
+        </p:sp>
+        <p:sp>
+          <p:nvSpPr>
+            <p:cNvPr id="32" name="Pfeil: Chevron 31">
+              <a:extLst>
+                <a:ext uri="{FF2B5EF4-FFF2-40B4-BE49-F238E27FC236}">
+                  <a16:creationId xmlns:a16="http://schemas.microsoft.com/office/drawing/2014/main" id="{45B47365-D35F-BB0C-46EF-1950C2F220C5}"/>
+                </a:ext>
+              </a:extLst>
+            </p:cNvPr>
+            <p:cNvSpPr/>
+            <p:nvPr/>
+          </p:nvSpPr>
+          <p:spPr>
+            <a:xfrm>
+              <a:off x="6672064" y="4702657"/>
+              <a:ext cx="2088232" cy="1080120"/>
+            </a:xfrm>
+            <a:prstGeom prst="chevron">
+              <a:avLst>
+                <a:gd name="adj" fmla="val 26529"/>
+              </a:avLst>
+            </a:prstGeom>
+            <a:solidFill>
+              <a:srgbClr val="FFC000"/>
+            </a:solidFill>
+            <a:ln w="9525" cap="flat" cmpd="sng" algn="ctr">
+              <a:noFill/>
+              <a:prstDash val="solid"/>
+            </a:ln>
+            <a:effectLst/>
+          </p:spPr>
+          <p:txBody>
+            <a:bodyPr rtlCol="0" anchor="ctr"/>
+            <a:lstStyle/>
+            <a:p>
+              <a:pPr algn="ctr"/>
+              <a:endParaRPr lang="de-DE" sz="2000" dirty="0"/>
+            </a:p>
+            <a:p>
+              <a:pPr algn="ctr"/>
+              <a:r>
+                <a:rPr lang="de-DE" sz="2000" dirty="0" err="1"/>
+                <a:t>Implemen-tierung</a:t>
+              </a:r>
+              <a:endParaRPr lang="de-DE" sz="2000" dirty="0"/>
+            </a:p>
+            <a:p>
+              <a:pPr marL="0" marR="0" indent="0" algn="ctr" defTabSz="914400" eaLnBrk="1" fontAlgn="auto" latinLnBrk="0" hangingPunct="1">
+                <a:lnSpc>
+                  <a:spcPct val="100000"/>
+                </a:lnSpc>
+                <a:spcBef>
+                  <a:spcPts val="0"/>
+                </a:spcBef>
+                <a:spcAft>
+                  <a:spcPts val="0"/>
+                </a:spcAft>
+                <a:buClrTx/>
+                <a:buSzTx/>
+                <a:buFontTx/>
+                <a:buNone/>
+                <a:tabLst/>
+              </a:pPr>
+              <a:endParaRPr kumimoji="0" lang="de-DE" sz="2000" b="1" i="0" u="none" strike="noStrike" kern="0" cap="none" spc="0" normalizeH="0" baseline="0" noProof="0" dirty="0">
+                <a:ln>
+                  <a:noFill/>
+                </a:ln>
+                <a:effectLst/>
+                <a:uLnTx/>
+                <a:uFillTx/>
+                <a:latin typeface="Arial" panose="020B0604020202020204"/>
+                <a:ea typeface="+mn-ea"/>
+                <a:cs typeface="Arial" panose="020B0604020202020204" pitchFamily="34" charset="0"/>
+              </a:endParaRPr>
+            </a:p>
+          </p:txBody>
+        </p:sp>
+        <p:sp>
+          <p:nvSpPr>
+            <p:cNvPr id="33" name="Pfeil: Chevron 32">
+              <a:extLst>
+                <a:ext uri="{FF2B5EF4-FFF2-40B4-BE49-F238E27FC236}">
+                  <a16:creationId xmlns:a16="http://schemas.microsoft.com/office/drawing/2014/main" id="{98892B3B-6C34-827D-9635-A38513A38425}"/>
+                </a:ext>
+              </a:extLst>
+            </p:cNvPr>
+            <p:cNvSpPr/>
+            <p:nvPr/>
+          </p:nvSpPr>
+          <p:spPr>
+            <a:xfrm>
+              <a:off x="8616280" y="4701530"/>
+              <a:ext cx="2088232" cy="1080120"/>
+            </a:xfrm>
+            <a:prstGeom prst="chevron">
+              <a:avLst>
+                <a:gd name="adj" fmla="val 26529"/>
+              </a:avLst>
+            </a:prstGeom>
+            <a:solidFill>
+              <a:srgbClr val="FFC000"/>
+            </a:solidFill>
+            <a:ln w="9525" cap="flat" cmpd="sng" algn="ctr">
+              <a:noFill/>
+              <a:prstDash val="solid"/>
+            </a:ln>
+            <a:effectLst/>
+          </p:spPr>
+          <p:txBody>
+            <a:bodyPr rtlCol="0" anchor="ctr"/>
+            <a:lstStyle/>
+            <a:p>
+              <a:pPr algn="ctr"/>
+              <a:endParaRPr lang="de-DE" sz="2000" dirty="0"/>
+            </a:p>
+            <a:p>
+              <a:pPr algn="ctr"/>
+              <a:r>
+                <a:rPr lang="de-DE" sz="2000" dirty="0"/>
+                <a:t>Akzeptanz-test</a:t>
+              </a:r>
+            </a:p>
+            <a:p>
+              <a:pPr marL="0" marR="0" indent="0" algn="ctr" defTabSz="914400" eaLnBrk="1" fontAlgn="auto" latinLnBrk="0" hangingPunct="1">
+                <a:lnSpc>
+                  <a:spcPct val="100000"/>
+                </a:lnSpc>
+                <a:spcBef>
+                  <a:spcPts val="0"/>
+                </a:spcBef>
+                <a:spcAft>
+                  <a:spcPts val="0"/>
+                </a:spcAft>
+                <a:buClrTx/>
+                <a:buSzTx/>
+                <a:buFontTx/>
+                <a:buNone/>
+                <a:tabLst/>
+              </a:pPr>
+              <a:endParaRPr kumimoji="0" lang="de-DE" sz="2000" b="1" i="0" u="none" strike="noStrike" kern="0" cap="none" spc="0" normalizeH="0" baseline="0" noProof="0" dirty="0">
+                <a:ln>
+                  <a:noFill/>
+                </a:ln>
+                <a:effectLst/>
+                <a:uLnTx/>
+                <a:uFillTx/>
+                <a:latin typeface="Arial" panose="020B0604020202020204"/>
+                <a:ea typeface="+mn-ea"/>
+                <a:cs typeface="Arial" panose="020B0604020202020204" pitchFamily="34" charset="0"/>
+              </a:endParaRPr>
+            </a:p>
+          </p:txBody>
+        </p:sp>
+        <p:sp>
+          <p:nvSpPr>
+            <p:cNvPr id="39" name="Textfeld 38">
+              <a:extLst>
+                <a:ext uri="{FF2B5EF4-FFF2-40B4-BE49-F238E27FC236}">
+                  <a16:creationId xmlns:a16="http://schemas.microsoft.com/office/drawing/2014/main" id="{6738E563-6448-29A0-A8FD-C14905D10A50}"/>
+                </a:ext>
+              </a:extLst>
+            </p:cNvPr>
+            <p:cNvSpPr txBox="1"/>
+            <p:nvPr/>
+          </p:nvSpPr>
+          <p:spPr>
+            <a:xfrm>
+              <a:off x="751379" y="4282226"/>
+              <a:ext cx="2940228" cy="400110"/>
+            </a:xfrm>
+            <a:prstGeom prst="rect">
+              <a:avLst/>
+            </a:prstGeom>
+            <a:noFill/>
+          </p:spPr>
+          <p:txBody>
+            <a:bodyPr wrap="none" rtlCol="0">
+              <a:spAutoFit/>
+            </a:bodyPr>
+            <a:lstStyle/>
+            <a:p>
+              <a:r>
+                <a:rPr lang="de-DE" sz="2000" b="1" dirty="0"/>
+                <a:t>Software </a:t>
+              </a:r>
+              <a:r>
+                <a:rPr lang="de-DE" sz="2000" b="1" dirty="0" err="1"/>
+                <a:t>Craftsmanship</a:t>
+              </a:r>
+              <a:endParaRPr lang="de-DE" sz="2000" b="1" dirty="0"/>
+            </a:p>
+          </p:txBody>
+        </p:sp>
+        <p:sp>
+          <p:nvSpPr>
+            <p:cNvPr id="41" name="Textfeld 40">
+              <a:extLst>
+                <a:ext uri="{FF2B5EF4-FFF2-40B4-BE49-F238E27FC236}">
+                  <a16:creationId xmlns:a16="http://schemas.microsoft.com/office/drawing/2014/main" id="{CA3508D3-D3E2-FE35-F9AB-143FE218DA85}"/>
+                </a:ext>
+              </a:extLst>
+            </p:cNvPr>
+            <p:cNvSpPr txBox="1"/>
+            <p:nvPr/>
+          </p:nvSpPr>
+          <p:spPr>
+            <a:xfrm>
+              <a:off x="1232905" y="5775067"/>
+              <a:ext cx="8040216" cy="246221"/>
+            </a:xfrm>
+            <a:prstGeom prst="rect">
+              <a:avLst/>
+            </a:prstGeom>
+            <a:noFill/>
+          </p:spPr>
+          <p:txBody>
+            <a:bodyPr wrap="square">
+              <a:spAutoFit/>
+            </a:bodyPr>
+            <a:lstStyle/>
+            <a:p>
+              <a:r>
+                <a:rPr lang="de-DE" sz="1000" dirty="0"/>
+                <a:t>Design </a:t>
+              </a:r>
+              <a:r>
+                <a:rPr lang="de-DE" sz="1000" dirty="0" err="1"/>
+                <a:t>before</a:t>
+              </a:r>
+              <a:r>
+                <a:rPr lang="de-DE" sz="1000" dirty="0"/>
+                <a:t> Implementation: https://clean-code-developer.de/en/the-straight/blue-degree/#elementor-toc__heading-anchor-5</a:t>
+              </a:r>
+            </a:p>
+          </p:txBody>
+        </p:sp>
+      </p:grpSp>
+      <p:sp>
+        <p:nvSpPr>
+          <p:cNvPr id="5" name="Textfeld 4">
+            <a:extLst>
+              <a:ext uri="{FF2B5EF4-FFF2-40B4-BE49-F238E27FC236}">
+                <a16:creationId xmlns:a16="http://schemas.microsoft.com/office/drawing/2014/main" id="{16FDA4B5-FDE3-B5D8-39A0-BDBC7C45E5E6}"/>
+              </a:ext>
+            </a:extLst>
+          </p:cNvPr>
+          <p:cNvSpPr txBox="1"/>
+          <p:nvPr/>
+        </p:nvSpPr>
+        <p:spPr>
+          <a:xfrm rot="20912112">
+            <a:off x="5039329" y="5026868"/>
+            <a:ext cx="1635384" cy="400110"/>
+          </a:xfrm>
+          <a:prstGeom prst="rect">
+            <a:avLst/>
+          </a:prstGeom>
+          <a:solidFill>
+            <a:srgbClr val="FFC000"/>
+          </a:solidFill>
+        </p:spPr>
+        <p:txBody>
+          <a:bodyPr wrap="none" rtlCol="0">
+            <a:spAutoFit/>
+          </a:bodyPr>
+          <a:lstStyle/>
+          <a:p>
+            <a:r>
+              <a:rPr lang="de-DE" sz="2000" b="1" dirty="0"/>
+              <a:t>Spezifikation</a:t>
+            </a:r>
+          </a:p>
+        </p:txBody>
+      </p:sp>
+    </p:spTree>
+    <p:extLst>
+      <p:ext uri="{BB962C8B-B14F-4D97-AF65-F5344CB8AC3E}">
+        <p14:creationId xmlns:p14="http://schemas.microsoft.com/office/powerpoint/2010/main" val="4083945008"/>
+      </p:ext>
+    </p:extLst>
+  </p:cSld>
+  <p:clrMapOvr>
+    <a:masterClrMapping/>
+  </p:clrMapOvr>
+  <p:timing>
+    <p:tnLst>
+      <p:par>
+        <p:cTn id="1" dur="indefinite" restart="never" nodeType="tmRoot">
+          <p:childTnLst>
+            <p:seq concurrent="1" nextAc="seek">
+              <p:cTn id="2" dur="indefinite" nodeType="mainSeq">
+                <p:childTnLst>
+                  <p:par>
+                    <p:cTn id="3" fill="hold">
+                      <p:stCondLst>
+                        <p:cond delay="indefinite"/>
+                      </p:stCondLst>
+                      <p:childTnLst>
+                        <p:par>
+                          <p:cTn id="4" fill="hold">
+                            <p:stCondLst>
+                              <p:cond delay="0"/>
+                            </p:stCondLst>
+                            <p:childTnLst>
+                              <p:par>
+                                <p:cTn id="5" presetID="22" presetClass="entr" presetSubtype="8" fill="hold" nodeType="clickEffect">
+                                  <p:stCondLst>
+                                    <p:cond delay="0"/>
+                                  </p:stCondLst>
+                                  <p:childTnLst>
+                                    <p:set>
+                                      <p:cBhvr>
+                                        <p:cTn id="6" dur="1" fill="hold">
+                                          <p:stCondLst>
+                                            <p:cond delay="0"/>
+                                          </p:stCondLst>
+                                        </p:cTn>
+                                        <p:tgtEl>
+                                          <p:spTgt spid="3"/>
+                                        </p:tgtEl>
+                                        <p:attrNameLst>
+                                          <p:attrName>style.visibility</p:attrName>
+                                        </p:attrNameLst>
+                                      </p:cBhvr>
+                                      <p:to>
+                                        <p:strVal val="visible"/>
+                                      </p:to>
+                                    </p:set>
+                                    <p:animEffect transition="in" filter="wipe(left)">
+                                      <p:cBhvr>
+                                        <p:cTn id="7" dur="500"/>
+                                        <p:tgtEl>
+                                          <p:spTgt spid="3"/>
+                                        </p:tgtEl>
+                                      </p:cBhvr>
+                                    </p:animEffect>
+                                  </p:childTnLst>
+                                </p:cTn>
+                              </p:par>
+                            </p:childTnLst>
+                          </p:cTn>
+                        </p:par>
+                      </p:childTnLst>
+                    </p:cTn>
+                  </p:par>
+                  <p:par>
+                    <p:cTn id="8" fill="hold">
+                      <p:stCondLst>
+                        <p:cond delay="indefinite"/>
+                      </p:stCondLst>
+                      <p:childTnLst>
+                        <p:par>
+                          <p:cTn id="9" fill="hold">
+                            <p:stCondLst>
+                              <p:cond delay="0"/>
+                            </p:stCondLst>
+                            <p:childTnLst>
+                              <p:par>
+                                <p:cTn id="10" presetID="31" presetClass="entr" presetSubtype="0" fill="hold" grpId="0" nodeType="clickEffect">
+                                  <p:stCondLst>
+                                    <p:cond delay="0"/>
+                                  </p:stCondLst>
+                                  <p:childTnLst>
+                                    <p:set>
+                                      <p:cBhvr>
+                                        <p:cTn id="11" dur="1" fill="hold">
+                                          <p:stCondLst>
+                                            <p:cond delay="0"/>
+                                          </p:stCondLst>
+                                        </p:cTn>
+                                        <p:tgtEl>
+                                          <p:spTgt spid="5"/>
+                                        </p:tgtEl>
+                                        <p:attrNameLst>
+                                          <p:attrName>style.visibility</p:attrName>
+                                        </p:attrNameLst>
+                                      </p:cBhvr>
+                                      <p:to>
+                                        <p:strVal val="visible"/>
+                                      </p:to>
+                                    </p:set>
+                                    <p:anim calcmode="lin" valueType="num">
+                                      <p:cBhvr>
+                                        <p:cTn id="12" dur="1000" fill="hold"/>
+                                        <p:tgtEl>
+                                          <p:spTgt spid="5"/>
+                                        </p:tgtEl>
+                                        <p:attrNameLst>
+                                          <p:attrName>ppt_w</p:attrName>
+                                        </p:attrNameLst>
+                                      </p:cBhvr>
+                                      <p:tavLst>
+                                        <p:tav tm="0">
+                                          <p:val>
+                                            <p:fltVal val="0"/>
+                                          </p:val>
+                                        </p:tav>
+                                        <p:tav tm="100000">
+                                          <p:val>
+                                            <p:strVal val="#ppt_w"/>
+                                          </p:val>
+                                        </p:tav>
+                                      </p:tavLst>
+                                    </p:anim>
+                                    <p:anim calcmode="lin" valueType="num">
+                                      <p:cBhvr>
+                                        <p:cTn id="13" dur="1000" fill="hold"/>
+                                        <p:tgtEl>
+                                          <p:spTgt spid="5"/>
+                                        </p:tgtEl>
+                                        <p:attrNameLst>
+                                          <p:attrName>ppt_h</p:attrName>
+                                        </p:attrNameLst>
+                                      </p:cBhvr>
+                                      <p:tavLst>
+                                        <p:tav tm="0">
+                                          <p:val>
+                                            <p:fltVal val="0"/>
+                                          </p:val>
+                                        </p:tav>
+                                        <p:tav tm="100000">
+                                          <p:val>
+                                            <p:strVal val="#ppt_h"/>
+                                          </p:val>
+                                        </p:tav>
+                                      </p:tavLst>
+                                    </p:anim>
+                                    <p:anim calcmode="lin" valueType="num">
+                                      <p:cBhvr>
+                                        <p:cTn id="14" dur="1000" fill="hold"/>
+                                        <p:tgtEl>
+                                          <p:spTgt spid="5"/>
+                                        </p:tgtEl>
+                                        <p:attrNameLst>
+                                          <p:attrName>style.rotation</p:attrName>
+                                        </p:attrNameLst>
+                                      </p:cBhvr>
+                                      <p:tavLst>
+                                        <p:tav tm="0">
+                                          <p:val>
+                                            <p:fltVal val="90"/>
+                                          </p:val>
+                                        </p:tav>
+                                        <p:tav tm="100000">
+                                          <p:val>
+                                            <p:fltVal val="0"/>
+                                          </p:val>
+                                        </p:tav>
+                                      </p:tavLst>
+                                    </p:anim>
+                                    <p:animEffect transition="in" filter="fade">
+                                      <p:cBhvr>
+                                        <p:cTn id="15" dur="1000"/>
+                                        <p:tgtEl>
+                                          <p:spTgt spid="5"/>
+                                        </p:tgtEl>
+                                      </p:cBhvr>
+                                    </p:animEffect>
+                                  </p:childTnLst>
+                                </p:cTn>
+                              </p:par>
+                            </p:childTnLst>
+                          </p:cTn>
+                        </p:par>
+                      </p:childTnLst>
+                    </p:cTn>
+                  </p:par>
+                </p:childTnLst>
+              </p:cTn>
+              <p:prevCondLst>
+                <p:cond evt="onPrev" delay="0">
+                  <p:tgtEl>
+                    <p:sldTgt/>
+                  </p:tgtEl>
+                </p:cond>
+              </p:prevCondLst>
+              <p:nextCondLst>
+                <p:cond evt="onNext" delay="0">
+                  <p:tgtEl>
+                    <p:sldTgt/>
+                  </p:tgtEl>
+                </p:cond>
+              </p:nextCondLst>
+            </p:seq>
+          </p:childTnLst>
+        </p:cTn>
+      </p:par>
+    </p:tnLst>
+    <p:bldLst>
+      <p:bldP spid="5" grpId="0" animBg="1"/>
+    </p:bldLst>
+  </p:timing>
 </p:sld>
 </file>
 
@@ -14368,6 +16904,39 @@
 </file>
 
 <file path=customXml/item1.xml><?xml version="1.0" encoding="utf-8"?>
+<?mso-contentType ?>
+<FormTemplates xmlns="http://schemas.microsoft.com/sharepoint/v3/contenttype/forms">
+  <Display>DocumentLibraryForm</Display>
+  <Edit>DocumentLibraryForm</Edit>
+  <New>DocumentLibraryForm</New>
+</FormTemplates>
+</file>
+
+<file path=customXml/item2.xml><?xml version="1.0" encoding="utf-8"?>
+<?mso-contentType ?>
+<p:Policy xmlns:p="office.server.policy" id="" local="true">
+  <p:Name>Dokument</p:Name>
+  <p:Description/>
+  <p:Statement/>
+  <p:PolicyItems>
+    <p:PolicyItem featureId="Microsoft.Office.RecordsManagement.PolicyFeatures.PolicyLabel" staticId="0x010100EF5765CEE729E1418BE065284ADE3D31|2097993778" UniqueId="018cb3dd-2760-4978-a79e-fe94012d8686">
+      <p:Name>Bezeichnungen</p:Name>
+      <p:Description>Generiert Bezeichnungen, die in Microsoft Office-Dokumente eingefügt werden können, um sicherzustellen, dass Dokumenteigenschaften oder sonstige wichtige Informationen beim Drucken von Dokumenten enthalten sind. Bezeichnungen können auch für die Suche nach Dokumenten verwendet werden.</p:Description>
+      <p:CustomData>
+        <label>
+          <properties>
+            <lock>True</lock>
+          </properties>
+          <segment type="literal">v.</segment>
+          <segment type="metadata">_UIVersionString</segment>
+        </label>
+      </p:CustomData>
+    </p:PolicyItem>
+  </p:PolicyItems>
+</p:Policy>
+</file>
+
+<file path=customXml/item3.xml><?xml version="1.0" encoding="utf-8"?>
 <p:properties xmlns:p="http://schemas.microsoft.com/office/2006/metadata/properties" xmlns:xsi="http://www.w3.org/2001/XMLSchema-instance" xmlns:pc="http://schemas.microsoft.com/office/infopath/2007/PartnerControls">
   <documentManagement>
     <_dlc_DocId xmlns="3ba2c390-782e-48d2-92a4-4ceacf62dc83">SNID-180-47</_dlc_DocId>
@@ -14401,40 +16970,57 @@
 </p:properties>
 </file>
 
-<file path=customXml/item2.xml><?xml version="1.0" encoding="utf-8"?>
+<file path=customXml/item4.xml><?xml version="1.0" encoding="utf-8"?>
 <?mso-contentType ?>
-<p:Policy xmlns:p="office.server.policy" id="" local="true">
-  <p:Name>Dokument</p:Name>
-  <p:Description/>
-  <p:Statement/>
-  <p:PolicyItems>
-    <p:PolicyItem featureId="Microsoft.Office.RecordsManagement.PolicyFeatures.PolicyLabel" staticId="0x010100EF5765CEE729E1418BE065284ADE3D31|2097993778" UniqueId="018cb3dd-2760-4978-a79e-fe94012d8686">
-      <p:Name>Bezeichnungen</p:Name>
-      <p:Description>Generiert Bezeichnungen, die in Microsoft Office-Dokumente eingefügt werden können, um sicherzustellen, dass Dokumenteigenschaften oder sonstige wichtige Informationen beim Drucken von Dokumenten enthalten sind. Bezeichnungen können auch für die Suche nach Dokumenten verwendet werden.</p:Description>
-      <p:CustomData>
-        <label>
-          <properties>
-            <lock>True</lock>
-          </properties>
-          <segment type="literal">v.</segment>
-          <segment type="metadata">_UIVersionString</segment>
-        </label>
-      </p:CustomData>
-    </p:PolicyItem>
-  </p:PolicyItems>
-</p:Policy>
+<spe:Receivers xmlns:spe="http://schemas.microsoft.com/sharepoint/events">
+  <Receiver>
+    <Name>Document ID Generator</Name>
+    <Synchronization>Synchronous</Synchronization>
+    <Type>10001</Type>
+    <SequenceNumber>1000</SequenceNumber>
+    <Url/>
+    <Assembly>Microsoft.Office.DocumentManagement, Version=15.0.0.0, Culture=neutral, PublicKeyToken=71e9bce111e9429c</Assembly>
+    <Class>Microsoft.Office.DocumentManagement.Internal.DocIdHandler</Class>
+    <Data/>
+    <Filter/>
+  </Receiver>
+  <Receiver>
+    <Name>Document ID Generator</Name>
+    <Synchronization>Synchronous</Synchronization>
+    <Type>10002</Type>
+    <SequenceNumber>1001</SequenceNumber>
+    <Url/>
+    <Assembly>Microsoft.Office.DocumentManagement, Version=15.0.0.0, Culture=neutral, PublicKeyToken=71e9bce111e9429c</Assembly>
+    <Class>Microsoft.Office.DocumentManagement.Internal.DocIdHandler</Class>
+    <Data/>
+    <Filter/>
+  </Receiver>
+  <Receiver>
+    <Name>Document ID Generator</Name>
+    <Synchronization>Synchronous</Synchronization>
+    <Type>10004</Type>
+    <SequenceNumber>1002</SequenceNumber>
+    <Url/>
+    <Assembly>Microsoft.Office.DocumentManagement, Version=15.0.0.0, Culture=neutral, PublicKeyToken=71e9bce111e9429c</Assembly>
+    <Class>Microsoft.Office.DocumentManagement.Internal.DocIdHandler</Class>
+    <Data/>
+    <Filter/>
+  </Receiver>
+  <Receiver>
+    <Name>Document ID Generator</Name>
+    <Synchronization>Synchronous</Synchronization>
+    <Type>10006</Type>
+    <SequenceNumber>1003</SequenceNumber>
+    <Url/>
+    <Assembly>Microsoft.Office.DocumentManagement, Version=15.0.0.0, Culture=neutral, PublicKeyToken=71e9bce111e9429c</Assembly>
+    <Class>Microsoft.Office.DocumentManagement.Internal.DocIdHandler</Class>
+    <Data/>
+    <Filter/>
+  </Receiver>
+</spe:Receivers>
 </file>
 
-<file path=customXml/item3.xml><?xml version="1.0" encoding="utf-8"?>
-<?mso-contentType ?>
-<FormTemplates xmlns="http://schemas.microsoft.com/sharepoint/v3/contenttype/forms">
-  <Display>DocumentLibraryForm</Display>
-  <Edit>DocumentLibraryForm</Edit>
-  <New>DocumentLibraryForm</New>
-</FormTemplates>
-</file>
-
-<file path=customXml/item4.xml><?xml version="1.0" encoding="utf-8"?>
+<file path=customXml/item5.xml><?xml version="1.0" encoding="utf-8"?>
 <ct:contentTypeSchema xmlns:ct="http://schemas.microsoft.com/office/2006/metadata/contentType" xmlns:ma="http://schemas.microsoft.com/office/2006/metadata/properties/metaAttributes" ct:_="" ma:_="" ma:contentTypeName="Dokument" ma:contentTypeID="0x010100EF5765CEE729E1418BE065284ADE3D31" ma:contentTypeVersion="29" ma:contentTypeDescription="Ein neues Dokument erstellen." ma:contentTypeScope="" ma:versionID="3d50e400cca5a7bd800a74eb9a530f8f">
   <xsd:schema xmlns:xsd="http://www.w3.org/2001/XMLSchema" xmlns:xs="http://www.w3.org/2001/XMLSchema" xmlns:p="http://schemas.microsoft.com/office/2006/metadata/properties" xmlns:ns1="http://schemas.microsoft.com/sharepoint/v3" xmlns:ns2="b5c6ba39-e055-4528-8d96-942d43fd41f6" xmlns:ns3="3ba2c390-782e-48d2-92a4-4ceacf62dc83" xmlns:ns4="1561a55d-4589-43de-94bb-8dded3e84ec0" targetNamespace="http://schemas.microsoft.com/office/2006/metadata/properties" ma:root="true" ma:fieldsID="5a6f0763cb74c2d9ba07ecaec821d4b1" ns1:_="" ns2:_="" ns3:_="" ns4:_="">
     <xsd:import namespace="http://schemas.microsoft.com/sharepoint/v3"/>
@@ -14779,57 +17365,23 @@
 </ct:contentTypeSchema>
 </file>
 
-<file path=customXml/item5.xml><?xml version="1.0" encoding="utf-8"?>
-<?mso-contentType ?>
-<spe:Receivers xmlns:spe="http://schemas.microsoft.com/sharepoint/events">
-  <Receiver>
-    <Name>Document ID Generator</Name>
-    <Synchronization>Synchronous</Synchronization>
-    <Type>10001</Type>
-    <SequenceNumber>1000</SequenceNumber>
-    <Url/>
-    <Assembly>Microsoft.Office.DocumentManagement, Version=15.0.0.0, Culture=neutral, PublicKeyToken=71e9bce111e9429c</Assembly>
-    <Class>Microsoft.Office.DocumentManagement.Internal.DocIdHandler</Class>
-    <Data/>
-    <Filter/>
-  </Receiver>
-  <Receiver>
-    <Name>Document ID Generator</Name>
-    <Synchronization>Synchronous</Synchronization>
-    <Type>10002</Type>
-    <SequenceNumber>1001</SequenceNumber>
-    <Url/>
-    <Assembly>Microsoft.Office.DocumentManagement, Version=15.0.0.0, Culture=neutral, PublicKeyToken=71e9bce111e9429c</Assembly>
-    <Class>Microsoft.Office.DocumentManagement.Internal.DocIdHandler</Class>
-    <Data/>
-    <Filter/>
-  </Receiver>
-  <Receiver>
-    <Name>Document ID Generator</Name>
-    <Synchronization>Synchronous</Synchronization>
-    <Type>10004</Type>
-    <SequenceNumber>1002</SequenceNumber>
-    <Url/>
-    <Assembly>Microsoft.Office.DocumentManagement, Version=15.0.0.0, Culture=neutral, PublicKeyToken=71e9bce111e9429c</Assembly>
-    <Class>Microsoft.Office.DocumentManagement.Internal.DocIdHandler</Class>
-    <Data/>
-    <Filter/>
-  </Receiver>
-  <Receiver>
-    <Name>Document ID Generator</Name>
-    <Synchronization>Synchronous</Synchronization>
-    <Type>10006</Type>
-    <SequenceNumber>1003</SequenceNumber>
-    <Url/>
-    <Assembly>Microsoft.Office.DocumentManagement, Version=15.0.0.0, Culture=neutral, PublicKeyToken=71e9bce111e9429c</Assembly>
-    <Class>Microsoft.Office.DocumentManagement.Internal.DocIdHandler</Class>
-    <Data/>
-    <Filter/>
-  </Receiver>
-</spe:Receivers>
+<file path=customXml/itemProps1.xml><?xml version="1.0" encoding="utf-8"?>
+<ds:datastoreItem xmlns:ds="http://schemas.openxmlformats.org/officeDocument/2006/customXml" ds:itemID="{BF9375A8-3119-4DA8-B304-E0F5F369DCAD}">
+  <ds:schemaRefs>
+    <ds:schemaRef ds:uri="http://schemas.microsoft.com/sharepoint/v3/contenttype/forms"/>
+  </ds:schemaRefs>
+</ds:datastoreItem>
 </file>
 
-<file path=customXml/itemProps1.xml><?xml version="1.0" encoding="utf-8"?>
+<file path=customXml/itemProps2.xml><?xml version="1.0" encoding="utf-8"?>
+<ds:datastoreItem xmlns:ds="http://schemas.openxmlformats.org/officeDocument/2006/customXml" ds:itemID="{1D4355BD-3339-4747-A9BA-2F7E78B26BF6}">
+  <ds:schemaRefs>
+    <ds:schemaRef ds:uri="office.server.policy"/>
+  </ds:schemaRefs>
+</ds:datastoreItem>
+</file>
+
+<file path=customXml/itemProps3.xml><?xml version="1.0" encoding="utf-8"?>
 <ds:datastoreItem xmlns:ds="http://schemas.openxmlformats.org/officeDocument/2006/customXml" ds:itemID="{E5519D02-F5E4-4D45-BACB-7D3735C24017}">
   <ds:schemaRefs>
     <ds:schemaRef ds:uri="http://schemas.microsoft.com/office/infopath/2007/PartnerControls"/>
@@ -14848,23 +17400,15 @@
 </ds:datastoreItem>
 </file>
 
-<file path=customXml/itemProps2.xml><?xml version="1.0" encoding="utf-8"?>
-<ds:datastoreItem xmlns:ds="http://schemas.openxmlformats.org/officeDocument/2006/customXml" ds:itemID="{1D4355BD-3339-4747-A9BA-2F7E78B26BF6}">
+<file path=customXml/itemProps4.xml><?xml version="1.0" encoding="utf-8"?>
+<ds:datastoreItem xmlns:ds="http://schemas.openxmlformats.org/officeDocument/2006/customXml" ds:itemID="{38B952D7-EB30-489B-97CD-4DF8165C4AB9}">
   <ds:schemaRefs>
-    <ds:schemaRef ds:uri="office.server.policy"/>
+    <ds:schemaRef ds:uri="http://schemas.microsoft.com/sharepoint/events"/>
   </ds:schemaRefs>
 </ds:datastoreItem>
 </file>
 
-<file path=customXml/itemProps3.xml><?xml version="1.0" encoding="utf-8"?>
-<ds:datastoreItem xmlns:ds="http://schemas.openxmlformats.org/officeDocument/2006/customXml" ds:itemID="{BF9375A8-3119-4DA8-B304-E0F5F369DCAD}">
-  <ds:schemaRefs>
-    <ds:schemaRef ds:uri="http://schemas.microsoft.com/sharepoint/v3/contenttype/forms"/>
-  </ds:schemaRefs>
-</ds:datastoreItem>
-</file>
-
-<file path=customXml/itemProps4.xml><?xml version="1.0" encoding="utf-8"?>
+<file path=customXml/itemProps5.xml><?xml version="1.0" encoding="utf-8"?>
 <ds:datastoreItem xmlns:ds="http://schemas.openxmlformats.org/officeDocument/2006/customXml" ds:itemID="{BBCE9F00-598A-4817-82B0-FFE08B1F3937}">
   <ds:schemaRefs>
     <ds:schemaRef ds:uri="http://schemas.microsoft.com/office/2006/metadata/contentType"/>
@@ -14883,12 +17427,4 @@
     <ds:schemaRef ds:uri="http://schemas.microsoft.com/internal/obd"/>
   </ds:schemaRefs>
 </ds:datastoreItem>
-</file>
-
-<file path=customXml/itemProps5.xml><?xml version="1.0" encoding="utf-8"?>
-<ds:datastoreItem xmlns:ds="http://schemas.openxmlformats.org/officeDocument/2006/customXml" ds:itemID="{38B952D7-EB30-489B-97CD-4DF8165C4AB9}">
-  <ds:schemaRefs>
-    <ds:schemaRef ds:uri="http://schemas.microsoft.com/sharepoint/events"/>
-  </ds:schemaRefs>
-</ds:datastoreItem>
 </file>
</xml_diff>